<commit_message>
adapted lightning talk Christina
</commit_message>
<xml_diff>
--- a/Lightning Talk Christina.pptx
+++ b/Lightning Talk Christina.pptx
@@ -31,6 +31,13 @@
     <p:embeddedFont>
       <p:font typeface="Canva Student Font" panose="020B0604020202020204" charset="0"/>
       <p:regular r:id="rId12"/>
+    </p:embeddedFont>
+    <p:embeddedFont>
+      <p:font typeface="Segoe UI" panose="020B0502040204020203" pitchFamily="34" charset="0"/>
+      <p:regular r:id="rId13"/>
+      <p:bold r:id="rId14"/>
+      <p:italic r:id="rId15"/>
+      <p:boldItalic r:id="rId16"/>
     </p:embeddedFont>
   </p:embeddedFontLst>
   <p:defaultTextStyle>
@@ -147,6 +154,438 @@
 </p:presentation>
 </file>
 
+<file path=ppt/revisionInfo.xml><?xml version="1.0" encoding="utf-8"?>
+<p1510:revInfo xmlns:a="http://schemas.openxmlformats.org/drawingml/2006/main" xmlns:r="http://schemas.openxmlformats.org/officeDocument/2006/relationships" xmlns:p1510="http://schemas.microsoft.com/office/powerpoint/2015/10/main">
+  <p1510:revLst>
+    <p1510:client id="{758A810B-C379-4C8B-B534-293CCBD759B1}" v="39" dt="2026-06-09T08:47:20.271"/>
+  </p1510:revLst>
+</p1510:revInfo>
+</file>
+
+<file path=ppt/changesInfos/changesInfo1.xml><?xml version="1.0" encoding="utf-8"?>
+<pc:chgInfo xmlns:a="http://schemas.openxmlformats.org/drawingml/2006/main" xmlns:r="http://schemas.openxmlformats.org/officeDocument/2006/relationships" xmlns:ac="http://schemas.microsoft.com/office/drawing/2013/main/command" xmlns:pc="http://schemas.microsoft.com/office/powerpoint/2013/main/command">
+  <pc:docChgLst>
+    <pc:chgData name="Christina Knes" userId="7e9737a164333dbd" providerId="LiveId" clId="{72053980-4108-4AED-A5B7-3290F7F82C69}"/>
+    <pc:docChg chg="custSel modSld">
+      <pc:chgData name="Christina Knes" userId="7e9737a164333dbd" providerId="LiveId" clId="{72053980-4108-4AED-A5B7-3290F7F82C69}" dt="2026-06-09T08:48:05.793" v="139"/>
+      <pc:docMkLst>
+        <pc:docMk/>
+      </pc:docMkLst>
+      <pc:sldChg chg="modSp mod modAnim">
+        <pc:chgData name="Christina Knes" userId="7e9737a164333dbd" providerId="LiveId" clId="{72053980-4108-4AED-A5B7-3290F7F82C69}" dt="2026-06-09T08:43:44.663" v="120"/>
+        <pc:sldMkLst>
+          <pc:docMk/>
+          <pc:sldMk cId="0" sldId="256"/>
+        </pc:sldMkLst>
+        <pc:spChg chg="mod">
+          <ac:chgData name="Christina Knes" userId="7e9737a164333dbd" providerId="LiveId" clId="{72053980-4108-4AED-A5B7-3290F7F82C69}" dt="2026-06-09T08:30:01.882" v="2" actId="1076"/>
+          <ac:spMkLst>
+            <pc:docMk/>
+            <pc:sldMk cId="0" sldId="256"/>
+            <ac:spMk id="2" creationId="{00000000-0000-0000-0000-000000000000}"/>
+          </ac:spMkLst>
+        </pc:spChg>
+        <pc:spChg chg="mod">
+          <ac:chgData name="Christina Knes" userId="7e9737a164333dbd" providerId="LiveId" clId="{72053980-4108-4AED-A5B7-3290F7F82C69}" dt="2026-06-09T08:30:21.465" v="8" actId="1076"/>
+          <ac:spMkLst>
+            <pc:docMk/>
+            <pc:sldMk cId="0" sldId="256"/>
+            <ac:spMk id="3" creationId="{00000000-0000-0000-0000-000000000000}"/>
+          </ac:spMkLst>
+        </pc:spChg>
+        <pc:spChg chg="mod">
+          <ac:chgData name="Christina Knes" userId="7e9737a164333dbd" providerId="LiveId" clId="{72053980-4108-4AED-A5B7-3290F7F82C69}" dt="2026-06-09T08:30:07.044" v="4" actId="1076"/>
+          <ac:spMkLst>
+            <pc:docMk/>
+            <pc:sldMk cId="0" sldId="256"/>
+            <ac:spMk id="4" creationId="{00000000-0000-0000-0000-000000000000}"/>
+          </ac:spMkLst>
+        </pc:spChg>
+        <pc:spChg chg="mod">
+          <ac:chgData name="Christina Knes" userId="7e9737a164333dbd" providerId="LiveId" clId="{72053980-4108-4AED-A5B7-3290F7F82C69}" dt="2026-06-09T08:30:11.840" v="5" actId="1076"/>
+          <ac:spMkLst>
+            <pc:docMk/>
+            <pc:sldMk cId="0" sldId="256"/>
+            <ac:spMk id="5" creationId="{00000000-0000-0000-0000-000000000000}"/>
+          </ac:spMkLst>
+        </pc:spChg>
+        <pc:spChg chg="mod">
+          <ac:chgData name="Christina Knes" userId="7e9737a164333dbd" providerId="LiveId" clId="{72053980-4108-4AED-A5B7-3290F7F82C69}" dt="2026-06-09T08:29:19.573" v="0" actId="1076"/>
+          <ac:spMkLst>
+            <pc:docMk/>
+            <pc:sldMk cId="0" sldId="256"/>
+            <ac:spMk id="6" creationId="{00000000-0000-0000-0000-000000000000}"/>
+          </ac:spMkLst>
+        </pc:spChg>
+        <pc:spChg chg="mod">
+          <ac:chgData name="Christina Knes" userId="7e9737a164333dbd" providerId="LiveId" clId="{72053980-4108-4AED-A5B7-3290F7F82C69}" dt="2026-06-09T08:30:14.386" v="6" actId="1076"/>
+          <ac:spMkLst>
+            <pc:docMk/>
+            <pc:sldMk cId="0" sldId="256"/>
+            <ac:spMk id="7" creationId="{00000000-0000-0000-0000-000000000000}"/>
+          </ac:spMkLst>
+        </pc:spChg>
+        <pc:spChg chg="mod">
+          <ac:chgData name="Christina Knes" userId="7e9737a164333dbd" providerId="LiveId" clId="{72053980-4108-4AED-A5B7-3290F7F82C69}" dt="2026-06-09T08:30:17.718" v="7" actId="1076"/>
+          <ac:spMkLst>
+            <pc:docMk/>
+            <pc:sldMk cId="0" sldId="256"/>
+            <ac:spMk id="8" creationId="{00000000-0000-0000-0000-000000000000}"/>
+          </ac:spMkLst>
+        </pc:spChg>
+        <pc:spChg chg="mod">
+          <ac:chgData name="Christina Knes" userId="7e9737a164333dbd" providerId="LiveId" clId="{72053980-4108-4AED-A5B7-3290F7F82C69}" dt="2026-06-09T08:29:21.563" v="1" actId="1076"/>
+          <ac:spMkLst>
+            <pc:docMk/>
+            <pc:sldMk cId="0" sldId="256"/>
+            <ac:spMk id="9" creationId="{00000000-0000-0000-0000-000000000000}"/>
+          </ac:spMkLst>
+        </pc:spChg>
+        <pc:spChg chg="mod">
+          <ac:chgData name="Christina Knes" userId="7e9737a164333dbd" providerId="LiveId" clId="{72053980-4108-4AED-A5B7-3290F7F82C69}" dt="2026-06-09T08:30:25.382" v="10" actId="1076"/>
+          <ac:spMkLst>
+            <pc:docMk/>
+            <pc:sldMk cId="0" sldId="256"/>
+            <ac:spMk id="10" creationId="{00000000-0000-0000-0000-000000000000}"/>
+          </ac:spMkLst>
+        </pc:spChg>
+        <pc:spChg chg="mod">
+          <ac:chgData name="Christina Knes" userId="7e9737a164333dbd" providerId="LiveId" clId="{72053980-4108-4AED-A5B7-3290F7F82C69}" dt="2026-06-09T08:30:23.124" v="9" actId="1076"/>
+          <ac:spMkLst>
+            <pc:docMk/>
+            <pc:sldMk cId="0" sldId="256"/>
+            <ac:spMk id="14" creationId="{00000000-0000-0000-0000-000000000000}"/>
+          </ac:spMkLst>
+        </pc:spChg>
+        <pc:spChg chg="mod">
+          <ac:chgData name="Christina Knes" userId="7e9737a164333dbd" providerId="LiveId" clId="{72053980-4108-4AED-A5B7-3290F7F82C69}" dt="2026-06-09T08:30:04.732" v="3" actId="1076"/>
+          <ac:spMkLst>
+            <pc:docMk/>
+            <pc:sldMk cId="0" sldId="256"/>
+            <ac:spMk id="15" creationId="{00000000-0000-0000-0000-000000000000}"/>
+          </ac:spMkLst>
+        </pc:spChg>
+      </pc:sldChg>
+      <pc:sldChg chg="modSp mod addAnim delAnim modAnim">
+        <pc:chgData name="Christina Knes" userId="7e9737a164333dbd" providerId="LiveId" clId="{72053980-4108-4AED-A5B7-3290F7F82C69}" dt="2026-06-09T08:48:05.793" v="139"/>
+        <pc:sldMkLst>
+          <pc:docMk/>
+          <pc:sldMk cId="0" sldId="257"/>
+        </pc:sldMkLst>
+        <pc:spChg chg="mod">
+          <ac:chgData name="Christina Knes" userId="7e9737a164333dbd" providerId="LiveId" clId="{72053980-4108-4AED-A5B7-3290F7F82C69}" dt="2026-06-09T08:43:33.008" v="118" actId="1036"/>
+          <ac:spMkLst>
+            <pc:docMk/>
+            <pc:sldMk cId="0" sldId="257"/>
+            <ac:spMk id="2" creationId="{00000000-0000-0000-0000-000000000000}"/>
+          </ac:spMkLst>
+        </pc:spChg>
+        <pc:spChg chg="mod">
+          <ac:chgData name="Christina Knes" userId="7e9737a164333dbd" providerId="LiveId" clId="{72053980-4108-4AED-A5B7-3290F7F82C69}" dt="2026-06-09T08:31:09.424" v="15" actId="1076"/>
+          <ac:spMkLst>
+            <pc:docMk/>
+            <pc:sldMk cId="0" sldId="257"/>
+            <ac:spMk id="3" creationId="{00000000-0000-0000-0000-000000000000}"/>
+          </ac:spMkLst>
+        </pc:spChg>
+        <pc:spChg chg="mod">
+          <ac:chgData name="Christina Knes" userId="7e9737a164333dbd" providerId="LiveId" clId="{72053980-4108-4AED-A5B7-3290F7F82C69}" dt="2026-06-09T08:31:06.243" v="14" actId="1076"/>
+          <ac:spMkLst>
+            <pc:docMk/>
+            <pc:sldMk cId="0" sldId="257"/>
+            <ac:spMk id="5" creationId="{00000000-0000-0000-0000-000000000000}"/>
+          </ac:spMkLst>
+        </pc:spChg>
+        <pc:spChg chg="mod">
+          <ac:chgData name="Christina Knes" userId="7e9737a164333dbd" providerId="LiveId" clId="{72053980-4108-4AED-A5B7-3290F7F82C69}" dt="2026-06-09T08:31:19.069" v="16" actId="1076"/>
+          <ac:spMkLst>
+            <pc:docMk/>
+            <pc:sldMk cId="0" sldId="257"/>
+            <ac:spMk id="6" creationId="{00000000-0000-0000-0000-000000000000}"/>
+          </ac:spMkLst>
+        </pc:spChg>
+      </pc:sldChg>
+      <pc:sldChg chg="delSp modSp mod addAnim delAnim modAnim">
+        <pc:chgData name="Christina Knes" userId="7e9737a164333dbd" providerId="LiveId" clId="{72053980-4108-4AED-A5B7-3290F7F82C69}" dt="2026-06-09T08:44:33.548" v="126"/>
+        <pc:sldMkLst>
+          <pc:docMk/>
+          <pc:sldMk cId="0" sldId="258"/>
+        </pc:sldMkLst>
+        <pc:spChg chg="mod">
+          <ac:chgData name="Christina Knes" userId="7e9737a164333dbd" providerId="LiveId" clId="{72053980-4108-4AED-A5B7-3290F7F82C69}" dt="2026-06-09T08:43:14.642" v="113" actId="1076"/>
+          <ac:spMkLst>
+            <pc:docMk/>
+            <pc:sldMk cId="0" sldId="258"/>
+            <ac:spMk id="2" creationId="{00000000-0000-0000-0000-000000000000}"/>
+          </ac:spMkLst>
+        </pc:spChg>
+        <pc:spChg chg="mod">
+          <ac:chgData name="Christina Knes" userId="7e9737a164333dbd" providerId="LiveId" clId="{72053980-4108-4AED-A5B7-3290F7F82C69}" dt="2026-06-09T08:43:14.642" v="113" actId="1076"/>
+          <ac:spMkLst>
+            <pc:docMk/>
+            <pc:sldMk cId="0" sldId="258"/>
+            <ac:spMk id="6" creationId="{00000000-0000-0000-0000-000000000000}"/>
+          </ac:spMkLst>
+        </pc:spChg>
+        <pc:spChg chg="mod">
+          <ac:chgData name="Christina Knes" userId="7e9737a164333dbd" providerId="LiveId" clId="{72053980-4108-4AED-A5B7-3290F7F82C69}" dt="2026-06-09T08:43:14.642" v="113" actId="1076"/>
+          <ac:spMkLst>
+            <pc:docMk/>
+            <pc:sldMk cId="0" sldId="258"/>
+            <ac:spMk id="7" creationId="{00000000-0000-0000-0000-000000000000}"/>
+          </ac:spMkLst>
+        </pc:spChg>
+        <pc:spChg chg="mod">
+          <ac:chgData name="Christina Knes" userId="7e9737a164333dbd" providerId="LiveId" clId="{72053980-4108-4AED-A5B7-3290F7F82C69}" dt="2026-06-09T08:43:14.642" v="113" actId="1076"/>
+          <ac:spMkLst>
+            <pc:docMk/>
+            <pc:sldMk cId="0" sldId="258"/>
+            <ac:spMk id="8" creationId="{00000000-0000-0000-0000-000000000000}"/>
+          </ac:spMkLst>
+        </pc:spChg>
+        <pc:spChg chg="mod">
+          <ac:chgData name="Christina Knes" userId="7e9737a164333dbd" providerId="LiveId" clId="{72053980-4108-4AED-A5B7-3290F7F82C69}" dt="2026-06-09T08:43:14.642" v="113" actId="1076"/>
+          <ac:spMkLst>
+            <pc:docMk/>
+            <pc:sldMk cId="0" sldId="258"/>
+            <ac:spMk id="9" creationId="{00000000-0000-0000-0000-000000000000}"/>
+          </ac:spMkLst>
+        </pc:spChg>
+        <pc:spChg chg="mod">
+          <ac:chgData name="Christina Knes" userId="7e9737a164333dbd" providerId="LiveId" clId="{72053980-4108-4AED-A5B7-3290F7F82C69}" dt="2026-06-09T08:43:06.653" v="112" actId="1076"/>
+          <ac:spMkLst>
+            <pc:docMk/>
+            <pc:sldMk cId="0" sldId="258"/>
+            <ac:spMk id="10" creationId="{00000000-0000-0000-0000-000000000000}"/>
+          </ac:spMkLst>
+        </pc:spChg>
+        <pc:spChg chg="del mod">
+          <ac:chgData name="Christina Knes" userId="7e9737a164333dbd" providerId="LiveId" clId="{72053980-4108-4AED-A5B7-3290F7F82C69}" dt="2026-06-09T08:42:50.669" v="108" actId="478"/>
+          <ac:spMkLst>
+            <pc:docMk/>
+            <pc:sldMk cId="0" sldId="258"/>
+            <ac:spMk id="12" creationId="{00000000-0000-0000-0000-000000000000}"/>
+          </ac:spMkLst>
+        </pc:spChg>
+        <pc:spChg chg="del mod">
+          <ac:chgData name="Christina Knes" userId="7e9737a164333dbd" providerId="LiveId" clId="{72053980-4108-4AED-A5B7-3290F7F82C69}" dt="2026-06-09T08:42:53.749" v="109" actId="478"/>
+          <ac:spMkLst>
+            <pc:docMk/>
+            <pc:sldMk cId="0" sldId="258"/>
+            <ac:spMk id="13" creationId="{00000000-0000-0000-0000-000000000000}"/>
+          </ac:spMkLst>
+        </pc:spChg>
+        <pc:spChg chg="del mod">
+          <ac:chgData name="Christina Knes" userId="7e9737a164333dbd" providerId="LiveId" clId="{72053980-4108-4AED-A5B7-3290F7F82C69}" dt="2026-06-09T08:42:56.380" v="110" actId="478"/>
+          <ac:spMkLst>
+            <pc:docMk/>
+            <pc:sldMk cId="0" sldId="258"/>
+            <ac:spMk id="14" creationId="{00000000-0000-0000-0000-000000000000}"/>
+          </ac:spMkLst>
+        </pc:spChg>
+        <pc:spChg chg="del mod">
+          <ac:chgData name="Christina Knes" userId="7e9737a164333dbd" providerId="LiveId" clId="{72053980-4108-4AED-A5B7-3290F7F82C69}" dt="2026-06-09T08:42:58.516" v="111" actId="478"/>
+          <ac:spMkLst>
+            <pc:docMk/>
+            <pc:sldMk cId="0" sldId="258"/>
+            <ac:spMk id="15" creationId="{00000000-0000-0000-0000-000000000000}"/>
+          </ac:spMkLst>
+        </pc:spChg>
+        <pc:spChg chg="mod">
+          <ac:chgData name="Christina Knes" userId="7e9737a164333dbd" providerId="LiveId" clId="{72053980-4108-4AED-A5B7-3290F7F82C69}" dt="2026-06-09T08:43:06.653" v="112" actId="1076"/>
+          <ac:spMkLst>
+            <pc:docMk/>
+            <pc:sldMk cId="0" sldId="258"/>
+            <ac:spMk id="16" creationId="{00000000-0000-0000-0000-000000000000}"/>
+          </ac:spMkLst>
+        </pc:spChg>
+        <pc:spChg chg="mod">
+          <ac:chgData name="Christina Knes" userId="7e9737a164333dbd" providerId="LiveId" clId="{72053980-4108-4AED-A5B7-3290F7F82C69}" dt="2026-06-09T08:43:06.653" v="112" actId="1076"/>
+          <ac:spMkLst>
+            <pc:docMk/>
+            <pc:sldMk cId="0" sldId="258"/>
+            <ac:spMk id="17" creationId="{00000000-0000-0000-0000-000000000000}"/>
+          </ac:spMkLst>
+        </pc:spChg>
+        <pc:spChg chg="mod">
+          <ac:chgData name="Christina Knes" userId="7e9737a164333dbd" providerId="LiveId" clId="{72053980-4108-4AED-A5B7-3290F7F82C69}" dt="2026-06-09T08:43:06.653" v="112" actId="1076"/>
+          <ac:spMkLst>
+            <pc:docMk/>
+            <pc:sldMk cId="0" sldId="258"/>
+            <ac:spMk id="18" creationId="{00000000-0000-0000-0000-000000000000}"/>
+          </ac:spMkLst>
+        </pc:spChg>
+        <pc:grpChg chg="mod">
+          <ac:chgData name="Christina Knes" userId="7e9737a164333dbd" providerId="LiveId" clId="{72053980-4108-4AED-A5B7-3290F7F82C69}" dt="2026-06-09T08:43:14.642" v="113" actId="1076"/>
+          <ac:grpSpMkLst>
+            <pc:docMk/>
+            <pc:sldMk cId="0" sldId="258"/>
+            <ac:grpSpMk id="3" creationId="{00000000-0000-0000-0000-000000000000}"/>
+          </ac:grpSpMkLst>
+        </pc:grpChg>
+      </pc:sldChg>
+      <pc:sldChg chg="modSp mod modAnim">
+        <pc:chgData name="Christina Knes" userId="7e9737a164333dbd" providerId="LiveId" clId="{72053980-4108-4AED-A5B7-3290F7F82C69}" dt="2026-06-09T08:45:41.531" v="128"/>
+        <pc:sldMkLst>
+          <pc:docMk/>
+          <pc:sldMk cId="0" sldId="260"/>
+        </pc:sldMkLst>
+        <pc:spChg chg="mod">
+          <ac:chgData name="Christina Knes" userId="7e9737a164333dbd" providerId="LiveId" clId="{72053980-4108-4AED-A5B7-3290F7F82C69}" dt="2026-06-09T08:37:47.403" v="31" actId="1036"/>
+          <ac:spMkLst>
+            <pc:docMk/>
+            <pc:sldMk cId="0" sldId="260"/>
+            <ac:spMk id="26" creationId="{00000000-0000-0000-0000-000000000000}"/>
+          </ac:spMkLst>
+        </pc:spChg>
+        <pc:spChg chg="mod">
+          <ac:chgData name="Christina Knes" userId="7e9737a164333dbd" providerId="LiveId" clId="{72053980-4108-4AED-A5B7-3290F7F82C69}" dt="2026-06-09T08:37:53.649" v="39" actId="1036"/>
+          <ac:spMkLst>
+            <pc:docMk/>
+            <pc:sldMk cId="0" sldId="260"/>
+            <ac:spMk id="27" creationId="{00000000-0000-0000-0000-000000000000}"/>
+          </ac:spMkLst>
+        </pc:spChg>
+        <pc:spChg chg="mod">
+          <ac:chgData name="Christina Knes" userId="7e9737a164333dbd" providerId="LiveId" clId="{72053980-4108-4AED-A5B7-3290F7F82C69}" dt="2026-06-09T08:37:59.110" v="47" actId="1035"/>
+          <ac:spMkLst>
+            <pc:docMk/>
+            <pc:sldMk cId="0" sldId="260"/>
+            <ac:spMk id="28" creationId="{00000000-0000-0000-0000-000000000000}"/>
+          </ac:spMkLst>
+        </pc:spChg>
+        <pc:spChg chg="mod">
+          <ac:chgData name="Christina Knes" userId="7e9737a164333dbd" providerId="LiveId" clId="{72053980-4108-4AED-A5B7-3290F7F82C69}" dt="2026-06-09T08:36:27.710" v="28" actId="1076"/>
+          <ac:spMkLst>
+            <pc:docMk/>
+            <pc:sldMk cId="0" sldId="260"/>
+            <ac:spMk id="29" creationId="{00000000-0000-0000-0000-000000000000}"/>
+          </ac:spMkLst>
+        </pc:spChg>
+        <pc:spChg chg="mod">
+          <ac:chgData name="Christina Knes" userId="7e9737a164333dbd" providerId="LiveId" clId="{72053980-4108-4AED-A5B7-3290F7F82C69}" dt="2026-06-09T08:37:50.518" v="34" actId="1036"/>
+          <ac:spMkLst>
+            <pc:docMk/>
+            <pc:sldMk cId="0" sldId="260"/>
+            <ac:spMk id="30" creationId="{00000000-0000-0000-0000-000000000000}"/>
+          </ac:spMkLst>
+        </pc:spChg>
+      </pc:sldChg>
+      <pc:sldChg chg="modSp mod modAnim">
+        <pc:chgData name="Christina Knes" userId="7e9737a164333dbd" providerId="LiveId" clId="{72053980-4108-4AED-A5B7-3290F7F82C69}" dt="2026-06-09T08:45:49.745" v="129"/>
+        <pc:sldMkLst>
+          <pc:docMk/>
+          <pc:sldMk cId="0" sldId="261"/>
+        </pc:sldMkLst>
+        <pc:spChg chg="mod">
+          <ac:chgData name="Christina Knes" userId="7e9737a164333dbd" providerId="LiveId" clId="{72053980-4108-4AED-A5B7-3290F7F82C69}" dt="2026-06-09T08:41:04.858" v="95" actId="20577"/>
+          <ac:spMkLst>
+            <pc:docMk/>
+            <pc:sldMk cId="0" sldId="261"/>
+            <ac:spMk id="3" creationId="{00000000-0000-0000-0000-000000000000}"/>
+          </ac:spMkLst>
+        </pc:spChg>
+        <pc:spChg chg="mod">
+          <ac:chgData name="Christina Knes" userId="7e9737a164333dbd" providerId="LiveId" clId="{72053980-4108-4AED-A5B7-3290F7F82C69}" dt="2026-06-09T08:38:10.023" v="48" actId="1076"/>
+          <ac:spMkLst>
+            <pc:docMk/>
+            <pc:sldMk cId="0" sldId="261"/>
+            <ac:spMk id="4" creationId="{00000000-0000-0000-0000-000000000000}"/>
+          </ac:spMkLst>
+        </pc:spChg>
+      </pc:sldChg>
+      <pc:sldChg chg="addSp modSp mod">
+        <pc:chgData name="Christina Knes" userId="7e9737a164333dbd" providerId="LiveId" clId="{72053980-4108-4AED-A5B7-3290F7F82C69}" dt="2026-06-09T08:40:37.397" v="81" actId="1076"/>
+        <pc:sldMkLst>
+          <pc:docMk/>
+          <pc:sldMk cId="0" sldId="262"/>
+        </pc:sldMkLst>
+        <pc:spChg chg="mod">
+          <ac:chgData name="Christina Knes" userId="7e9737a164333dbd" providerId="LiveId" clId="{72053980-4108-4AED-A5B7-3290F7F82C69}" dt="2026-06-09T08:40:30.593" v="80" actId="1076"/>
+          <ac:spMkLst>
+            <pc:docMk/>
+            <pc:sldMk cId="0" sldId="262"/>
+            <ac:spMk id="2" creationId="{00000000-0000-0000-0000-000000000000}"/>
+          </ac:spMkLst>
+        </pc:spChg>
+        <pc:spChg chg="mod">
+          <ac:chgData name="Christina Knes" userId="7e9737a164333dbd" providerId="LiveId" clId="{72053980-4108-4AED-A5B7-3290F7F82C69}" dt="2026-06-09T08:40:19.787" v="76" actId="1076"/>
+          <ac:spMkLst>
+            <pc:docMk/>
+            <pc:sldMk cId="0" sldId="262"/>
+            <ac:spMk id="3" creationId="{00000000-0000-0000-0000-000000000000}"/>
+          </ac:spMkLst>
+        </pc:spChg>
+        <pc:spChg chg="mod">
+          <ac:chgData name="Christina Knes" userId="7e9737a164333dbd" providerId="LiveId" clId="{72053980-4108-4AED-A5B7-3290F7F82C69}" dt="2026-06-09T08:40:13.422" v="72" actId="1076"/>
+          <ac:spMkLst>
+            <pc:docMk/>
+            <pc:sldMk cId="0" sldId="262"/>
+            <ac:spMk id="4" creationId="{00000000-0000-0000-0000-000000000000}"/>
+          </ac:spMkLst>
+        </pc:spChg>
+        <pc:spChg chg="mod">
+          <ac:chgData name="Christina Knes" userId="7e9737a164333dbd" providerId="LiveId" clId="{72053980-4108-4AED-A5B7-3290F7F82C69}" dt="2026-06-09T08:40:16.851" v="74" actId="1076"/>
+          <ac:spMkLst>
+            <pc:docMk/>
+            <pc:sldMk cId="0" sldId="262"/>
+            <ac:spMk id="5" creationId="{00000000-0000-0000-0000-000000000000}"/>
+          </ac:spMkLst>
+        </pc:spChg>
+        <pc:spChg chg="mod">
+          <ac:chgData name="Christina Knes" userId="7e9737a164333dbd" providerId="LiveId" clId="{72053980-4108-4AED-A5B7-3290F7F82C69}" dt="2026-06-09T08:40:27.388" v="78" actId="1076"/>
+          <ac:spMkLst>
+            <pc:docMk/>
+            <pc:sldMk cId="0" sldId="262"/>
+            <ac:spMk id="6" creationId="{00000000-0000-0000-0000-000000000000}"/>
+          </ac:spMkLst>
+        </pc:spChg>
+        <pc:spChg chg="mod">
+          <ac:chgData name="Christina Knes" userId="7e9737a164333dbd" providerId="LiveId" clId="{72053980-4108-4AED-A5B7-3290F7F82C69}" dt="2026-06-09T08:40:18.456" v="75" actId="1076"/>
+          <ac:spMkLst>
+            <pc:docMk/>
+            <pc:sldMk cId="0" sldId="262"/>
+            <ac:spMk id="7" creationId="{00000000-0000-0000-0000-000000000000}"/>
+          </ac:spMkLst>
+        </pc:spChg>
+        <pc:spChg chg="mod">
+          <ac:chgData name="Christina Knes" userId="7e9737a164333dbd" providerId="LiveId" clId="{72053980-4108-4AED-A5B7-3290F7F82C69}" dt="2026-06-09T08:40:29.200" v="79" actId="1076"/>
+          <ac:spMkLst>
+            <pc:docMk/>
+            <pc:sldMk cId="0" sldId="262"/>
+            <ac:spMk id="9" creationId="{00000000-0000-0000-0000-000000000000}"/>
+          </ac:spMkLst>
+        </pc:spChg>
+        <pc:spChg chg="mod">
+          <ac:chgData name="Christina Knes" userId="7e9737a164333dbd" providerId="LiveId" clId="{72053980-4108-4AED-A5B7-3290F7F82C69}" dt="2026-06-09T08:40:25.875" v="77" actId="1076"/>
+          <ac:spMkLst>
+            <pc:docMk/>
+            <pc:sldMk cId="0" sldId="262"/>
+            <ac:spMk id="10" creationId="{00000000-0000-0000-0000-000000000000}"/>
+          </ac:spMkLst>
+        </pc:spChg>
+        <pc:spChg chg="mod">
+          <ac:chgData name="Christina Knes" userId="7e9737a164333dbd" providerId="LiveId" clId="{72053980-4108-4AED-A5B7-3290F7F82C69}" dt="2026-06-09T08:40:14.843" v="73" actId="1076"/>
+          <ac:spMkLst>
+            <pc:docMk/>
+            <pc:sldMk cId="0" sldId="262"/>
+            <ac:spMk id="14" creationId="{00000000-0000-0000-0000-000000000000}"/>
+          </ac:spMkLst>
+        </pc:spChg>
+        <pc:spChg chg="add mod">
+          <ac:chgData name="Christina Knes" userId="7e9737a164333dbd" providerId="LiveId" clId="{72053980-4108-4AED-A5B7-3290F7F82C69}" dt="2026-06-09T08:40:37.397" v="81" actId="1076"/>
+          <ac:spMkLst>
+            <pc:docMk/>
+            <pc:sldMk cId="0" sldId="262"/>
+            <ac:spMk id="16" creationId="{991D8DE7-5AF2-F117-76F1-3EE3ECF51802}"/>
+          </ac:spMkLst>
+        </pc:spChg>
+      </pc:sldChg>
+    </pc:docChg>
+  </pc:docChgLst>
+</pc:chgInfo>
+</file>
+
 <file path=ppt/slideLayouts/slideLayout1.xml><?xml version="1.0" encoding="utf-8"?>
 <p:sldLayout xmlns:a="http://schemas.openxmlformats.org/drawingml/2006/main" xmlns:r="http://schemas.openxmlformats.org/officeDocument/2006/relationships" xmlns:p="http://schemas.openxmlformats.org/presentationml/2006/main" type="title" preserve="1">
   <p:cSld name="Title Slide">
@@ -327,7 +766,7 @@
             <a:fld id="{1D8BD707-D9CF-40AE-B4C6-C98DA3205C09}" type="datetimeFigureOut">
               <a:rPr lang="en-US" smtClean="0"/>
               <a:pPr/>
-              <a:t>5/18/2026</a:t>
+              <a:t>6/9/2026</a:t>
             </a:fld>
             <a:endParaRPr lang="en-US"/>
           </a:p>
@@ -492,7 +931,7 @@
             <a:fld id="{1D8BD707-D9CF-40AE-B4C6-C98DA3205C09}" type="datetimeFigureOut">
               <a:rPr lang="en-US" smtClean="0"/>
               <a:pPr/>
-              <a:t>5/18/2026</a:t>
+              <a:t>6/9/2026</a:t>
             </a:fld>
             <a:endParaRPr lang="en-US"/>
           </a:p>
@@ -667,7 +1106,7 @@
             <a:fld id="{1D8BD707-D9CF-40AE-B4C6-C98DA3205C09}" type="datetimeFigureOut">
               <a:rPr lang="en-US" smtClean="0"/>
               <a:pPr/>
-              <a:t>5/18/2026</a:t>
+              <a:t>6/9/2026</a:t>
             </a:fld>
             <a:endParaRPr lang="en-US"/>
           </a:p>
@@ -832,7 +1271,7 @@
             <a:fld id="{1D8BD707-D9CF-40AE-B4C6-C98DA3205C09}" type="datetimeFigureOut">
               <a:rPr lang="en-US" smtClean="0"/>
               <a:pPr/>
-              <a:t>5/18/2026</a:t>
+              <a:t>6/9/2026</a:t>
             </a:fld>
             <a:endParaRPr lang="en-US"/>
           </a:p>
@@ -1074,7 +1513,7 @@
             <a:fld id="{1D8BD707-D9CF-40AE-B4C6-C98DA3205C09}" type="datetimeFigureOut">
               <a:rPr lang="en-US" smtClean="0"/>
               <a:pPr/>
-              <a:t>5/18/2026</a:t>
+              <a:t>6/9/2026</a:t>
             </a:fld>
             <a:endParaRPr lang="en-US"/>
           </a:p>
@@ -1356,7 +1795,7 @@
             <a:fld id="{1D8BD707-D9CF-40AE-B4C6-C98DA3205C09}" type="datetimeFigureOut">
               <a:rPr lang="en-US" smtClean="0"/>
               <a:pPr/>
-              <a:t>5/18/2026</a:t>
+              <a:t>6/9/2026</a:t>
             </a:fld>
             <a:endParaRPr lang="en-US"/>
           </a:p>
@@ -1772,7 +2211,7 @@
             <a:fld id="{1D8BD707-D9CF-40AE-B4C6-C98DA3205C09}" type="datetimeFigureOut">
               <a:rPr lang="en-US" smtClean="0"/>
               <a:pPr/>
-              <a:t>5/18/2026</a:t>
+              <a:t>6/9/2026</a:t>
             </a:fld>
             <a:endParaRPr lang="en-US"/>
           </a:p>
@@ -1886,7 +2325,7 @@
             <a:fld id="{1D8BD707-D9CF-40AE-B4C6-C98DA3205C09}" type="datetimeFigureOut">
               <a:rPr lang="en-US" smtClean="0"/>
               <a:pPr/>
-              <a:t>5/18/2026</a:t>
+              <a:t>6/9/2026</a:t>
             </a:fld>
             <a:endParaRPr lang="en-US"/>
           </a:p>
@@ -1978,7 +2417,7 @@
             <a:fld id="{1D8BD707-D9CF-40AE-B4C6-C98DA3205C09}" type="datetimeFigureOut">
               <a:rPr lang="en-US" smtClean="0"/>
               <a:pPr/>
-              <a:t>5/18/2026</a:t>
+              <a:t>6/9/2026</a:t>
             </a:fld>
             <a:endParaRPr lang="en-US"/>
           </a:p>
@@ -2250,7 +2689,7 @@
             <a:fld id="{1D8BD707-D9CF-40AE-B4C6-C98DA3205C09}" type="datetimeFigureOut">
               <a:rPr lang="en-US" smtClean="0"/>
               <a:pPr/>
-              <a:t>5/18/2026</a:t>
+              <a:t>6/9/2026</a:t>
             </a:fld>
             <a:endParaRPr lang="en-US"/>
           </a:p>
@@ -2499,7 +2938,7 @@
             <a:fld id="{1D8BD707-D9CF-40AE-B4C6-C98DA3205C09}" type="datetimeFigureOut">
               <a:rPr lang="en-US" smtClean="0"/>
               <a:pPr/>
-              <a:t>5/18/2026</a:t>
+              <a:t>6/9/2026</a:t>
             </a:fld>
             <a:endParaRPr lang="en-US"/>
           </a:p>
@@ -2707,7 +3146,7 @@
             <a:fld id="{1D8BD707-D9CF-40AE-B4C6-C98DA3205C09}" type="datetimeFigureOut">
               <a:rPr lang="en-US" smtClean="0"/>
               <a:pPr/>
-              <a:t>5/18/2026</a:t>
+              <a:t>6/9/2026</a:t>
             </a:fld>
             <a:endParaRPr lang="en-US"/>
           </a:p>
@@ -3094,7 +3533,7 @@
         </p:nvSpPr>
         <p:spPr>
           <a:xfrm rot="-691699">
-            <a:off x="15763663" y="3157614"/>
+            <a:off x="16345508" y="2893683"/>
             <a:ext cx="4154462" cy="3863649"/>
           </a:xfrm>
           <a:custGeom>
@@ -3153,7 +3592,7 @@
         </p:nvSpPr>
         <p:spPr>
           <a:xfrm rot="-284944">
-            <a:off x="-1396635" y="3102424"/>
+            <a:off x="-1837951" y="3037093"/>
             <a:ext cx="4096277" cy="3630325"/>
           </a:xfrm>
           <a:custGeom>
@@ -3212,7 +3651,7 @@
         </p:nvSpPr>
         <p:spPr>
           <a:xfrm rot="1061051">
-            <a:off x="12724036" y="7681159"/>
+            <a:off x="12885689" y="8121676"/>
             <a:ext cx="3642065" cy="3848946"/>
           </a:xfrm>
           <a:custGeom>
@@ -3271,7 +3710,7 @@
         </p:nvSpPr>
         <p:spPr>
           <a:xfrm rot="-411245">
-            <a:off x="7229722" y="8180178"/>
+            <a:off x="7640446" y="8421029"/>
             <a:ext cx="4476094" cy="3731943"/>
           </a:xfrm>
           <a:custGeom>
@@ -3330,7 +3769,7 @@
         </p:nvSpPr>
         <p:spPr>
           <a:xfrm rot="-474403">
-            <a:off x="6963632" y="-2635620"/>
+            <a:off x="6948183" y="-2882444"/>
             <a:ext cx="4368067" cy="4329846"/>
           </a:xfrm>
           <a:custGeom>
@@ -3389,7 +3828,7 @@
         </p:nvSpPr>
         <p:spPr>
           <a:xfrm>
-            <a:off x="2029993" y="7417753"/>
+            <a:off x="2095416" y="7659441"/>
             <a:ext cx="4373018" cy="4214496"/>
           </a:xfrm>
           <a:custGeom>
@@ -3448,7 +3887,7 @@
         </p:nvSpPr>
         <p:spPr>
           <a:xfrm rot="356799">
-            <a:off x="-2200203" y="7515623"/>
+            <a:off x="-2319440" y="7621568"/>
             <a:ext cx="3888820" cy="3485355"/>
           </a:xfrm>
           <a:custGeom>
@@ -3507,7 +3946,7 @@
         </p:nvSpPr>
         <p:spPr>
           <a:xfrm rot="675348">
-            <a:off x="12487865" y="-1080492"/>
+            <a:off x="12448212" y="-1678300"/>
             <a:ext cx="3789402" cy="3685194"/>
           </a:xfrm>
           <a:custGeom>
@@ -3566,7 +4005,7 @@
         </p:nvSpPr>
         <p:spPr>
           <a:xfrm rot="710027">
-            <a:off x="2074980" y="-1213346"/>
+            <a:off x="1788193" y="-1759765"/>
             <a:ext cx="4057937" cy="3692723"/>
           </a:xfrm>
           <a:custGeom>
@@ -3769,7 +4208,7 @@
         </p:nvSpPr>
         <p:spPr>
           <a:xfrm>
-            <a:off x="-2075123" y="-1202141"/>
+            <a:off x="-2482149" y="-1417257"/>
             <a:ext cx="3294905" cy="3163108"/>
           </a:xfrm>
           <a:custGeom>
@@ -3828,7 +4267,7 @@
         </p:nvSpPr>
         <p:spPr>
           <a:xfrm rot="-503037">
-            <a:off x="17148200" y="7696708"/>
+            <a:off x="17176209" y="7989173"/>
             <a:ext cx="3294905" cy="2230322"/>
           </a:xfrm>
           <a:custGeom>
@@ -3884,128 +4323,6 @@
   <p:clrMapOvr>
     <a:masterClrMapping/>
   </p:clrMapOvr>
-  <p:timing>
-    <p:tnLst>
-      <p:par>
-        <p:cTn id="1" dur="indefinite" restart="never" nodeType="tmRoot">
-          <p:childTnLst>
-            <p:seq concurrent="1" nextAc="seek">
-              <p:cTn id="2" dur="indefinite" nodeType="mainSeq">
-                <p:childTnLst>
-                  <p:par>
-                    <p:cTn id="3" fill="hold">
-                      <p:stCondLst>
-                        <p:cond delay="indefinite"/>
-                      </p:stCondLst>
-                      <p:childTnLst>
-                        <p:par>
-                          <p:cTn id="4" fill="hold">
-                            <p:stCondLst>
-                              <p:cond delay="0"/>
-                            </p:stCondLst>
-                            <p:childTnLst>
-                              <p:par>
-                                <p:cTn id="5" presetID="10" presetClass="entr" presetSubtype="0" fill="hold" grpId="0" nodeType="clickEffect">
-                                  <p:stCondLst>
-                                    <p:cond delay="0"/>
-                                  </p:stCondLst>
-                                  <p:childTnLst>
-                                    <p:set>
-                                      <p:cBhvr>
-                                        <p:cTn id="6" dur="1" fill="hold">
-                                          <p:stCondLst>
-                                            <p:cond delay="0"/>
-                                          </p:stCondLst>
-                                        </p:cTn>
-                                        <p:tgtEl>
-                                          <p:spTgt spid="12"/>
-                                        </p:tgtEl>
-                                        <p:attrNameLst>
-                                          <p:attrName>style.visibility</p:attrName>
-                                        </p:attrNameLst>
-                                      </p:cBhvr>
-                                      <p:to>
-                                        <p:strVal val="visible"/>
-                                      </p:to>
-                                    </p:set>
-                                    <p:animEffect transition="in" filter="fade">
-                                      <p:cBhvr>
-                                        <p:cTn id="7" dur="500"/>
-                                        <p:tgtEl>
-                                          <p:spTgt spid="12"/>
-                                        </p:tgtEl>
-                                      </p:cBhvr>
-                                    </p:animEffect>
-                                  </p:childTnLst>
-                                </p:cTn>
-                              </p:par>
-                              <p:par>
-                                <p:cTn id="8" presetID="10" presetClass="entr" presetSubtype="0" fill="hold" grpId="0" nodeType="withEffect">
-                                  <p:stCondLst>
-                                    <p:cond delay="0"/>
-                                  </p:stCondLst>
-                                  <p:childTnLst>
-                                    <p:set>
-                                      <p:cBhvr>
-                                        <p:cTn id="9" dur="1" fill="hold">
-                                          <p:stCondLst>
-                                            <p:cond delay="0"/>
-                                          </p:stCondLst>
-                                        </p:cTn>
-                                        <p:tgtEl>
-                                          <p:spTgt spid="13"/>
-                                        </p:tgtEl>
-                                        <p:attrNameLst>
-                                          <p:attrName>style.visibility</p:attrName>
-                                        </p:attrNameLst>
-                                      </p:cBhvr>
-                                      <p:to>
-                                        <p:strVal val="visible"/>
-                                      </p:to>
-                                    </p:set>
-                                    <p:animEffect transition="in" filter="fade">
-                                      <p:cBhvr>
-                                        <p:cTn id="10" dur="500"/>
-                                        <p:tgtEl>
-                                          <p:spTgt spid="13"/>
-                                        </p:tgtEl>
-                                      </p:cBhvr>
-                                    </p:animEffect>
-                                  </p:childTnLst>
-                                </p:cTn>
-                              </p:par>
-                            </p:childTnLst>
-                          </p:cTn>
-                        </p:par>
-                      </p:childTnLst>
-                    </p:cTn>
-                  </p:par>
-                </p:childTnLst>
-              </p:cTn>
-              <p:prevCondLst>
-                <p:cond evt="onPrev" delay="0">
-                  <p:tgtEl>
-                    <p:sldTgt/>
-                  </p:tgtEl>
-                </p:cond>
-              </p:prevCondLst>
-              <p:nextCondLst>
-                <p:cond evt="onNext" delay="0">
-                  <p:tgtEl>
-                    <p:sldTgt/>
-                  </p:tgtEl>
-                </p:cond>
-              </p:nextCondLst>
-            </p:seq>
-          </p:childTnLst>
-        </p:cTn>
-      </p:par>
-    </p:tnLst>
-    <p:bldLst>
-      <p:bldP spid="12" grpId="0"/>
-      <p:bldP spid="13" grpId="0"/>
-    </p:bldLst>
-  </p:timing>
 </p:sld>
 </file>
 
@@ -4042,8 +4359,8 @@
         </p:nvSpPr>
         <p:spPr>
           <a:xfrm>
-            <a:off x="11125200" y="374650"/>
-            <a:ext cx="5598662" cy="5206755"/>
+            <a:off x="11456165" y="755651"/>
+            <a:ext cx="5267697" cy="4768849"/>
           </a:xfrm>
           <a:custGeom>
             <a:avLst/>
@@ -4101,7 +4418,7 @@
         </p:nvSpPr>
         <p:spPr>
           <a:xfrm>
-            <a:off x="533400" y="1787525"/>
+            <a:off x="381000" y="1751883"/>
             <a:ext cx="9626922" cy="3789045"/>
           </a:xfrm>
           <a:prstGeom prst="rect">
@@ -4327,7 +4644,7 @@
         </p:nvSpPr>
         <p:spPr>
           <a:xfrm>
-            <a:off x="9846402" y="5834825"/>
+            <a:off x="9829800" y="5682697"/>
             <a:ext cx="8156257" cy="4265295"/>
           </a:xfrm>
           <a:prstGeom prst="rect">
@@ -4560,7 +4877,7 @@
         </p:nvSpPr>
         <p:spPr>
           <a:xfrm>
-            <a:off x="3733800" y="6059432"/>
+            <a:off x="3429000" y="5920823"/>
             <a:ext cx="4209050" cy="4040688"/>
           </a:xfrm>
           <a:custGeom>
@@ -4864,7 +5181,7 @@
         </p:nvSpPr>
         <p:spPr>
           <a:xfrm>
-            <a:off x="1661480" y="3268517"/>
+            <a:off x="1827536" y="3519528"/>
             <a:ext cx="2533572" cy="2511403"/>
           </a:xfrm>
           <a:custGeom>
@@ -4923,7 +5240,7 @@
         </p:nvGrpSpPr>
         <p:grpSpPr>
           <a:xfrm rot="2700000">
-            <a:off x="2316610" y="4766348"/>
+            <a:off x="2482666" y="5017359"/>
             <a:ext cx="337633" cy="337597"/>
             <a:chOff x="0" y="0"/>
             <a:chExt cx="88924" cy="88914"/>
@@ -5013,7 +5330,7 @@
         </p:nvSpPr>
         <p:spPr>
           <a:xfrm rot="868315">
-            <a:off x="2330217" y="4737616"/>
+            <a:off x="2496273" y="4988627"/>
             <a:ext cx="310421" cy="342147"/>
           </a:xfrm>
           <a:custGeom>
@@ -5072,7 +5389,7 @@
         </p:nvSpPr>
         <p:spPr>
           <a:xfrm>
-            <a:off x="5705768" y="3478158"/>
+            <a:off x="5871824" y="3729169"/>
             <a:ext cx="2728794" cy="2728794"/>
           </a:xfrm>
           <a:custGeom>
@@ -5125,7 +5442,7 @@
         </p:nvSpPr>
         <p:spPr>
           <a:xfrm>
-            <a:off x="9949036" y="3615025"/>
+            <a:off x="10115092" y="3866036"/>
             <a:ext cx="2529409" cy="2301762"/>
           </a:xfrm>
           <a:custGeom>
@@ -5184,7 +5501,7 @@
         </p:nvSpPr>
         <p:spPr>
           <a:xfrm>
-            <a:off x="14083344" y="3696903"/>
+            <a:off x="14249400" y="3947914"/>
             <a:ext cx="2564325" cy="2138006"/>
           </a:xfrm>
           <a:custGeom>
@@ -5243,7 +5560,7 @@
         </p:nvSpPr>
         <p:spPr>
           <a:xfrm>
-            <a:off x="5156087" y="5888355"/>
+            <a:off x="5293102" y="6185120"/>
             <a:ext cx="3828155" cy="1057275"/>
           </a:xfrm>
           <a:prstGeom prst="rect">
@@ -5319,177 +5636,13 @@
       </p:sp>
       <p:sp>
         <p:nvSpPr>
-          <p:cNvPr id="12" name="TextBox 12"/>
-          <p:cNvSpPr txBox="1"/>
-          <p:nvPr/>
-        </p:nvSpPr>
-        <p:spPr>
-          <a:xfrm>
-            <a:off x="1229714" y="7111970"/>
-            <a:ext cx="3456099" cy="1423210"/>
-          </a:xfrm>
-          <a:prstGeom prst="rect">
-            <a:avLst/>
-          </a:prstGeom>
-        </p:spPr>
-        <p:txBody>
-          <a:bodyPr lIns="0" tIns="0" rIns="0" bIns="0" rtlCol="0" anchor="t">
-            <a:spAutoFit/>
-          </a:bodyPr>
-          <a:lstStyle/>
-          <a:p>
-            <a:pPr algn="ctr">
-              <a:lnSpc>
-                <a:spcPts val="3780"/>
-              </a:lnSpc>
-            </a:pPr>
-            <a:r>
-              <a:rPr lang="en-US" sz="2400">
-                <a:solidFill>
-                  <a:srgbClr val="000000"/>
-                </a:solidFill>
-                <a:latin typeface="Bricolage Grotesque"/>
-                <a:ea typeface="Bricolage Grotesque"/>
-                <a:cs typeface="Bricolage Grotesque"/>
-                <a:sym typeface="Bricolage Grotesque"/>
-              </a:rPr>
-              <a:t>No significant difference in overall essay quality.</a:t>
-            </a:r>
-          </a:p>
-        </p:txBody>
-      </p:sp>
-      <p:sp>
-        <p:nvSpPr>
-          <p:cNvPr id="13" name="TextBox 13"/>
-          <p:cNvSpPr txBox="1"/>
-          <p:nvPr/>
-        </p:nvSpPr>
-        <p:spPr>
-          <a:xfrm>
-            <a:off x="5371612" y="7111970"/>
-            <a:ext cx="3456099" cy="1423210"/>
-          </a:xfrm>
-          <a:prstGeom prst="rect">
-            <a:avLst/>
-          </a:prstGeom>
-        </p:spPr>
-        <p:txBody>
-          <a:bodyPr lIns="0" tIns="0" rIns="0" bIns="0" rtlCol="0" anchor="t">
-            <a:spAutoFit/>
-          </a:bodyPr>
-          <a:lstStyle/>
-          <a:p>
-            <a:pPr algn="ctr">
-              <a:lnSpc>
-                <a:spcPts val="3780"/>
-              </a:lnSpc>
-            </a:pPr>
-            <a:r>
-              <a:rPr lang="en-US" sz="2400">
-                <a:solidFill>
-                  <a:srgbClr val="000000"/>
-                </a:solidFill>
-                <a:latin typeface="Bricolage Grotesque"/>
-                <a:ea typeface="Bricolage Grotesque"/>
-                <a:cs typeface="Bricolage Grotesque"/>
-                <a:sym typeface="Bricolage Grotesque"/>
-              </a:rPr>
-              <a:t>No improvement in essay scores compared to the control group.</a:t>
-            </a:r>
-          </a:p>
-        </p:txBody>
-      </p:sp>
-      <p:sp>
-        <p:nvSpPr>
-          <p:cNvPr id="14" name="TextBox 14"/>
-          <p:cNvSpPr txBox="1"/>
-          <p:nvPr/>
-        </p:nvSpPr>
-        <p:spPr>
-          <a:xfrm>
-            <a:off x="9523036" y="7078142"/>
-            <a:ext cx="3456099" cy="1423210"/>
-          </a:xfrm>
-          <a:prstGeom prst="rect">
-            <a:avLst/>
-          </a:prstGeom>
-        </p:spPr>
-        <p:txBody>
-          <a:bodyPr lIns="0" tIns="0" rIns="0" bIns="0" rtlCol="0" anchor="t">
-            <a:spAutoFit/>
-          </a:bodyPr>
-          <a:lstStyle/>
-          <a:p>
-            <a:pPr algn="ctr">
-              <a:lnSpc>
-                <a:spcPts val="3780"/>
-              </a:lnSpc>
-            </a:pPr>
-            <a:r>
-              <a:rPr lang="en-US" sz="2400">
-                <a:solidFill>
-                  <a:srgbClr val="000000"/>
-                </a:solidFill>
-                <a:latin typeface="Bricolage Grotesque"/>
-                <a:ea typeface="Bricolage Grotesque"/>
-                <a:cs typeface="Bricolage Grotesque"/>
-                <a:sym typeface="Bricolage Grotesque"/>
-              </a:rPr>
-              <a:t>Writing duration did not differ significantly between the groups.</a:t>
-            </a:r>
-          </a:p>
-        </p:txBody>
-      </p:sp>
-      <p:sp>
-        <p:nvSpPr>
-          <p:cNvPr id="15" name="TextBox 15"/>
-          <p:cNvSpPr txBox="1"/>
-          <p:nvPr/>
-        </p:nvSpPr>
-        <p:spPr>
-          <a:xfrm>
-            <a:off x="13480926" y="7078142"/>
-            <a:ext cx="3828155" cy="2397836"/>
-          </a:xfrm>
-          <a:prstGeom prst="rect">
-            <a:avLst/>
-          </a:prstGeom>
-        </p:spPr>
-        <p:txBody>
-          <a:bodyPr lIns="0" tIns="0" rIns="0" bIns="0" rtlCol="0" anchor="t">
-            <a:spAutoFit/>
-          </a:bodyPr>
-          <a:lstStyle/>
-          <a:p>
-            <a:pPr algn="ctr">
-              <a:lnSpc>
-                <a:spcPts val="3780"/>
-              </a:lnSpc>
-            </a:pPr>
-            <a:r>
-              <a:rPr lang="en-US" sz="2400">
-                <a:solidFill>
-                  <a:srgbClr val="000000"/>
-                </a:solidFill>
-                <a:latin typeface="Bricolage Grotesque"/>
-                <a:ea typeface="Bricolage Grotesque"/>
-                <a:cs typeface="Bricolage Grotesque"/>
-                <a:sym typeface="Bricolage Grotesque"/>
-              </a:rPr>
-              <a:t>Text authenticity was marginally lower and AI detectors flagged more potential AI-generated content.</a:t>
-            </a:r>
-          </a:p>
-        </p:txBody>
-      </p:sp>
-      <p:sp>
-        <p:nvSpPr>
           <p:cNvPr id="16" name="TextBox 16"/>
           <p:cNvSpPr txBox="1"/>
           <p:nvPr/>
         </p:nvSpPr>
         <p:spPr>
           <a:xfrm>
-            <a:off x="1200217" y="6140277"/>
+            <a:off x="1357202" y="6451819"/>
             <a:ext cx="3456099" cy="523875"/>
           </a:xfrm>
           <a:prstGeom prst="rect">
@@ -5530,7 +5683,7 @@
         </p:nvSpPr>
         <p:spPr>
           <a:xfrm>
-            <a:off x="9493539" y="6102177"/>
+            <a:off x="9738215" y="6451818"/>
             <a:ext cx="3456099" cy="523875"/>
           </a:xfrm>
           <a:prstGeom prst="rect">
@@ -5549,7 +5702,7 @@
               </a:lnSpc>
             </a:pPr>
             <a:r>
-              <a:rPr lang="en-US" sz="3000" b="1">
+              <a:rPr lang="en-US" sz="3000" b="1" dirty="0">
                 <a:solidFill>
                   <a:srgbClr val="000000"/>
                 </a:solidFill>
@@ -5571,7 +5724,7 @@
         </p:nvSpPr>
         <p:spPr>
           <a:xfrm>
-            <a:off x="13265401" y="5835477"/>
+            <a:off x="13408628" y="6185120"/>
             <a:ext cx="4200211" cy="1057275"/>
           </a:xfrm>
           <a:prstGeom prst="rect">
@@ -5590,7 +5743,7 @@
               </a:lnSpc>
             </a:pPr>
             <a:r>
-              <a:rPr lang="en-US" sz="3000" b="1">
+              <a:rPr lang="en-US" sz="3000" b="1" dirty="0">
                 <a:solidFill>
                   <a:srgbClr val="000000"/>
                 </a:solidFill>
@@ -5621,9 +5774,6 @@
                     <p:cTn id="3" fill="hold">
                       <p:stCondLst>
                         <p:cond delay="indefinite"/>
-                        <p:cond evt="onBegin" delay="0">
-                          <p:tn val="2"/>
-                        </p:cond>
                       </p:stCondLst>
                       <p:childTnLst>
                         <p:par>
@@ -5633,7 +5783,7 @@
                             </p:stCondLst>
                             <p:childTnLst>
                               <p:par>
-                                <p:cTn id="5" presetID="10" presetClass="entr" presetSubtype="0" fill="hold" grpId="0" nodeType="withEffect">
+                                <p:cTn id="5" presetID="10" presetClass="entr" presetSubtype="0" fill="hold" grpId="0" nodeType="clickEffect">
                                   <p:stCondLst>
                                     <p:cond delay="0"/>
                                   </p:stCondLst>
@@ -5681,7 +5831,7 @@
                                           </p:stCondLst>
                                         </p:cTn>
                                         <p:tgtEl>
-                                          <p:spTgt spid="12"/>
+                                          <p:spTgt spid="2"/>
                                         </p:tgtEl>
                                         <p:attrNameLst>
                                           <p:attrName>style.visibility</p:attrName>
@@ -5695,41 +5845,6 @@
                                       <p:cBhvr>
                                         <p:cTn id="10" dur="500"/>
                                         <p:tgtEl>
-                                          <p:spTgt spid="12"/>
-                                        </p:tgtEl>
-                                      </p:cBhvr>
-                                    </p:animEffect>
-                                  </p:childTnLst>
-                                </p:cTn>
-                              </p:par>
-                              <p:par>
-                                <p:cTn id="11" presetID="10" presetClass="entr" presetSubtype="0" fill="hold" grpId="0" nodeType="withEffect">
-                                  <p:stCondLst>
-                                    <p:cond delay="0"/>
-                                  </p:stCondLst>
-                                  <p:childTnLst>
-                                    <p:set>
-                                      <p:cBhvr>
-                                        <p:cTn id="12" dur="1" fill="hold">
-                                          <p:stCondLst>
-                                            <p:cond delay="0"/>
-                                          </p:stCondLst>
-                                        </p:cTn>
-                                        <p:tgtEl>
-                                          <p:spTgt spid="2"/>
-                                        </p:tgtEl>
-                                        <p:attrNameLst>
-                                          <p:attrName>style.visibility</p:attrName>
-                                        </p:attrNameLst>
-                                      </p:cBhvr>
-                                      <p:to>
-                                        <p:strVal val="visible"/>
-                                      </p:to>
-                                    </p:set>
-                                    <p:animEffect transition="in" filter="fade">
-                                      <p:cBhvr>
-                                        <p:cTn id="13" dur="500"/>
-                                        <p:tgtEl>
                                           <p:spTgt spid="2"/>
                                         </p:tgtEl>
                                       </p:cBhvr>
@@ -5738,14 +5853,14 @@
                                 </p:cTn>
                               </p:par>
                               <p:par>
-                                <p:cTn id="14" presetID="10" presetClass="entr" presetSubtype="0" fill="hold" nodeType="withEffect">
+                                <p:cTn id="11" presetID="10" presetClass="entr" presetSubtype="0" fill="hold" nodeType="withEffect">
                                   <p:stCondLst>
                                     <p:cond delay="0"/>
                                   </p:stCondLst>
                                   <p:childTnLst>
                                     <p:set>
                                       <p:cBhvr>
-                                        <p:cTn id="15" dur="1" fill="hold">
+                                        <p:cTn id="12" dur="1" fill="hold">
                                           <p:stCondLst>
                                             <p:cond delay="0"/>
                                           </p:stCondLst>
@@ -5763,9 +5878,44 @@
                                     </p:set>
                                     <p:animEffect transition="in" filter="fade">
                                       <p:cBhvr>
+                                        <p:cTn id="13" dur="500"/>
+                                        <p:tgtEl>
+                                          <p:spTgt spid="3"/>
+                                        </p:tgtEl>
+                                      </p:cBhvr>
+                                    </p:animEffect>
+                                  </p:childTnLst>
+                                </p:cTn>
+                              </p:par>
+                              <p:par>
+                                <p:cTn id="14" presetID="10" presetClass="entr" presetSubtype="0" fill="hold" grpId="0" nodeType="withEffect">
+                                  <p:stCondLst>
+                                    <p:cond delay="0"/>
+                                  </p:stCondLst>
+                                  <p:childTnLst>
+                                    <p:set>
+                                      <p:cBhvr>
+                                        <p:cTn id="15" dur="1" fill="hold">
+                                          <p:stCondLst>
+                                            <p:cond delay="0"/>
+                                          </p:stCondLst>
+                                        </p:cTn>
+                                        <p:tgtEl>
+                                          <p:spTgt spid="6"/>
+                                        </p:tgtEl>
+                                        <p:attrNameLst>
+                                          <p:attrName>style.visibility</p:attrName>
+                                        </p:attrNameLst>
+                                      </p:cBhvr>
+                                      <p:to>
+                                        <p:strVal val="visible"/>
+                                      </p:to>
+                                    </p:set>
+                                    <p:animEffect transition="in" filter="fade">
+                                      <p:cBhvr>
                                         <p:cTn id="16" dur="500"/>
                                         <p:tgtEl>
-                                          <p:spTgt spid="3"/>
+                                          <p:spTgt spid="6"/>
                                         </p:tgtEl>
                                       </p:cBhvr>
                                     </p:animEffect>
@@ -5786,7 +5936,7 @@
                                           </p:stCondLst>
                                         </p:cTn>
                                         <p:tgtEl>
-                                          <p:spTgt spid="6"/>
+                                          <p:spTgt spid="7"/>
                                         </p:tgtEl>
                                         <p:attrNameLst>
                                           <p:attrName>style.visibility</p:attrName>
@@ -5800,59 +5950,6 @@
                                       <p:cBhvr>
                                         <p:cTn id="19" dur="500"/>
                                         <p:tgtEl>
-                                          <p:spTgt spid="6"/>
-                                        </p:tgtEl>
-                                      </p:cBhvr>
-                                    </p:animEffect>
-                                  </p:childTnLst>
-                                </p:cTn>
-                              </p:par>
-                            </p:childTnLst>
-                          </p:cTn>
-                        </p:par>
-                      </p:childTnLst>
-                    </p:cTn>
-                  </p:par>
-                  <p:par>
-                    <p:cTn id="20" fill="hold">
-                      <p:stCondLst>
-                        <p:cond delay="indefinite"/>
-                      </p:stCondLst>
-                      <p:childTnLst>
-                        <p:par>
-                          <p:cTn id="21" fill="hold">
-                            <p:stCondLst>
-                              <p:cond delay="0"/>
-                            </p:stCondLst>
-                            <p:childTnLst>
-                              <p:par>
-                                <p:cTn id="22" presetID="10" presetClass="entr" presetSubtype="0" fill="hold" grpId="0" nodeType="clickEffect">
-                                  <p:stCondLst>
-                                    <p:cond delay="0"/>
-                                  </p:stCondLst>
-                                  <p:childTnLst>
-                                    <p:set>
-                                      <p:cBhvr>
-                                        <p:cTn id="23" dur="1" fill="hold">
-                                          <p:stCondLst>
-                                            <p:cond delay="0"/>
-                                          </p:stCondLst>
-                                        </p:cTn>
-                                        <p:tgtEl>
-                                          <p:spTgt spid="7"/>
-                                        </p:tgtEl>
-                                        <p:attrNameLst>
-                                          <p:attrName>style.visibility</p:attrName>
-                                        </p:attrNameLst>
-                                      </p:cBhvr>
-                                      <p:to>
-                                        <p:strVal val="visible"/>
-                                      </p:to>
-                                    </p:set>
-                                    <p:animEffect transition="in" filter="fade">
-                                      <p:cBhvr>
-                                        <p:cTn id="24" dur="500"/>
-                                        <p:tgtEl>
                                           <p:spTgt spid="7"/>
                                         </p:tgtEl>
                                       </p:cBhvr>
@@ -5861,14 +5958,14 @@
                                 </p:cTn>
                               </p:par>
                               <p:par>
-                                <p:cTn id="25" presetID="10" presetClass="entr" presetSubtype="0" fill="hold" grpId="0" nodeType="withEffect">
+                                <p:cTn id="20" presetID="10" presetClass="entr" presetSubtype="0" fill="hold" grpId="0" nodeType="withEffect">
                                   <p:stCondLst>
                                     <p:cond delay="0"/>
                                   </p:stCondLst>
                                   <p:childTnLst>
                                     <p:set>
                                       <p:cBhvr>
-                                        <p:cTn id="26" dur="1" fill="hold">
+                                        <p:cTn id="21" dur="1" fill="hold">
                                           <p:stCondLst>
                                             <p:cond delay="0"/>
                                           </p:stCondLst>
@@ -5886,7 +5983,7 @@
                                     </p:set>
                                     <p:animEffect transition="in" filter="fade">
                                       <p:cBhvr>
-                                        <p:cTn id="27" dur="500"/>
+                                        <p:cTn id="22" dur="500"/>
                                         <p:tgtEl>
                                           <p:spTgt spid="10"/>
                                         </p:tgtEl>
@@ -5896,67 +5993,14 @@
                                 </p:cTn>
                               </p:par>
                               <p:par>
-                                <p:cTn id="28" presetID="10" presetClass="entr" presetSubtype="0" fill="hold" grpId="0" nodeType="withEffect">
+                                <p:cTn id="23" presetID="10" presetClass="entr" presetSubtype="0" fill="hold" grpId="0" nodeType="withEffect">
                                   <p:stCondLst>
                                     <p:cond delay="0"/>
                                   </p:stCondLst>
                                   <p:childTnLst>
                                     <p:set>
                                       <p:cBhvr>
-                                        <p:cTn id="29" dur="1" fill="hold">
-                                          <p:stCondLst>
-                                            <p:cond delay="0"/>
-                                          </p:stCondLst>
-                                        </p:cTn>
-                                        <p:tgtEl>
-                                          <p:spTgt spid="13"/>
-                                        </p:tgtEl>
-                                        <p:attrNameLst>
-                                          <p:attrName>style.visibility</p:attrName>
-                                        </p:attrNameLst>
-                                      </p:cBhvr>
-                                      <p:to>
-                                        <p:strVal val="visible"/>
-                                      </p:to>
-                                    </p:set>
-                                    <p:animEffect transition="in" filter="fade">
-                                      <p:cBhvr>
-                                        <p:cTn id="30" dur="500"/>
-                                        <p:tgtEl>
-                                          <p:spTgt spid="13"/>
-                                        </p:tgtEl>
-                                      </p:cBhvr>
-                                    </p:animEffect>
-                                  </p:childTnLst>
-                                </p:cTn>
-                              </p:par>
-                            </p:childTnLst>
-                          </p:cTn>
-                        </p:par>
-                      </p:childTnLst>
-                    </p:cTn>
-                  </p:par>
-                  <p:par>
-                    <p:cTn id="31" fill="hold">
-                      <p:stCondLst>
-                        <p:cond delay="indefinite"/>
-                      </p:stCondLst>
-                      <p:childTnLst>
-                        <p:par>
-                          <p:cTn id="32" fill="hold">
-                            <p:stCondLst>
-                              <p:cond delay="0"/>
-                            </p:stCondLst>
-                            <p:childTnLst>
-                              <p:par>
-                                <p:cTn id="33" presetID="10" presetClass="entr" presetSubtype="0" fill="hold" grpId="0" nodeType="clickEffect">
-                                  <p:stCondLst>
-                                    <p:cond delay="0"/>
-                                  </p:stCondLst>
-                                  <p:childTnLst>
-                                    <p:set>
-                                      <p:cBhvr>
-                                        <p:cTn id="34" dur="1" fill="hold">
+                                        <p:cTn id="24" dur="1" fill="hold">
                                           <p:stCondLst>
                                             <p:cond delay="0"/>
                                           </p:stCondLst>
@@ -5974,7 +6018,7 @@
                                     </p:set>
                                     <p:animEffect transition="in" filter="fade">
                                       <p:cBhvr>
-                                        <p:cTn id="35" dur="500"/>
+                                        <p:cTn id="25" dur="500"/>
                                         <p:tgtEl>
                                           <p:spTgt spid="8"/>
                                         </p:tgtEl>
@@ -5984,14 +6028,14 @@
                                 </p:cTn>
                               </p:par>
                               <p:par>
-                                <p:cTn id="36" presetID="10" presetClass="entr" presetSubtype="0" fill="hold" grpId="0" nodeType="withEffect">
+                                <p:cTn id="26" presetID="10" presetClass="entr" presetSubtype="0" fill="hold" grpId="0" nodeType="withEffect">
                                   <p:stCondLst>
                                     <p:cond delay="0"/>
                                   </p:stCondLst>
                                   <p:childTnLst>
                                     <p:set>
                                       <p:cBhvr>
-                                        <p:cTn id="37" dur="1" fill="hold">
+                                        <p:cTn id="27" dur="1" fill="hold">
                                           <p:stCondLst>
                                             <p:cond delay="0"/>
                                           </p:stCondLst>
@@ -6009,7 +6053,7 @@
                                     </p:set>
                                     <p:animEffect transition="in" filter="fade">
                                       <p:cBhvr>
-                                        <p:cTn id="38" dur="500"/>
+                                        <p:cTn id="28" dur="500"/>
                                         <p:tgtEl>
                                           <p:spTgt spid="17"/>
                                         </p:tgtEl>
@@ -6019,67 +6063,14 @@
                                 </p:cTn>
                               </p:par>
                               <p:par>
-                                <p:cTn id="39" presetID="10" presetClass="entr" presetSubtype="0" fill="hold" grpId="0" nodeType="withEffect">
+                                <p:cTn id="29" presetID="10" presetClass="entr" presetSubtype="0" fill="hold" grpId="0" nodeType="withEffect">
                                   <p:stCondLst>
                                     <p:cond delay="0"/>
                                   </p:stCondLst>
                                   <p:childTnLst>
                                     <p:set>
                                       <p:cBhvr>
-                                        <p:cTn id="40" dur="1" fill="hold">
-                                          <p:stCondLst>
-                                            <p:cond delay="0"/>
-                                          </p:stCondLst>
-                                        </p:cTn>
-                                        <p:tgtEl>
-                                          <p:spTgt spid="14"/>
-                                        </p:tgtEl>
-                                        <p:attrNameLst>
-                                          <p:attrName>style.visibility</p:attrName>
-                                        </p:attrNameLst>
-                                      </p:cBhvr>
-                                      <p:to>
-                                        <p:strVal val="visible"/>
-                                      </p:to>
-                                    </p:set>
-                                    <p:animEffect transition="in" filter="fade">
-                                      <p:cBhvr>
-                                        <p:cTn id="41" dur="500"/>
-                                        <p:tgtEl>
-                                          <p:spTgt spid="14"/>
-                                        </p:tgtEl>
-                                      </p:cBhvr>
-                                    </p:animEffect>
-                                  </p:childTnLst>
-                                </p:cTn>
-                              </p:par>
-                            </p:childTnLst>
-                          </p:cTn>
-                        </p:par>
-                      </p:childTnLst>
-                    </p:cTn>
-                  </p:par>
-                  <p:par>
-                    <p:cTn id="42" fill="hold">
-                      <p:stCondLst>
-                        <p:cond delay="indefinite"/>
-                      </p:stCondLst>
-                      <p:childTnLst>
-                        <p:par>
-                          <p:cTn id="43" fill="hold">
-                            <p:stCondLst>
-                              <p:cond delay="0"/>
-                            </p:stCondLst>
-                            <p:childTnLst>
-                              <p:par>
-                                <p:cTn id="44" presetID="10" presetClass="entr" presetSubtype="0" fill="hold" grpId="0" nodeType="clickEffect">
-                                  <p:stCondLst>
-                                    <p:cond delay="0"/>
-                                  </p:stCondLst>
-                                  <p:childTnLst>
-                                    <p:set>
-                                      <p:cBhvr>
-                                        <p:cTn id="45" dur="1" fill="hold">
+                                        <p:cTn id="30" dur="1" fill="hold">
                                           <p:stCondLst>
                                             <p:cond delay="0"/>
                                           </p:stCondLst>
@@ -6097,7 +6088,7 @@
                                     </p:set>
                                     <p:animEffect transition="in" filter="fade">
                                       <p:cBhvr>
-                                        <p:cTn id="46" dur="500"/>
+                                        <p:cTn id="31" dur="500"/>
                                         <p:tgtEl>
                                           <p:spTgt spid="9"/>
                                         </p:tgtEl>
@@ -6107,14 +6098,14 @@
                                 </p:cTn>
                               </p:par>
                               <p:par>
-                                <p:cTn id="47" presetID="10" presetClass="entr" presetSubtype="0" fill="hold" grpId="0" nodeType="withEffect">
+                                <p:cTn id="32" presetID="10" presetClass="entr" presetSubtype="0" fill="hold" grpId="0" nodeType="withEffect">
                                   <p:stCondLst>
                                     <p:cond delay="0"/>
                                   </p:stCondLst>
                                   <p:childTnLst>
                                     <p:set>
                                       <p:cBhvr>
-                                        <p:cTn id="48" dur="1" fill="hold">
+                                        <p:cTn id="33" dur="1" fill="hold">
                                           <p:stCondLst>
                                             <p:cond delay="0"/>
                                           </p:stCondLst>
@@ -6132,44 +6123,9 @@
                                     </p:set>
                                     <p:animEffect transition="in" filter="fade">
                                       <p:cBhvr>
-                                        <p:cTn id="49" dur="500"/>
+                                        <p:cTn id="34" dur="500"/>
                                         <p:tgtEl>
                                           <p:spTgt spid="18"/>
-                                        </p:tgtEl>
-                                      </p:cBhvr>
-                                    </p:animEffect>
-                                  </p:childTnLst>
-                                </p:cTn>
-                              </p:par>
-                              <p:par>
-                                <p:cTn id="50" presetID="10" presetClass="entr" presetSubtype="0" fill="hold" grpId="0" nodeType="withEffect">
-                                  <p:stCondLst>
-                                    <p:cond delay="0"/>
-                                  </p:stCondLst>
-                                  <p:childTnLst>
-                                    <p:set>
-                                      <p:cBhvr>
-                                        <p:cTn id="51" dur="1" fill="hold">
-                                          <p:stCondLst>
-                                            <p:cond delay="0"/>
-                                          </p:stCondLst>
-                                        </p:cTn>
-                                        <p:tgtEl>
-                                          <p:spTgt spid="15"/>
-                                        </p:tgtEl>
-                                        <p:attrNameLst>
-                                          <p:attrName>style.visibility</p:attrName>
-                                        </p:attrNameLst>
-                                      </p:cBhvr>
-                                      <p:to>
-                                        <p:strVal val="visible"/>
-                                      </p:to>
-                                    </p:set>
-                                    <p:animEffect transition="in" filter="fade">
-                                      <p:cBhvr>
-                                        <p:cTn id="52" dur="500"/>
-                                        <p:tgtEl>
-                                          <p:spTgt spid="15"/>
                                         </p:tgtEl>
                                       </p:cBhvr>
                                     </p:animEffect>
@@ -6210,10 +6166,6 @@
       <p:bldP spid="8" grpId="0" animBg="1"/>
       <p:bldP spid="9" grpId="0" animBg="1"/>
       <p:bldP spid="10" grpId="0"/>
-      <p:bldP spid="12" grpId="0"/>
-      <p:bldP spid="13" grpId="0"/>
-      <p:bldP spid="14" grpId="0"/>
-      <p:bldP spid="15" grpId="0"/>
       <p:bldP spid="16" grpId="0"/>
       <p:bldP spid="17" grpId="0"/>
       <p:bldP spid="18" grpId="0"/>
@@ -8147,7 +8099,7 @@
         </p:nvSpPr>
         <p:spPr>
           <a:xfrm rot="-535869">
-            <a:off x="11226228" y="7703363"/>
+            <a:off x="11226228" y="8137921"/>
             <a:ext cx="3894554" cy="3582989"/>
           </a:xfrm>
           <a:custGeom>
@@ -8206,7 +8158,7 @@
         </p:nvSpPr>
         <p:spPr>
           <a:xfrm rot="-145680">
-            <a:off x="3401939" y="8092896"/>
+            <a:off x="3401939" y="8445960"/>
             <a:ext cx="3519250" cy="3330090"/>
           </a:xfrm>
           <a:custGeom>
@@ -8265,7 +8217,7 @@
         </p:nvSpPr>
         <p:spPr>
           <a:xfrm>
-            <a:off x="-654506" y="7600646"/>
+            <a:off x="-654506" y="7962900"/>
             <a:ext cx="3607581" cy="3476806"/>
           </a:xfrm>
           <a:custGeom>
@@ -8324,7 +8276,7 @@
         </p:nvSpPr>
         <p:spPr>
           <a:xfrm rot="359659">
-            <a:off x="15708951" y="8173505"/>
+            <a:off x="15708951" y="8406456"/>
             <a:ext cx="3100699" cy="3015430"/>
           </a:xfrm>
           <a:custGeom>
@@ -8383,7 +8335,7 @@
         </p:nvSpPr>
         <p:spPr>
           <a:xfrm rot="574447">
-            <a:off x="7322967" y="8295921"/>
+            <a:off x="7322967" y="8486079"/>
             <a:ext cx="3642065" cy="3848946"/>
           </a:xfrm>
           <a:custGeom>
@@ -8730,7 +8682,7 @@
                 <a:cs typeface="Bricolage Grotesque"/>
                 <a:sym typeface="Bricolage Grotesque"/>
               </a:rPr>
-              <a:t>My master thesis focuses on ChatGPT and essay enhancement.</a:t>
+              <a:t>My master thesis focuses on AI (ChatGPT) and essay enhancement.</a:t>
             </a:r>
           </a:p>
           <a:p>
@@ -8829,7 +8781,7 @@
         </p:nvSpPr>
         <p:spPr>
           <a:xfrm>
-            <a:off x="10820400" y="1028700"/>
+            <a:off x="11277600" y="1485900"/>
             <a:ext cx="8302245" cy="8229600"/>
           </a:xfrm>
           <a:custGeom>
@@ -8906,7 +8858,7 @@
                             </p:stCondLst>
                             <p:childTnLst>
                               <p:par>
-                                <p:cTn id="5" presetID="10" presetClass="entr" presetSubtype="0" fill="hold" nodeType="clickEffect">
+                                <p:cTn id="5" presetID="10" presetClass="entr" presetSubtype="0" fill="hold" grpId="0" nodeType="clickEffect">
                                   <p:stCondLst>
                                     <p:cond delay="0"/>
                                   </p:stCondLst>
@@ -8948,33 +8900,15 @@
                                   </p:childTnLst>
                                 </p:cTn>
                               </p:par>
-                            </p:childTnLst>
-                          </p:cTn>
-                        </p:par>
-                      </p:childTnLst>
-                    </p:cTn>
-                  </p:par>
-                  <p:par>
-                    <p:cTn id="8" fill="hold">
-                      <p:stCondLst>
-                        <p:cond delay="indefinite"/>
-                      </p:stCondLst>
-                      <p:childTnLst>
-                        <p:par>
-                          <p:cTn id="9" fill="hold">
-                            <p:stCondLst>
-                              <p:cond delay="0"/>
-                            </p:stCondLst>
-                            <p:childTnLst>
                               <p:par>
-                                <p:cTn id="10" presetID="10" presetClass="entr" presetSubtype="0" fill="hold" nodeType="clickEffect">
+                                <p:cTn id="8" presetID="10" presetClass="entr" presetSubtype="0" fill="hold" grpId="0" nodeType="withEffect">
                                   <p:stCondLst>
                                     <p:cond delay="0"/>
                                   </p:stCondLst>
                                   <p:childTnLst>
                                     <p:set>
                                       <p:cBhvr>
-                                        <p:cTn id="11" dur="1" fill="hold">
+                                        <p:cTn id="9" dur="1" fill="hold">
                                           <p:stCondLst>
                                             <p:cond delay="0"/>
                                           </p:stCondLst>
@@ -8996,7 +8930,7 @@
                                     </p:set>
                                     <p:animEffect transition="in" filter="fade">
                                       <p:cBhvr>
-                                        <p:cTn id="12" dur="500"/>
+                                        <p:cTn id="10" dur="500"/>
                                         <p:tgtEl>
                                           <p:spTgt spid="3">
                                             <p:txEl>
@@ -9009,33 +8943,15 @@
                                   </p:childTnLst>
                                 </p:cTn>
                               </p:par>
-                            </p:childTnLst>
-                          </p:cTn>
-                        </p:par>
-                      </p:childTnLst>
-                    </p:cTn>
-                  </p:par>
-                  <p:par>
-                    <p:cTn id="13" fill="hold">
-                      <p:stCondLst>
-                        <p:cond delay="indefinite"/>
-                      </p:stCondLst>
-                      <p:childTnLst>
-                        <p:par>
-                          <p:cTn id="14" fill="hold">
-                            <p:stCondLst>
-                              <p:cond delay="0"/>
-                            </p:stCondLst>
-                            <p:childTnLst>
                               <p:par>
-                                <p:cTn id="15" presetID="10" presetClass="entr" presetSubtype="0" fill="hold" nodeType="clickEffect">
+                                <p:cTn id="11" presetID="10" presetClass="entr" presetSubtype="0" fill="hold" grpId="0" nodeType="withEffect">
                                   <p:stCondLst>
                                     <p:cond delay="0"/>
                                   </p:stCondLst>
                                   <p:childTnLst>
                                     <p:set>
                                       <p:cBhvr>
-                                        <p:cTn id="16" dur="1" fill="hold">
+                                        <p:cTn id="12" dur="1" fill="hold">
                                           <p:stCondLst>
                                             <p:cond delay="0"/>
                                           </p:stCondLst>
@@ -9057,7 +8973,7 @@
                                     </p:set>
                                     <p:animEffect transition="in" filter="fade">
                                       <p:cBhvr>
-                                        <p:cTn id="17" dur="500"/>
+                                        <p:cTn id="13" dur="500"/>
                                         <p:tgtEl>
                                           <p:spTgt spid="3">
                                             <p:txEl>
@@ -9097,6 +9013,9 @@
         </p:cTn>
       </p:par>
     </p:tnLst>
+    <p:bldLst>
+      <p:bldP spid="3" grpId="0" build="allAtOnce"/>
+    </p:bldLst>
   </p:timing>
 </p:sld>
 </file>
@@ -9134,7 +9053,7 @@
         </p:nvSpPr>
         <p:spPr>
           <a:xfrm rot="-691699">
-            <a:off x="15311864" y="3220273"/>
+            <a:off x="15180553" y="2882165"/>
             <a:ext cx="4154462" cy="3863649"/>
           </a:xfrm>
           <a:custGeom>
@@ -9193,7 +9112,7 @@
         </p:nvSpPr>
         <p:spPr>
           <a:xfrm rot="-284944">
-            <a:off x="-828357" y="3007444"/>
+            <a:off x="-1640674" y="2979175"/>
             <a:ext cx="4096277" cy="3630325"/>
           </a:xfrm>
           <a:custGeom>
@@ -9252,7 +9171,7 @@
         </p:nvSpPr>
         <p:spPr>
           <a:xfrm rot="1061051">
-            <a:off x="12662573" y="7240317"/>
+            <a:off x="12862599" y="7878048"/>
             <a:ext cx="3642065" cy="3848946"/>
           </a:xfrm>
           <a:custGeom>
@@ -9311,7 +9230,7 @@
         </p:nvSpPr>
         <p:spPr>
           <a:xfrm rot="-411245">
-            <a:off x="7229722" y="8180178"/>
+            <a:off x="7681266" y="8281653"/>
             <a:ext cx="4476094" cy="3731943"/>
           </a:xfrm>
           <a:custGeom>
@@ -9370,7 +9289,7 @@
         </p:nvSpPr>
         <p:spPr>
           <a:xfrm rot="-474403">
-            <a:off x="6959966" y="-2524910"/>
+            <a:off x="6959966" y="-2119797"/>
             <a:ext cx="4368067" cy="4329846"/>
           </a:xfrm>
           <a:custGeom>
@@ -9429,7 +9348,7 @@
         </p:nvSpPr>
         <p:spPr>
           <a:xfrm>
-            <a:off x="2059461" y="7107532"/>
+            <a:off x="2470295" y="7921556"/>
             <a:ext cx="4373018" cy="4214496"/>
           </a:xfrm>
           <a:custGeom>
@@ -9547,7 +9466,7 @@
         </p:nvSpPr>
         <p:spPr>
           <a:xfrm rot="675348">
-            <a:off x="12487240" y="-563389"/>
+            <a:off x="12477356" y="-1035948"/>
             <a:ext cx="3789402" cy="3685194"/>
           </a:xfrm>
           <a:custGeom>
@@ -9606,7 +9525,7 @@
         </p:nvSpPr>
         <p:spPr>
           <a:xfrm rot="710027">
-            <a:off x="2194216" y="-882445"/>
+            <a:off x="2141444" y="-1085938"/>
             <a:ext cx="4057937" cy="3692723"/>
           </a:xfrm>
           <a:custGeom>
@@ -9824,7 +9743,7 @@
         </p:nvSpPr>
         <p:spPr>
           <a:xfrm rot="-503037">
-            <a:off x="17148200" y="7696708"/>
+            <a:off x="17176210" y="7849281"/>
             <a:ext cx="3294905" cy="2230322"/>
           </a:xfrm>
           <a:custGeom>
@@ -9872,6 +9791,252 @@
           <a:lstStyle/>
           <a:p>
             <a:endParaRPr lang="de-AT"/>
+          </a:p>
+        </p:txBody>
+      </p:sp>
+      <p:sp>
+        <p:nvSpPr>
+          <p:cNvPr id="16" name="Textfeld 15">
+            <a:extLst>
+              <a:ext uri="{FF2B5EF4-FFF2-40B4-BE49-F238E27FC236}">
+                <a16:creationId xmlns:a16="http://schemas.microsoft.com/office/drawing/2014/main" id="{991D8DE7-5AF2-F117-76F1-3EE3ECF51802}"/>
+              </a:ext>
+            </a:extLst>
+          </p:cNvPr>
+          <p:cNvSpPr txBox="1"/>
+          <p:nvPr/>
+        </p:nvSpPr>
+        <p:spPr>
+          <a:xfrm>
+            <a:off x="4291726" y="6952813"/>
+            <a:ext cx="9704545" cy="1169551"/>
+          </a:xfrm>
+          <a:prstGeom prst="rect">
+            <a:avLst/>
+          </a:prstGeom>
+          <a:noFill/>
+        </p:spPr>
+        <p:txBody>
+          <a:bodyPr wrap="square">
+            <a:spAutoFit/>
+          </a:bodyPr>
+          <a:lstStyle/>
+          <a:p>
+            <a:pPr algn="ctr"/>
+            <a:r>
+              <a:rPr lang="de-AT" sz="1600" dirty="0">
+                <a:solidFill>
+                  <a:srgbClr val="558DFD"/>
+                </a:solidFill>
+                <a:latin typeface="Bobby Jones Soft"/>
+              </a:rPr>
+              <a:t>Source: </a:t>
+            </a:r>
+          </a:p>
+          <a:p>
+            <a:pPr algn="ctr"/>
+            <a:r>
+              <a:rPr lang="de-AT" b="0" i="0" dirty="0">
+                <a:solidFill>
+                  <a:srgbClr val="475569"/>
+                </a:solidFill>
+                <a:effectLst/>
+                <a:latin typeface="Segoe UI" panose="020B0502040204020203" pitchFamily="34" charset="0"/>
+              </a:rPr>
+              <a:t>Bašić, Ž., </a:t>
+            </a:r>
+            <a:r>
+              <a:rPr lang="de-AT" b="0" i="0" dirty="0" err="1">
+                <a:solidFill>
+                  <a:srgbClr val="475569"/>
+                </a:solidFill>
+                <a:effectLst/>
+                <a:latin typeface="Segoe UI" panose="020B0502040204020203" pitchFamily="34" charset="0"/>
+              </a:rPr>
+              <a:t>Banovac</a:t>
+            </a:r>
+            <a:r>
+              <a:rPr lang="de-AT" b="0" i="0" dirty="0">
+                <a:solidFill>
+                  <a:srgbClr val="475569"/>
+                </a:solidFill>
+                <a:effectLst/>
+                <a:latin typeface="Segoe UI" panose="020B0502040204020203" pitchFamily="34" charset="0"/>
+              </a:rPr>
+              <a:t>, A., </a:t>
+            </a:r>
+            <a:r>
+              <a:rPr lang="de-AT" b="0" i="0" dirty="0" err="1">
+                <a:solidFill>
+                  <a:srgbClr val="475569"/>
+                </a:solidFill>
+                <a:effectLst/>
+                <a:latin typeface="Segoe UI" panose="020B0502040204020203" pitchFamily="34" charset="0"/>
+              </a:rPr>
+              <a:t>Kružić</a:t>
+            </a:r>
+            <a:r>
+              <a:rPr lang="de-AT" b="0" i="0" dirty="0">
+                <a:solidFill>
+                  <a:srgbClr val="475569"/>
+                </a:solidFill>
+                <a:effectLst/>
+                <a:latin typeface="Segoe UI" panose="020B0502040204020203" pitchFamily="34" charset="0"/>
+              </a:rPr>
+              <a:t>, I. et al. ChatGPT-3.5 </a:t>
+            </a:r>
+            <a:r>
+              <a:rPr lang="de-AT" b="0" i="0" dirty="0" err="1">
+                <a:solidFill>
+                  <a:srgbClr val="475569"/>
+                </a:solidFill>
+                <a:effectLst/>
+                <a:latin typeface="Segoe UI" panose="020B0502040204020203" pitchFamily="34" charset="0"/>
+              </a:rPr>
+              <a:t>as</a:t>
+            </a:r>
+            <a:r>
+              <a:rPr lang="de-AT" b="0" i="0" dirty="0">
+                <a:solidFill>
+                  <a:srgbClr val="475569"/>
+                </a:solidFill>
+                <a:effectLst/>
+                <a:latin typeface="Segoe UI" panose="020B0502040204020203" pitchFamily="34" charset="0"/>
+              </a:rPr>
+              <a:t> </a:t>
+            </a:r>
+            <a:r>
+              <a:rPr lang="de-AT" b="0" i="0" dirty="0" err="1">
+                <a:solidFill>
+                  <a:srgbClr val="475569"/>
+                </a:solidFill>
+                <a:effectLst/>
+                <a:latin typeface="Segoe UI" panose="020B0502040204020203" pitchFamily="34" charset="0"/>
+              </a:rPr>
+              <a:t>writing</a:t>
+            </a:r>
+            <a:r>
+              <a:rPr lang="de-AT" b="0" i="0" dirty="0">
+                <a:solidFill>
+                  <a:srgbClr val="475569"/>
+                </a:solidFill>
+                <a:effectLst/>
+                <a:latin typeface="Segoe UI" panose="020B0502040204020203" pitchFamily="34" charset="0"/>
+              </a:rPr>
+              <a:t> </a:t>
+            </a:r>
+            <a:r>
+              <a:rPr lang="de-AT" b="0" i="0" dirty="0" err="1">
+                <a:solidFill>
+                  <a:srgbClr val="475569"/>
+                </a:solidFill>
+                <a:effectLst/>
+                <a:latin typeface="Segoe UI" panose="020B0502040204020203" pitchFamily="34" charset="0"/>
+              </a:rPr>
+              <a:t>assistance</a:t>
+            </a:r>
+            <a:r>
+              <a:rPr lang="de-AT" b="0" i="0" dirty="0">
+                <a:solidFill>
+                  <a:srgbClr val="475569"/>
+                </a:solidFill>
+                <a:effectLst/>
+                <a:latin typeface="Segoe UI" panose="020B0502040204020203" pitchFamily="34" charset="0"/>
+              </a:rPr>
+              <a:t> in </a:t>
+            </a:r>
+            <a:r>
+              <a:rPr lang="de-AT" b="0" i="0" dirty="0" err="1">
+                <a:solidFill>
+                  <a:srgbClr val="475569"/>
+                </a:solidFill>
+                <a:effectLst/>
+                <a:latin typeface="Segoe UI" panose="020B0502040204020203" pitchFamily="34" charset="0"/>
+              </a:rPr>
+              <a:t>students</a:t>
+            </a:r>
+            <a:r>
+              <a:rPr lang="de-AT" b="0" i="0" dirty="0">
+                <a:solidFill>
+                  <a:srgbClr val="475569"/>
+                </a:solidFill>
+                <a:effectLst/>
+                <a:latin typeface="Segoe UI" panose="020B0502040204020203" pitchFamily="34" charset="0"/>
+              </a:rPr>
+              <a:t>’ </a:t>
+            </a:r>
+            <a:r>
+              <a:rPr lang="de-AT" b="0" i="0" dirty="0" err="1">
+                <a:solidFill>
+                  <a:srgbClr val="475569"/>
+                </a:solidFill>
+                <a:effectLst/>
+                <a:latin typeface="Segoe UI" panose="020B0502040204020203" pitchFamily="34" charset="0"/>
+              </a:rPr>
+              <a:t>essays</a:t>
+            </a:r>
+            <a:r>
+              <a:rPr lang="de-AT" b="0" i="0" dirty="0">
+                <a:solidFill>
+                  <a:srgbClr val="475569"/>
+                </a:solidFill>
+                <a:effectLst/>
+                <a:latin typeface="Segoe UI" panose="020B0502040204020203" pitchFamily="34" charset="0"/>
+              </a:rPr>
+              <a:t>. </a:t>
+            </a:r>
+            <a:r>
+              <a:rPr lang="de-AT" b="0" i="0" dirty="0" err="1">
+                <a:solidFill>
+                  <a:srgbClr val="475569"/>
+                </a:solidFill>
+                <a:effectLst/>
+                <a:latin typeface="Segoe UI" panose="020B0502040204020203" pitchFamily="34" charset="0"/>
+              </a:rPr>
+              <a:t>Humanit</a:t>
+            </a:r>
+            <a:r>
+              <a:rPr lang="de-AT" b="0" i="0" dirty="0">
+                <a:solidFill>
+                  <a:srgbClr val="475569"/>
+                </a:solidFill>
+                <a:effectLst/>
+                <a:latin typeface="Segoe UI" panose="020B0502040204020203" pitchFamily="34" charset="0"/>
+              </a:rPr>
+              <a:t> Soc </a:t>
+            </a:r>
+            <a:r>
+              <a:rPr lang="de-AT" b="0" i="0" dirty="0" err="1">
+                <a:solidFill>
+                  <a:srgbClr val="475569"/>
+                </a:solidFill>
+                <a:effectLst/>
+                <a:latin typeface="Segoe UI" panose="020B0502040204020203" pitchFamily="34" charset="0"/>
+              </a:rPr>
+              <a:t>Sci</a:t>
+            </a:r>
+            <a:r>
+              <a:rPr lang="de-AT" b="0" i="0" dirty="0">
+                <a:solidFill>
+                  <a:srgbClr val="475569"/>
+                </a:solidFill>
+                <a:effectLst/>
+                <a:latin typeface="Segoe UI" panose="020B0502040204020203" pitchFamily="34" charset="0"/>
+              </a:rPr>
+              <a:t> Commun 10, 750 (2023). </a:t>
+            </a:r>
+          </a:p>
+          <a:p>
+            <a:pPr algn="ctr"/>
+            <a:r>
+              <a:rPr lang="de-AT" b="0" i="0" dirty="0">
+                <a:effectLst/>
+                <a:latin typeface="Segoe UI" panose="020B0502040204020203" pitchFamily="34" charset="0"/>
+                <a:hlinkClick r:id="rId13"/>
+              </a:rPr>
+              <a:t>https://doi.org/10.1057/s41599-023-02269-7</a:t>
+            </a:r>
+            <a:endParaRPr lang="de-AT" dirty="0"/>
           </a:p>
         </p:txBody>
       </p:sp>

</xml_diff>

<commit_message>
adapted lightning talk Knes
</commit_message>
<xml_diff>
--- a/Lightning Talk Christina.pptx
+++ b/Lightning Talk Christina.pptx
@@ -160,7 +160,7 @@
 <file path=ppt/revisionInfo.xml><?xml version="1.0" encoding="utf-8"?>
 <p1510:revInfo xmlns:a="http://schemas.openxmlformats.org/drawingml/2006/main" xmlns:r="http://schemas.openxmlformats.org/officeDocument/2006/relationships" xmlns:p1510="http://schemas.microsoft.com/office/powerpoint/2015/10/main">
   <p1510:revLst>
-    <p1510:client id="{758A810B-C379-4C8B-B534-293CCBD759B1}" v="46" dt="2026-06-15T15:39:01.142"/>
+    <p1510:client id="{758A810B-C379-4C8B-B534-293CCBD759B1}" v="65" dt="2026-06-16T14:34:57.367"/>
   </p1510:revLst>
 </p1510:revInfo>
 </file>
@@ -169,8 +169,8 @@
 <pc:chgInfo xmlns:a="http://schemas.openxmlformats.org/drawingml/2006/main" xmlns:r="http://schemas.openxmlformats.org/officeDocument/2006/relationships" xmlns:ac="http://schemas.microsoft.com/office/drawing/2013/main/command" xmlns:pc="http://schemas.microsoft.com/office/powerpoint/2013/main/command">
   <pc:docChgLst>
     <pc:chgData name="Christina Knes" userId="7e9737a164333dbd" providerId="LiveId" clId="{72053980-4108-4AED-A5B7-3290F7F82C69}"/>
-    <pc:docChg chg="custSel modSld">
-      <pc:chgData name="Christina Knes" userId="7e9737a164333dbd" providerId="LiveId" clId="{72053980-4108-4AED-A5B7-3290F7F82C69}" dt="2026-06-15T15:55:17.928" v="272" actId="20577"/>
+    <pc:docChg chg="undo custSel modSld">
+      <pc:chgData name="Christina Knes" userId="7e9737a164333dbd" providerId="LiveId" clId="{72053980-4108-4AED-A5B7-3290F7F82C69}" dt="2026-06-16T14:34:57.367" v="313" actId="113"/>
       <pc:docMkLst>
         <pc:docMk/>
       </pc:docMkLst>
@@ -309,13 +309,13 @@
         </pc:spChg>
       </pc:sldChg>
       <pc:sldChg chg="delSp modSp mod addAnim delAnim modAnim modNotesTx">
-        <pc:chgData name="Christina Knes" userId="7e9737a164333dbd" providerId="LiveId" clId="{72053980-4108-4AED-A5B7-3290F7F82C69}" dt="2026-06-15T15:42:01.323" v="258" actId="20577"/>
+        <pc:chgData name="Christina Knes" userId="7e9737a164333dbd" providerId="LiveId" clId="{72053980-4108-4AED-A5B7-3290F7F82C69}" dt="2026-06-16T14:34:57.367" v="313" actId="113"/>
         <pc:sldMkLst>
           <pc:docMk/>
           <pc:sldMk cId="0" sldId="258"/>
         </pc:sldMkLst>
         <pc:spChg chg="mod">
-          <ac:chgData name="Christina Knes" userId="7e9737a164333dbd" providerId="LiveId" clId="{72053980-4108-4AED-A5B7-3290F7F82C69}" dt="2026-06-09T08:43:14.642" v="113" actId="1076"/>
+          <ac:chgData name="Christina Knes" userId="7e9737a164333dbd" providerId="LiveId" clId="{72053980-4108-4AED-A5B7-3290F7F82C69}" dt="2026-06-16T14:31:47.459" v="284" actId="1076"/>
           <ac:spMkLst>
             <pc:docMk/>
             <pc:sldMk cId="0" sldId="258"/>
@@ -323,7 +323,7 @@
           </ac:spMkLst>
         </pc:spChg>
         <pc:spChg chg="mod">
-          <ac:chgData name="Christina Knes" userId="7e9737a164333dbd" providerId="LiveId" clId="{72053980-4108-4AED-A5B7-3290F7F82C69}" dt="2026-06-09T08:43:14.642" v="113" actId="1076"/>
+          <ac:chgData name="Christina Knes" userId="7e9737a164333dbd" providerId="LiveId" clId="{72053980-4108-4AED-A5B7-3290F7F82C69}" dt="2026-06-16T14:31:47.459" v="284" actId="1076"/>
           <ac:spMkLst>
             <pc:docMk/>
             <pc:sldMk cId="0" sldId="258"/>
@@ -331,7 +331,7 @@
           </ac:spMkLst>
         </pc:spChg>
         <pc:spChg chg="mod">
-          <ac:chgData name="Christina Knes" userId="7e9737a164333dbd" providerId="LiveId" clId="{72053980-4108-4AED-A5B7-3290F7F82C69}" dt="2026-06-09T08:43:14.642" v="113" actId="1076"/>
+          <ac:chgData name="Christina Knes" userId="7e9737a164333dbd" providerId="LiveId" clId="{72053980-4108-4AED-A5B7-3290F7F82C69}" dt="2026-06-16T14:32:02.273" v="285" actId="1076"/>
           <ac:spMkLst>
             <pc:docMk/>
             <pc:sldMk cId="0" sldId="258"/>
@@ -355,7 +355,7 @@
           </ac:spMkLst>
         </pc:spChg>
         <pc:spChg chg="mod">
-          <ac:chgData name="Christina Knes" userId="7e9737a164333dbd" providerId="LiveId" clId="{72053980-4108-4AED-A5B7-3290F7F82C69}" dt="2026-06-09T08:43:06.653" v="112" actId="1076"/>
+          <ac:chgData name="Christina Knes" userId="7e9737a164333dbd" providerId="LiveId" clId="{72053980-4108-4AED-A5B7-3290F7F82C69}" dt="2026-06-16T14:34:38.044" v="309" actId="113"/>
           <ac:spMkLst>
             <pc:docMk/>
             <pc:sldMk cId="0" sldId="258"/>
@@ -363,7 +363,15 @@
           </ac:spMkLst>
         </pc:spChg>
         <pc:spChg chg="mod">
-          <ac:chgData name="Christina Knes" userId="7e9737a164333dbd" providerId="LiveId" clId="{72053980-4108-4AED-A5B7-3290F7F82C69}" dt="2026-06-09T08:43:06.653" v="112" actId="1076"/>
+          <ac:chgData name="Christina Knes" userId="7e9737a164333dbd" providerId="LiveId" clId="{72053980-4108-4AED-A5B7-3290F7F82C69}" dt="2026-06-16T14:31:23.632" v="281" actId="1076"/>
+          <ac:spMkLst>
+            <pc:docMk/>
+            <pc:sldMk cId="0" sldId="258"/>
+            <ac:spMk id="11" creationId="{00000000-0000-0000-0000-000000000000}"/>
+          </ac:spMkLst>
+        </pc:spChg>
+        <pc:spChg chg="mod">
+          <ac:chgData name="Christina Knes" userId="7e9737a164333dbd" providerId="LiveId" clId="{72053980-4108-4AED-A5B7-3290F7F82C69}" dt="2026-06-16T14:34:34.801" v="308" actId="113"/>
           <ac:spMkLst>
             <pc:docMk/>
             <pc:sldMk cId="0" sldId="258"/>
@@ -371,7 +379,7 @@
           </ac:spMkLst>
         </pc:spChg>
         <pc:spChg chg="mod">
-          <ac:chgData name="Christina Knes" userId="7e9737a164333dbd" providerId="LiveId" clId="{72053980-4108-4AED-A5B7-3290F7F82C69}" dt="2026-06-09T08:43:06.653" v="112" actId="1076"/>
+          <ac:chgData name="Christina Knes" userId="7e9737a164333dbd" providerId="LiveId" clId="{72053980-4108-4AED-A5B7-3290F7F82C69}" dt="2026-06-16T14:34:47.222" v="311" actId="113"/>
           <ac:spMkLst>
             <pc:docMk/>
             <pc:sldMk cId="0" sldId="258"/>
@@ -379,7 +387,7 @@
           </ac:spMkLst>
         </pc:spChg>
         <pc:spChg chg="mod">
-          <ac:chgData name="Christina Knes" userId="7e9737a164333dbd" providerId="LiveId" clId="{72053980-4108-4AED-A5B7-3290F7F82C69}" dt="2026-06-09T08:43:06.653" v="112" actId="1076"/>
+          <ac:chgData name="Christina Knes" userId="7e9737a164333dbd" providerId="LiveId" clId="{72053980-4108-4AED-A5B7-3290F7F82C69}" dt="2026-06-16T14:34:57.367" v="313" actId="113"/>
           <ac:spMkLst>
             <pc:docMk/>
             <pc:sldMk cId="0" sldId="258"/>
@@ -387,7 +395,7 @@
           </ac:spMkLst>
         </pc:spChg>
         <pc:grpChg chg="mod">
-          <ac:chgData name="Christina Knes" userId="7e9737a164333dbd" providerId="LiveId" clId="{72053980-4108-4AED-A5B7-3290F7F82C69}" dt="2026-06-09T08:43:14.642" v="113" actId="1076"/>
+          <ac:chgData name="Christina Knes" userId="7e9737a164333dbd" providerId="LiveId" clId="{72053980-4108-4AED-A5B7-3290F7F82C69}" dt="2026-06-16T14:31:47.459" v="284" actId="1076"/>
           <ac:grpSpMkLst>
             <pc:docMk/>
             <pc:sldMk cId="0" sldId="258"/>
@@ -646,7 +654,7 @@
           <a:p>
             <a:fld id="{7AAA80C1-B10E-441C-98F7-90D0E5C9B104}" type="datetimeFigureOut">
               <a:rPr lang="de-AT" smtClean="0"/>
-              <a:t>15.06.2026</a:t>
+              <a:t>16.06.2026</a:t>
             </a:fld>
             <a:endParaRPr lang="de-AT"/>
           </a:p>
@@ -4968,7 +4976,7 @@
             <a:fld id="{1D8BD707-D9CF-40AE-B4C6-C98DA3205C09}" type="datetimeFigureOut">
               <a:rPr lang="en-US" smtClean="0"/>
               <a:pPr/>
-              <a:t>6/15/2026</a:t>
+              <a:t>6/16/2026</a:t>
             </a:fld>
             <a:endParaRPr lang="en-US"/>
           </a:p>
@@ -5133,7 +5141,7 @@
             <a:fld id="{1D8BD707-D9CF-40AE-B4C6-C98DA3205C09}" type="datetimeFigureOut">
               <a:rPr lang="en-US" smtClean="0"/>
               <a:pPr/>
-              <a:t>6/15/2026</a:t>
+              <a:t>6/16/2026</a:t>
             </a:fld>
             <a:endParaRPr lang="en-US"/>
           </a:p>
@@ -5308,7 +5316,7 @@
             <a:fld id="{1D8BD707-D9CF-40AE-B4C6-C98DA3205C09}" type="datetimeFigureOut">
               <a:rPr lang="en-US" smtClean="0"/>
               <a:pPr/>
-              <a:t>6/15/2026</a:t>
+              <a:t>6/16/2026</a:t>
             </a:fld>
             <a:endParaRPr lang="en-US"/>
           </a:p>
@@ -5473,7 +5481,7 @@
             <a:fld id="{1D8BD707-D9CF-40AE-B4C6-C98DA3205C09}" type="datetimeFigureOut">
               <a:rPr lang="en-US" smtClean="0"/>
               <a:pPr/>
-              <a:t>6/15/2026</a:t>
+              <a:t>6/16/2026</a:t>
             </a:fld>
             <a:endParaRPr lang="en-US"/>
           </a:p>
@@ -5715,7 +5723,7 @@
             <a:fld id="{1D8BD707-D9CF-40AE-B4C6-C98DA3205C09}" type="datetimeFigureOut">
               <a:rPr lang="en-US" smtClean="0"/>
               <a:pPr/>
-              <a:t>6/15/2026</a:t>
+              <a:t>6/16/2026</a:t>
             </a:fld>
             <a:endParaRPr lang="en-US"/>
           </a:p>
@@ -5997,7 +6005,7 @@
             <a:fld id="{1D8BD707-D9CF-40AE-B4C6-C98DA3205C09}" type="datetimeFigureOut">
               <a:rPr lang="en-US" smtClean="0"/>
               <a:pPr/>
-              <a:t>6/15/2026</a:t>
+              <a:t>6/16/2026</a:t>
             </a:fld>
             <a:endParaRPr lang="en-US"/>
           </a:p>
@@ -6413,7 +6421,7 @@
             <a:fld id="{1D8BD707-D9CF-40AE-B4C6-C98DA3205C09}" type="datetimeFigureOut">
               <a:rPr lang="en-US" smtClean="0"/>
               <a:pPr/>
-              <a:t>6/15/2026</a:t>
+              <a:t>6/16/2026</a:t>
             </a:fld>
             <a:endParaRPr lang="en-US"/>
           </a:p>
@@ -6527,7 +6535,7 @@
             <a:fld id="{1D8BD707-D9CF-40AE-B4C6-C98DA3205C09}" type="datetimeFigureOut">
               <a:rPr lang="en-US" smtClean="0"/>
               <a:pPr/>
-              <a:t>6/15/2026</a:t>
+              <a:t>6/16/2026</a:t>
             </a:fld>
             <a:endParaRPr lang="en-US"/>
           </a:p>
@@ -6619,7 +6627,7 @@
             <a:fld id="{1D8BD707-D9CF-40AE-B4C6-C98DA3205C09}" type="datetimeFigureOut">
               <a:rPr lang="en-US" smtClean="0"/>
               <a:pPr/>
-              <a:t>6/15/2026</a:t>
+              <a:t>6/16/2026</a:t>
             </a:fld>
             <a:endParaRPr lang="en-US"/>
           </a:p>
@@ -6891,7 +6899,7 @@
             <a:fld id="{1D8BD707-D9CF-40AE-B4C6-C98DA3205C09}" type="datetimeFigureOut">
               <a:rPr lang="en-US" smtClean="0"/>
               <a:pPr/>
-              <a:t>6/15/2026</a:t>
+              <a:t>6/16/2026</a:t>
             </a:fld>
             <a:endParaRPr lang="en-US"/>
           </a:p>
@@ -7140,7 +7148,7 @@
             <a:fld id="{1D8BD707-D9CF-40AE-B4C6-C98DA3205C09}" type="datetimeFigureOut">
               <a:rPr lang="en-US" smtClean="0"/>
               <a:pPr/>
-              <a:t>6/15/2026</a:t>
+              <a:t>6/16/2026</a:t>
             </a:fld>
             <a:endParaRPr lang="en-US"/>
           </a:p>
@@ -7348,7 +7356,7 @@
             <a:fld id="{1D8BD707-D9CF-40AE-B4C6-C98DA3205C09}" type="datetimeFigureOut">
               <a:rPr lang="en-US" smtClean="0"/>
               <a:pPr/>
-              <a:t>6/15/2026</a:t>
+              <a:t>6/16/2026</a:t>
             </a:fld>
             <a:endParaRPr lang="en-US"/>
           </a:p>
@@ -9383,7 +9391,7 @@
         </p:nvSpPr>
         <p:spPr>
           <a:xfrm>
-            <a:off x="1827536" y="3519528"/>
+            <a:off x="5871824" y="3574517"/>
             <a:ext cx="2533572" cy="2511403"/>
           </a:xfrm>
           <a:custGeom>
@@ -9442,7 +9450,7 @@
         </p:nvGrpSpPr>
         <p:grpSpPr>
           <a:xfrm rot="2700000">
-            <a:off x="2482666" y="5017359"/>
+            <a:off x="6526954" y="5072348"/>
             <a:ext cx="337633" cy="337597"/>
             <a:chOff x="0" y="0"/>
             <a:chExt cx="88924" cy="88914"/>
@@ -9532,7 +9540,7 @@
         </p:nvSpPr>
         <p:spPr>
           <a:xfrm rot="868315">
-            <a:off x="2496273" y="4988627"/>
+            <a:off x="6540561" y="5043616"/>
             <a:ext cx="310421" cy="342147"/>
           </a:xfrm>
           <a:custGeom>
@@ -9591,7 +9599,7 @@
         </p:nvSpPr>
         <p:spPr>
           <a:xfrm>
-            <a:off x="5871824" y="3729169"/>
+            <a:off x="1778038" y="3876749"/>
             <a:ext cx="2728794" cy="2728794"/>
           </a:xfrm>
           <a:custGeom>
@@ -9762,8 +9770,8 @@
         </p:nvSpPr>
         <p:spPr>
           <a:xfrm>
-            <a:off x="5293102" y="6185120"/>
-            <a:ext cx="3828155" cy="1057275"/>
+            <a:off x="5450037" y="6584849"/>
+            <a:ext cx="3828155" cy="507831"/>
           </a:xfrm>
           <a:prstGeom prst="rect">
             <a:avLst/>
@@ -9781,16 +9789,16 @@
               </a:lnSpc>
             </a:pPr>
             <a:r>
-              <a:rPr lang="en-US" sz="3000" b="1">
+              <a:rPr lang="en-US" sz="3000" dirty="0">
                 <a:solidFill>
                   <a:srgbClr val="000000"/>
                 </a:solidFill>
-                <a:latin typeface="Bricolage Grotesque Bold"/>
+                <a:latin typeface="Bricolage Grotesque" panose="020B0604020202020204" charset="0"/>
                 <a:ea typeface="Bricolage Grotesque Bold"/>
                 <a:cs typeface="Bricolage Grotesque Bold"/>
                 <a:sym typeface="Bricolage Grotesque Bold"/>
               </a:rPr>
-              <a:t>ChatGPT group did NOT perform better</a:t>
+              <a:t>Average grade “C”</a:t>
             </a:r>
           </a:p>
         </p:txBody>
@@ -9844,7 +9852,72 @@
         </p:nvSpPr>
         <p:spPr>
           <a:xfrm>
-            <a:off x="1357202" y="6451819"/>
+            <a:off x="1262257" y="6301531"/>
+            <a:ext cx="3671999" cy="1046440"/>
+          </a:xfrm>
+          <a:prstGeom prst="rect">
+            <a:avLst/>
+          </a:prstGeom>
+        </p:spPr>
+        <p:txBody>
+          <a:bodyPr wrap="square" lIns="0" tIns="0" rIns="0" bIns="0" rtlCol="0" anchor="t">
+            <a:spAutoFit/>
+          </a:bodyPr>
+          <a:lstStyle/>
+          <a:p>
+            <a:pPr algn="ctr">
+              <a:lnSpc>
+                <a:spcPts val="4200"/>
+              </a:lnSpc>
+            </a:pPr>
+            <a:r>
+              <a:rPr lang="en-US" sz="3000" dirty="0">
+                <a:solidFill>
+                  <a:srgbClr val="000000"/>
+                </a:solidFill>
+                <a:latin typeface="Bricolage Grotesque" panose="020B0604020202020204" charset="0"/>
+                <a:ea typeface="Bricolage Grotesque Bold"/>
+                <a:cs typeface="Bricolage Grotesque Bold"/>
+                <a:sym typeface="Bricolage Grotesque Bold"/>
+              </a:rPr>
+              <a:t>ChatGPT group did </a:t>
+            </a:r>
+            <a:r>
+              <a:rPr lang="en-US" sz="3000" dirty="0">
+                <a:solidFill>
+                  <a:srgbClr val="000000"/>
+                </a:solidFill>
+                <a:latin typeface="Bricolage Grotesque Bold" panose="020B0604020202020204" charset="0"/>
+                <a:ea typeface="Bricolage Grotesque Bold"/>
+                <a:cs typeface="Bricolage Grotesque Bold"/>
+                <a:sym typeface="Bricolage Grotesque Bold"/>
+              </a:rPr>
+              <a:t>NOT</a:t>
+            </a:r>
+            <a:r>
+              <a:rPr lang="en-US" sz="3000" dirty="0">
+                <a:solidFill>
+                  <a:srgbClr val="000000"/>
+                </a:solidFill>
+                <a:latin typeface="Bricolage Grotesque" panose="020B0604020202020204" charset="0"/>
+                <a:ea typeface="Bricolage Grotesque Bold"/>
+                <a:cs typeface="Bricolage Grotesque Bold"/>
+                <a:sym typeface="Bricolage Grotesque Bold"/>
+              </a:rPr>
+              <a:t> perform better</a:t>
+            </a:r>
+          </a:p>
+        </p:txBody>
+      </p:sp>
+      <p:sp>
+        <p:nvSpPr>
+          <p:cNvPr id="17" name="TextBox 17"/>
+          <p:cNvSpPr txBox="1"/>
+          <p:nvPr/>
+        </p:nvSpPr>
+        <p:spPr>
+          <a:xfrm>
+            <a:off x="9651746" y="6562813"/>
             <a:ext cx="3456099" cy="523875"/>
           </a:xfrm>
           <a:prstGeom prst="rect">
@@ -9863,52 +9936,11 @@
               </a:lnSpc>
             </a:pPr>
             <a:r>
-              <a:rPr lang="en-US" sz="3000" b="1" dirty="0">
+              <a:rPr lang="en-US" sz="3000" dirty="0">
                 <a:solidFill>
                   <a:srgbClr val="000000"/>
                 </a:solidFill>
-                <a:latin typeface="Bricolage Grotesque Bold"/>
-                <a:ea typeface="Bricolage Grotesque Bold"/>
-                <a:cs typeface="Bricolage Grotesque Bold"/>
-                <a:sym typeface="Bricolage Grotesque Bold"/>
-              </a:rPr>
-              <a:t>Average grade “C”</a:t>
-            </a:r>
-          </a:p>
-        </p:txBody>
-      </p:sp>
-      <p:sp>
-        <p:nvSpPr>
-          <p:cNvPr id="17" name="TextBox 17"/>
-          <p:cNvSpPr txBox="1"/>
-          <p:nvPr/>
-        </p:nvSpPr>
-        <p:spPr>
-          <a:xfrm>
-            <a:off x="9738215" y="6451818"/>
-            <a:ext cx="3456099" cy="523875"/>
-          </a:xfrm>
-          <a:prstGeom prst="rect">
-            <a:avLst/>
-          </a:prstGeom>
-        </p:spPr>
-        <p:txBody>
-          <a:bodyPr lIns="0" tIns="0" rIns="0" bIns="0" rtlCol="0" anchor="t">
-            <a:spAutoFit/>
-          </a:bodyPr>
-          <a:lstStyle/>
-          <a:p>
-            <a:pPr algn="ctr">
-              <a:lnSpc>
-                <a:spcPts val="4200"/>
-              </a:lnSpc>
-            </a:pPr>
-            <a:r>
-              <a:rPr lang="en-US" sz="3000" b="1" dirty="0">
-                <a:solidFill>
-                  <a:srgbClr val="000000"/>
-                </a:solidFill>
-                <a:latin typeface="Bricolage Grotesque Bold"/>
+                <a:latin typeface="Bricolage Grotesque" panose="020B0604020202020204" charset="0"/>
                 <a:ea typeface="Bricolage Grotesque Bold"/>
                 <a:cs typeface="Bricolage Grotesque Bold"/>
                 <a:sym typeface="Bricolage Grotesque Bold"/>
@@ -9926,7 +9958,7 @@
         </p:nvSpPr>
         <p:spPr>
           <a:xfrm>
-            <a:off x="13408628" y="6185120"/>
+            <a:off x="13387846" y="6310126"/>
             <a:ext cx="4200211" cy="1057275"/>
           </a:xfrm>
           <a:prstGeom prst="rect">
@@ -9945,11 +9977,11 @@
               </a:lnSpc>
             </a:pPr>
             <a:r>
-              <a:rPr lang="en-US" sz="3000" b="1" dirty="0">
+              <a:rPr lang="en-US" sz="3000" dirty="0">
                 <a:solidFill>
                   <a:srgbClr val="000000"/>
                 </a:solidFill>
-                <a:latin typeface="Bricolage Grotesque Bold"/>
+                <a:latin typeface="Bricolage Grotesque" panose="020B0604020202020204" charset="0"/>
                 <a:ea typeface="Bricolage Grotesque Bold"/>
                 <a:cs typeface="Bricolage Grotesque Bold"/>
                 <a:sym typeface="Bricolage Grotesque Bold"/>
@@ -10528,7 +10560,7 @@
               </a:lnSpc>
             </a:pPr>
             <a:r>
-              <a:rPr lang="en-US" sz="2800">
+              <a:rPr lang="en-US" sz="2800" dirty="0">
                 <a:solidFill>
                   <a:srgbClr val="000000"/>
                 </a:solidFill>

</xml_diff>

<commit_message>
adapted website with pictures and context
</commit_message>
<xml_diff>
--- a/Lightning Talk Christina.pptx
+++ b/Lightning Talk Christina.pptx
@@ -170,12 +170,12 @@
   <pc:docChgLst>
     <pc:chgData name="Christina Knes" userId="7e9737a164333dbd" providerId="LiveId" clId="{72053980-4108-4AED-A5B7-3290F7F82C69}"/>
     <pc:docChg chg="undo custSel modSld">
-      <pc:chgData name="Christina Knes" userId="7e9737a164333dbd" providerId="LiveId" clId="{72053980-4108-4AED-A5B7-3290F7F82C69}" dt="2026-06-16T14:34:57.367" v="313" actId="113"/>
+      <pc:chgData name="Christina Knes" userId="7e9737a164333dbd" providerId="LiveId" clId="{72053980-4108-4AED-A5B7-3290F7F82C69}" dt="2026-06-23T13:02:07.431" v="322" actId="20577"/>
       <pc:docMkLst>
         <pc:docMk/>
       </pc:docMkLst>
       <pc:sldChg chg="modSp mod modAnim modNotesTx">
-        <pc:chgData name="Christina Knes" userId="7e9737a164333dbd" providerId="LiveId" clId="{72053980-4108-4AED-A5B7-3290F7F82C69}" dt="2026-06-15T15:54:25.112" v="261" actId="20577"/>
+        <pc:chgData name="Christina Knes" userId="7e9737a164333dbd" providerId="LiveId" clId="{72053980-4108-4AED-A5B7-3290F7F82C69}" dt="2026-06-23T13:01:38.267" v="314" actId="20577"/>
         <pc:sldMkLst>
           <pc:docMk/>
           <pc:sldMk cId="0" sldId="256"/>
@@ -270,7 +270,7 @@
         </pc:spChg>
       </pc:sldChg>
       <pc:sldChg chg="modSp mod addAnim delAnim modAnim modNotesTx">
-        <pc:chgData name="Christina Knes" userId="7e9737a164333dbd" providerId="LiveId" clId="{72053980-4108-4AED-A5B7-3290F7F82C69}" dt="2026-06-15T15:40:53.228" v="255" actId="20577"/>
+        <pc:chgData name="Christina Knes" userId="7e9737a164333dbd" providerId="LiveId" clId="{72053980-4108-4AED-A5B7-3290F7F82C69}" dt="2026-06-23T13:01:42.612" v="317" actId="20577"/>
         <pc:sldMkLst>
           <pc:docMk/>
           <pc:sldMk cId="0" sldId="257"/>
@@ -309,7 +309,7 @@
         </pc:spChg>
       </pc:sldChg>
       <pc:sldChg chg="delSp modSp mod addAnim delAnim modAnim modNotesTx">
-        <pc:chgData name="Christina Knes" userId="7e9737a164333dbd" providerId="LiveId" clId="{72053980-4108-4AED-A5B7-3290F7F82C69}" dt="2026-06-16T14:34:57.367" v="313" actId="113"/>
+        <pc:chgData name="Christina Knes" userId="7e9737a164333dbd" providerId="LiveId" clId="{72053980-4108-4AED-A5B7-3290F7F82C69}" dt="2026-06-23T13:01:50.215" v="318" actId="20577"/>
         <pc:sldMkLst>
           <pc:docMk/>
           <pc:sldMk cId="0" sldId="258"/>
@@ -404,14 +404,14 @@
         </pc:grpChg>
       </pc:sldChg>
       <pc:sldChg chg="modNotesTx">
-        <pc:chgData name="Christina Knes" userId="7e9737a164333dbd" providerId="LiveId" clId="{72053980-4108-4AED-A5B7-3290F7F82C69}" dt="2026-06-15T15:54:41.833" v="263" actId="20577"/>
+        <pc:chgData name="Christina Knes" userId="7e9737a164333dbd" providerId="LiveId" clId="{72053980-4108-4AED-A5B7-3290F7F82C69}" dt="2026-06-23T13:01:53.179" v="319" actId="20577"/>
         <pc:sldMkLst>
           <pc:docMk/>
           <pc:sldMk cId="0" sldId="259"/>
         </pc:sldMkLst>
       </pc:sldChg>
       <pc:sldChg chg="modSp mod modAnim modNotesTx">
-        <pc:chgData name="Christina Knes" userId="7e9737a164333dbd" providerId="LiveId" clId="{72053980-4108-4AED-A5B7-3290F7F82C69}" dt="2026-06-15T15:55:01.062" v="266" actId="20577"/>
+        <pc:chgData name="Christina Knes" userId="7e9737a164333dbd" providerId="LiveId" clId="{72053980-4108-4AED-A5B7-3290F7F82C69}" dt="2026-06-23T13:01:57.362" v="320" actId="20577"/>
         <pc:sldMkLst>
           <pc:docMk/>
           <pc:sldMk cId="0" sldId="260"/>
@@ -458,7 +458,7 @@
         </pc:spChg>
       </pc:sldChg>
       <pc:sldChg chg="modSp mod modAnim modNotesTx">
-        <pc:chgData name="Christina Knes" userId="7e9737a164333dbd" providerId="LiveId" clId="{72053980-4108-4AED-A5B7-3290F7F82C69}" dt="2026-06-15T15:55:08.701" v="268" actId="20577"/>
+        <pc:chgData name="Christina Knes" userId="7e9737a164333dbd" providerId="LiveId" clId="{72053980-4108-4AED-A5B7-3290F7F82C69}" dt="2026-06-23T13:02:03.430" v="321" actId="20577"/>
         <pc:sldMkLst>
           <pc:docMk/>
           <pc:sldMk cId="0" sldId="261"/>
@@ -481,7 +481,7 @@
         </pc:spChg>
       </pc:sldChg>
       <pc:sldChg chg="addSp modSp mod modNotesTx">
-        <pc:chgData name="Christina Knes" userId="7e9737a164333dbd" providerId="LiveId" clId="{72053980-4108-4AED-A5B7-3290F7F82C69}" dt="2026-06-15T15:55:17.928" v="272" actId="20577"/>
+        <pc:chgData name="Christina Knes" userId="7e9737a164333dbd" providerId="LiveId" clId="{72053980-4108-4AED-A5B7-3290F7F82C69}" dt="2026-06-23T13:02:07.431" v="322" actId="20577"/>
         <pc:sldMkLst>
           <pc:docMk/>
           <pc:sldMk cId="0" sldId="262"/>
@@ -654,7 +654,7 @@
           <a:p>
             <a:fld id="{7AAA80C1-B10E-441C-98F7-90D0E5C9B104}" type="datetimeFigureOut">
               <a:rPr lang="de-AT" smtClean="0"/>
-              <a:t>16.06.2026</a:t>
+              <a:t>23.06.2026</a:t>
             </a:fld>
             <a:endParaRPr lang="de-AT"/>
           </a:p>
@@ -966,300 +966,6 @@
           <a:bodyPr/>
           <a:lstStyle/>
           <a:p>
-            <a:r>
-              <a:rPr lang="de-AT" dirty="0"/>
-              <a:t>Hello </a:t>
-            </a:r>
-            <a:r>
-              <a:rPr lang="de-AT" dirty="0" err="1"/>
-              <a:t>everyone</a:t>
-            </a:r>
-            <a:r>
-              <a:rPr lang="de-AT" dirty="0"/>
-              <a:t>,</a:t>
-            </a:r>
-          </a:p>
-          <a:p>
-            <a:endParaRPr lang="de-AT" dirty="0"/>
-          </a:p>
-          <a:p>
-            <a:r>
-              <a:rPr lang="de-AT" dirty="0" err="1"/>
-              <a:t>today</a:t>
-            </a:r>
-            <a:r>
-              <a:rPr lang="de-AT" dirty="0"/>
-              <a:t> I will </a:t>
-            </a:r>
-            <a:r>
-              <a:rPr lang="de-AT" dirty="0" err="1"/>
-              <a:t>present</a:t>
-            </a:r>
-            <a:r>
-              <a:rPr lang="de-AT" dirty="0"/>
-              <a:t> </a:t>
-            </a:r>
-            <a:r>
-              <a:rPr lang="de-AT" dirty="0" err="1"/>
-              <a:t>the</a:t>
-            </a:r>
-            <a:r>
-              <a:rPr lang="de-AT" dirty="0"/>
-              <a:t> </a:t>
-            </a:r>
-            <a:r>
-              <a:rPr lang="de-AT" dirty="0" err="1"/>
-              <a:t>study</a:t>
-            </a:r>
-            <a:r>
-              <a:rPr lang="de-AT" dirty="0"/>
-              <a:t> </a:t>
-            </a:r>
-            <a:r>
-              <a:rPr lang="de-AT" i="1" dirty="0"/>
-              <a:t>“ChatGPT-3.5 </a:t>
-            </a:r>
-            <a:r>
-              <a:rPr lang="de-AT" i="1" dirty="0" err="1"/>
-              <a:t>as</a:t>
-            </a:r>
-            <a:r>
-              <a:rPr lang="de-AT" i="1" dirty="0"/>
-              <a:t> Writing Assistance in </a:t>
-            </a:r>
-            <a:r>
-              <a:rPr lang="de-AT" i="1" dirty="0" err="1"/>
-              <a:t>Students</a:t>
-            </a:r>
-            <a:r>
-              <a:rPr lang="de-AT" i="1" dirty="0"/>
-              <a:t>’ Essays”</a:t>
-            </a:r>
-            <a:r>
-              <a:rPr lang="de-AT" dirty="0"/>
-              <a:t> </a:t>
-            </a:r>
-            <a:r>
-              <a:rPr lang="de-AT" dirty="0" err="1"/>
-              <a:t>by</a:t>
-            </a:r>
-            <a:r>
-              <a:rPr lang="de-AT" dirty="0"/>
-              <a:t> Bašić and </a:t>
-            </a:r>
-            <a:r>
-              <a:rPr lang="de-AT" dirty="0" err="1"/>
-              <a:t>colleagues</a:t>
-            </a:r>
-            <a:r>
-              <a:rPr lang="de-AT" dirty="0"/>
-              <a:t>, </a:t>
-            </a:r>
-            <a:r>
-              <a:rPr lang="de-AT" dirty="0" err="1"/>
-              <a:t>published</a:t>
-            </a:r>
-            <a:r>
-              <a:rPr lang="de-AT" dirty="0"/>
-              <a:t> in </a:t>
-            </a:r>
-            <a:r>
-              <a:rPr lang="de-AT" dirty="0" err="1"/>
-              <a:t>the</a:t>
-            </a:r>
-            <a:r>
-              <a:rPr lang="de-AT" dirty="0"/>
-              <a:t> </a:t>
-            </a:r>
-            <a:r>
-              <a:rPr lang="de-AT" dirty="0" err="1"/>
-              <a:t>year</a:t>
-            </a:r>
-            <a:r>
-              <a:rPr lang="de-AT" dirty="0"/>
-              <a:t> 2023, so </a:t>
-            </a:r>
-            <a:r>
-              <a:rPr lang="de-AT" dirty="0" err="1"/>
-              <a:t>we</a:t>
-            </a:r>
-            <a:r>
-              <a:rPr lang="de-AT" dirty="0"/>
-              <a:t> </a:t>
-            </a:r>
-            <a:r>
-              <a:rPr lang="de-AT" dirty="0" err="1"/>
-              <a:t>can</a:t>
-            </a:r>
-            <a:r>
-              <a:rPr lang="de-AT" dirty="0"/>
-              <a:t> </a:t>
-            </a:r>
-            <a:r>
-              <a:rPr lang="de-AT" dirty="0" err="1"/>
-              <a:t>say</a:t>
-            </a:r>
-            <a:r>
-              <a:rPr lang="de-AT" dirty="0"/>
-              <a:t> </a:t>
-            </a:r>
-            <a:r>
-              <a:rPr lang="de-AT" dirty="0" err="1"/>
-              <a:t>that</a:t>
-            </a:r>
-            <a:r>
-              <a:rPr lang="de-AT" dirty="0"/>
-              <a:t> </a:t>
-            </a:r>
-            <a:r>
-              <a:rPr lang="de-AT" dirty="0" err="1"/>
-              <a:t>it</a:t>
-            </a:r>
-            <a:r>
-              <a:rPr lang="de-AT" dirty="0"/>
-              <a:t> </a:t>
-            </a:r>
-            <a:r>
-              <a:rPr lang="de-AT" dirty="0" err="1"/>
-              <a:t>is</a:t>
-            </a:r>
-            <a:r>
-              <a:rPr lang="de-AT" dirty="0"/>
-              <a:t> </a:t>
-            </a:r>
-            <a:r>
-              <a:rPr lang="de-AT" dirty="0" err="1"/>
-              <a:t>one</a:t>
-            </a:r>
-            <a:r>
-              <a:rPr lang="de-AT" dirty="0"/>
-              <a:t> </a:t>
-            </a:r>
-            <a:r>
-              <a:rPr lang="de-AT" dirty="0" err="1"/>
-              <a:t>of</a:t>
-            </a:r>
-            <a:r>
-              <a:rPr lang="de-AT" dirty="0"/>
-              <a:t> </a:t>
-            </a:r>
-            <a:r>
-              <a:rPr lang="de-AT" dirty="0" err="1"/>
-              <a:t>the</a:t>
-            </a:r>
-            <a:r>
-              <a:rPr lang="de-AT" dirty="0"/>
-              <a:t> </a:t>
-            </a:r>
-            <a:r>
-              <a:rPr lang="de-AT" dirty="0" err="1"/>
-              <a:t>earlier</a:t>
-            </a:r>
-            <a:r>
-              <a:rPr lang="de-AT" dirty="0"/>
-              <a:t> </a:t>
-            </a:r>
-            <a:r>
-              <a:rPr lang="de-AT" dirty="0" err="1"/>
-              <a:t>studies</a:t>
-            </a:r>
-            <a:r>
-              <a:rPr lang="de-AT" dirty="0"/>
-              <a:t> on ChatGPT.</a:t>
-            </a:r>
-          </a:p>
-          <a:p>
-            <a:endParaRPr lang="de-AT" dirty="0"/>
-          </a:p>
-          <a:p>
-            <a:r>
-              <a:rPr lang="de-AT" dirty="0"/>
-              <a:t>The </a:t>
-            </a:r>
-            <a:r>
-              <a:rPr lang="de-AT" dirty="0" err="1"/>
-              <a:t>study</a:t>
-            </a:r>
-            <a:r>
-              <a:rPr lang="de-AT" dirty="0"/>
-              <a:t> </a:t>
-            </a:r>
-            <a:r>
-              <a:rPr lang="de-AT" dirty="0" err="1"/>
-              <a:t>investigates</a:t>
-            </a:r>
-            <a:r>
-              <a:rPr lang="de-AT" dirty="0"/>
-              <a:t> an </a:t>
-            </a:r>
-            <a:r>
-              <a:rPr lang="de-AT" dirty="0" err="1"/>
-              <a:t>important</a:t>
-            </a:r>
-            <a:r>
-              <a:rPr lang="de-AT" dirty="0"/>
-              <a:t> </a:t>
-            </a:r>
-            <a:r>
-              <a:rPr lang="de-AT" dirty="0" err="1"/>
-              <a:t>question</a:t>
-            </a:r>
-            <a:r>
-              <a:rPr lang="de-AT" dirty="0"/>
-              <a:t>:</a:t>
-            </a:r>
-          </a:p>
-          <a:p>
-            <a:endParaRPr lang="de-AT" dirty="0"/>
-          </a:p>
-          <a:p>
-            <a:r>
-              <a:rPr lang="de-AT" b="1" dirty="0"/>
-              <a:t>Does ChatGPT </a:t>
-            </a:r>
-            <a:r>
-              <a:rPr lang="de-AT" b="1" dirty="0" err="1"/>
-              <a:t>actually</a:t>
-            </a:r>
-            <a:r>
-              <a:rPr lang="de-AT" b="1" dirty="0"/>
-              <a:t> </a:t>
-            </a:r>
-            <a:r>
-              <a:rPr lang="de-AT" b="1" dirty="0" err="1"/>
-              <a:t>improve</a:t>
-            </a:r>
-            <a:r>
-              <a:rPr lang="de-AT" b="1" dirty="0"/>
-              <a:t> </a:t>
-            </a:r>
-            <a:r>
-              <a:rPr lang="de-AT" b="1" dirty="0" err="1"/>
-              <a:t>students</a:t>
-            </a:r>
-            <a:r>
-              <a:rPr lang="de-AT" b="1" dirty="0"/>
-              <a:t>’ essay-</a:t>
-            </a:r>
-            <a:r>
-              <a:rPr lang="de-AT" b="1" dirty="0" err="1"/>
-              <a:t>writing</a:t>
-            </a:r>
-            <a:r>
-              <a:rPr lang="de-AT" b="1" dirty="0"/>
-              <a:t> </a:t>
-            </a:r>
-            <a:r>
-              <a:rPr lang="de-AT" b="1" dirty="0" err="1"/>
-              <a:t>performance</a:t>
-            </a:r>
-            <a:r>
-              <a:rPr lang="de-AT" b="1" dirty="0"/>
-              <a:t>?</a:t>
-            </a:r>
-            <a:endParaRPr lang="de-AT" dirty="0"/>
-          </a:p>
-          <a:p>
             <a:endParaRPr lang="de-AT" dirty="0"/>
           </a:p>
         </p:txBody>
@@ -1344,560 +1050,6 @@
           <a:bodyPr/>
           <a:lstStyle/>
           <a:p>
-            <a:r>
-              <a:rPr lang="de-AT" dirty="0" err="1"/>
-              <a:t>To</a:t>
-            </a:r>
-            <a:r>
-              <a:rPr lang="de-AT" dirty="0"/>
-              <a:t> </a:t>
-            </a:r>
-            <a:r>
-              <a:rPr lang="de-AT" dirty="0" err="1"/>
-              <a:t>answer</a:t>
-            </a:r>
-            <a:r>
-              <a:rPr lang="de-AT" dirty="0"/>
-              <a:t> </a:t>
-            </a:r>
-            <a:r>
-              <a:rPr lang="de-AT" dirty="0" err="1"/>
-              <a:t>this</a:t>
-            </a:r>
-            <a:r>
-              <a:rPr lang="de-AT" dirty="0"/>
-              <a:t> </a:t>
-            </a:r>
-            <a:r>
-              <a:rPr lang="de-AT" dirty="0" err="1"/>
-              <a:t>question</a:t>
-            </a:r>
-            <a:r>
-              <a:rPr lang="de-AT" dirty="0"/>
-              <a:t>, </a:t>
-            </a:r>
-            <a:r>
-              <a:rPr lang="de-AT" dirty="0" err="1"/>
-              <a:t>the</a:t>
-            </a:r>
-            <a:r>
-              <a:rPr lang="de-AT" dirty="0"/>
-              <a:t> </a:t>
-            </a:r>
-            <a:r>
-              <a:rPr lang="de-AT" dirty="0" err="1"/>
-              <a:t>researchers</a:t>
-            </a:r>
-            <a:r>
-              <a:rPr lang="de-AT" dirty="0"/>
-              <a:t> </a:t>
-            </a:r>
-            <a:r>
-              <a:rPr lang="de-AT" dirty="0" err="1"/>
-              <a:t>conducted</a:t>
-            </a:r>
-            <a:r>
-              <a:rPr lang="de-AT" dirty="0"/>
-              <a:t> an </a:t>
-            </a:r>
-            <a:r>
-              <a:rPr lang="de-AT" dirty="0" err="1"/>
-              <a:t>experiment</a:t>
-            </a:r>
-            <a:r>
-              <a:rPr lang="de-AT" dirty="0"/>
-              <a:t> </a:t>
-            </a:r>
-            <a:r>
-              <a:rPr lang="de-AT" dirty="0" err="1"/>
-              <a:t>with</a:t>
-            </a:r>
-            <a:r>
-              <a:rPr lang="de-AT" dirty="0"/>
-              <a:t> </a:t>
-            </a:r>
-            <a:r>
-              <a:rPr lang="de-AT" b="1" dirty="0"/>
-              <a:t>18 </a:t>
-            </a:r>
-            <a:r>
-              <a:rPr lang="de-AT" b="1" dirty="0" err="1"/>
-              <a:t>master’s</a:t>
-            </a:r>
-            <a:r>
-              <a:rPr lang="de-AT" b="1" dirty="0"/>
-              <a:t> </a:t>
-            </a:r>
-            <a:r>
-              <a:rPr lang="de-AT" b="1" dirty="0" err="1"/>
-              <a:t>students</a:t>
-            </a:r>
-            <a:r>
-              <a:rPr lang="de-AT" dirty="0"/>
-              <a:t> </a:t>
-            </a:r>
-            <a:r>
-              <a:rPr lang="de-AT" dirty="0" err="1"/>
-              <a:t>from</a:t>
-            </a:r>
-            <a:r>
-              <a:rPr lang="de-AT" dirty="0"/>
-              <a:t> </a:t>
-            </a:r>
-            <a:r>
-              <a:rPr lang="de-AT" dirty="0" err="1"/>
-              <a:t>the</a:t>
-            </a:r>
-            <a:r>
-              <a:rPr lang="de-AT" dirty="0"/>
-              <a:t> University </a:t>
-            </a:r>
-            <a:r>
-              <a:rPr lang="de-AT" dirty="0" err="1"/>
-              <a:t>of</a:t>
-            </a:r>
-            <a:r>
-              <a:rPr lang="de-AT" dirty="0"/>
-              <a:t> Split.</a:t>
-            </a:r>
-          </a:p>
-          <a:p>
-            <a:endParaRPr lang="de-AT" dirty="0"/>
-          </a:p>
-          <a:p>
-            <a:r>
-              <a:rPr lang="de-AT" dirty="0"/>
-              <a:t>The </a:t>
-            </a:r>
-            <a:r>
-              <a:rPr lang="de-AT" dirty="0" err="1"/>
-              <a:t>students</a:t>
-            </a:r>
-            <a:r>
-              <a:rPr lang="de-AT" dirty="0"/>
-              <a:t> </a:t>
-            </a:r>
-            <a:r>
-              <a:rPr lang="de-AT" dirty="0" err="1"/>
-              <a:t>were</a:t>
-            </a:r>
-            <a:r>
-              <a:rPr lang="de-AT" dirty="0"/>
-              <a:t> </a:t>
-            </a:r>
-            <a:r>
-              <a:rPr lang="de-AT" dirty="0" err="1"/>
-              <a:t>divided</a:t>
-            </a:r>
-            <a:r>
-              <a:rPr lang="de-AT" dirty="0"/>
-              <a:t> </a:t>
-            </a:r>
-            <a:r>
-              <a:rPr lang="de-AT" dirty="0" err="1"/>
-              <a:t>into</a:t>
-            </a:r>
-            <a:r>
-              <a:rPr lang="de-AT" dirty="0"/>
-              <a:t> </a:t>
-            </a:r>
-            <a:r>
-              <a:rPr lang="de-AT" dirty="0" err="1"/>
-              <a:t>two</a:t>
-            </a:r>
-            <a:r>
-              <a:rPr lang="de-AT" dirty="0"/>
-              <a:t> </a:t>
-            </a:r>
-            <a:r>
-              <a:rPr lang="de-AT" dirty="0" err="1"/>
-              <a:t>groups</a:t>
-            </a:r>
-            <a:r>
-              <a:rPr lang="de-AT" dirty="0"/>
-              <a:t>:</a:t>
-            </a:r>
-          </a:p>
-          <a:p>
-            <a:endParaRPr lang="de-AT" dirty="0"/>
-          </a:p>
-          <a:p>
-            <a:r>
-              <a:rPr lang="de-AT" dirty="0"/>
-              <a:t>A </a:t>
-            </a:r>
-            <a:r>
-              <a:rPr lang="de-AT" dirty="0" err="1"/>
-              <a:t>control</a:t>
-            </a:r>
-            <a:r>
-              <a:rPr lang="de-AT" dirty="0"/>
-              <a:t> </a:t>
-            </a:r>
-            <a:r>
-              <a:rPr lang="de-AT" dirty="0" err="1"/>
-              <a:t>group</a:t>
-            </a:r>
-            <a:r>
-              <a:rPr lang="de-AT" dirty="0"/>
-              <a:t> </a:t>
-            </a:r>
-            <a:r>
-              <a:rPr lang="de-AT" dirty="0" err="1"/>
-              <a:t>that</a:t>
-            </a:r>
-            <a:r>
-              <a:rPr lang="de-AT" dirty="0"/>
-              <a:t> </a:t>
-            </a:r>
-            <a:r>
-              <a:rPr lang="de-AT" dirty="0" err="1"/>
-              <a:t>wrote</a:t>
-            </a:r>
-            <a:r>
-              <a:rPr lang="de-AT" dirty="0"/>
-              <a:t> </a:t>
-            </a:r>
-            <a:r>
-              <a:rPr lang="de-AT" dirty="0" err="1"/>
-              <a:t>essays</a:t>
-            </a:r>
-            <a:r>
-              <a:rPr lang="de-AT" dirty="0"/>
-              <a:t> in </a:t>
-            </a:r>
-            <a:r>
-              <a:rPr lang="de-AT" dirty="0" err="1"/>
-              <a:t>the</a:t>
-            </a:r>
-            <a:r>
-              <a:rPr lang="de-AT" dirty="0"/>
-              <a:t> traditional </a:t>
-            </a:r>
-            <a:r>
-              <a:rPr lang="de-AT" dirty="0" err="1"/>
-              <a:t>way</a:t>
-            </a:r>
-            <a:r>
-              <a:rPr lang="de-AT" dirty="0"/>
-              <a:t>. </a:t>
-            </a:r>
-          </a:p>
-          <a:p>
-            <a:r>
-              <a:rPr lang="de-AT" dirty="0"/>
-              <a:t>An experimental </a:t>
-            </a:r>
-            <a:r>
-              <a:rPr lang="de-AT" dirty="0" err="1"/>
-              <a:t>group</a:t>
-            </a:r>
-            <a:r>
-              <a:rPr lang="de-AT" dirty="0"/>
-              <a:t> </a:t>
-            </a:r>
-            <a:r>
-              <a:rPr lang="de-AT" dirty="0" err="1"/>
-              <a:t>that</a:t>
-            </a:r>
-            <a:r>
-              <a:rPr lang="de-AT" dirty="0"/>
-              <a:t> was </a:t>
-            </a:r>
-            <a:r>
-              <a:rPr lang="de-AT" dirty="0" err="1"/>
-              <a:t>allowed</a:t>
-            </a:r>
-            <a:r>
-              <a:rPr lang="de-AT" dirty="0"/>
-              <a:t> </a:t>
-            </a:r>
-            <a:r>
-              <a:rPr lang="de-AT" dirty="0" err="1"/>
-              <a:t>to</a:t>
-            </a:r>
-            <a:r>
-              <a:rPr lang="de-AT" dirty="0"/>
-              <a:t> </a:t>
-            </a:r>
-            <a:r>
-              <a:rPr lang="de-AT" dirty="0" err="1"/>
-              <a:t>use</a:t>
-            </a:r>
-            <a:r>
-              <a:rPr lang="de-AT" dirty="0"/>
-              <a:t> ChatGPT </a:t>
-            </a:r>
-            <a:r>
-              <a:rPr lang="de-AT" dirty="0" err="1"/>
-              <a:t>as</a:t>
-            </a:r>
-            <a:r>
-              <a:rPr lang="de-AT" dirty="0"/>
-              <a:t> a </a:t>
-            </a:r>
-            <a:r>
-              <a:rPr lang="de-AT" dirty="0" err="1"/>
-              <a:t>writing</a:t>
-            </a:r>
-            <a:r>
-              <a:rPr lang="de-AT" dirty="0"/>
-              <a:t> </a:t>
-            </a:r>
-            <a:r>
-              <a:rPr lang="de-AT" dirty="0" err="1"/>
-              <a:t>assistant</a:t>
-            </a:r>
-            <a:r>
-              <a:rPr lang="de-AT" dirty="0"/>
-              <a:t>. </a:t>
-            </a:r>
-          </a:p>
-          <a:p>
-            <a:endParaRPr lang="de-AT" dirty="0"/>
-          </a:p>
-          <a:p>
-            <a:r>
-              <a:rPr lang="de-AT" dirty="0"/>
-              <a:t>All </a:t>
-            </a:r>
-            <a:r>
-              <a:rPr lang="de-AT" dirty="0" err="1"/>
-              <a:t>students</a:t>
-            </a:r>
-            <a:r>
-              <a:rPr lang="de-AT" dirty="0"/>
-              <a:t> </a:t>
-            </a:r>
-            <a:r>
-              <a:rPr lang="de-AT" dirty="0" err="1"/>
-              <a:t>wrote</a:t>
-            </a:r>
-            <a:r>
-              <a:rPr lang="de-AT" dirty="0"/>
-              <a:t> an </a:t>
-            </a:r>
-            <a:r>
-              <a:rPr lang="de-AT" dirty="0" err="1"/>
-              <a:t>essay</a:t>
-            </a:r>
-            <a:r>
-              <a:rPr lang="de-AT" dirty="0"/>
-              <a:t> on </a:t>
-            </a:r>
-            <a:r>
-              <a:rPr lang="de-AT" dirty="0" err="1"/>
-              <a:t>the</a:t>
-            </a:r>
-            <a:r>
-              <a:rPr lang="de-AT" dirty="0"/>
-              <a:t> </a:t>
-            </a:r>
-            <a:r>
-              <a:rPr lang="de-AT" dirty="0" err="1"/>
-              <a:t>topic</a:t>
-            </a:r>
-            <a:r>
-              <a:rPr lang="de-AT" dirty="0"/>
-              <a:t>:</a:t>
-            </a:r>
-          </a:p>
-          <a:p>
-            <a:r>
-              <a:rPr lang="de-AT" b="1" dirty="0"/>
-              <a:t>“Advantages and </a:t>
-            </a:r>
-            <a:r>
-              <a:rPr lang="de-AT" b="1" dirty="0" err="1"/>
-              <a:t>disadvantages</a:t>
-            </a:r>
-            <a:r>
-              <a:rPr lang="de-AT" b="1" dirty="0"/>
-              <a:t> </a:t>
-            </a:r>
-            <a:r>
-              <a:rPr lang="de-AT" b="1" dirty="0" err="1"/>
-              <a:t>of</a:t>
-            </a:r>
-            <a:r>
-              <a:rPr lang="de-AT" b="1" dirty="0"/>
-              <a:t> </a:t>
-            </a:r>
-            <a:r>
-              <a:rPr lang="de-AT" b="1" dirty="0" err="1"/>
-              <a:t>biometric</a:t>
-            </a:r>
-            <a:r>
-              <a:rPr lang="de-AT" b="1" dirty="0"/>
-              <a:t> </a:t>
-            </a:r>
-            <a:r>
-              <a:rPr lang="de-AT" b="1" dirty="0" err="1"/>
-              <a:t>identification</a:t>
-            </a:r>
-            <a:r>
-              <a:rPr lang="de-AT" b="1" dirty="0"/>
-              <a:t> in </a:t>
-            </a:r>
-            <a:r>
-              <a:rPr lang="de-AT" b="1" dirty="0" err="1"/>
-              <a:t>forensic</a:t>
-            </a:r>
-            <a:r>
-              <a:rPr lang="de-AT" b="1" dirty="0"/>
-              <a:t> </a:t>
-            </a:r>
-            <a:r>
-              <a:rPr lang="de-AT" b="1" dirty="0" err="1"/>
-              <a:t>sciences</a:t>
-            </a:r>
-            <a:r>
-              <a:rPr lang="de-AT" b="1" dirty="0"/>
-              <a:t>.”</a:t>
-            </a:r>
-          </a:p>
-          <a:p>
-            <a:endParaRPr lang="de-AT" dirty="0"/>
-          </a:p>
-          <a:p>
-            <a:r>
-              <a:rPr lang="de-AT" dirty="0"/>
-              <a:t>The </a:t>
-            </a:r>
-            <a:r>
-              <a:rPr lang="de-AT" dirty="0" err="1"/>
-              <a:t>researchers</a:t>
-            </a:r>
-            <a:r>
-              <a:rPr lang="de-AT" dirty="0"/>
-              <a:t> </a:t>
-            </a:r>
-            <a:r>
-              <a:rPr lang="de-AT" dirty="0" err="1"/>
-              <a:t>then</a:t>
-            </a:r>
-            <a:r>
-              <a:rPr lang="de-AT" dirty="0"/>
-              <a:t> </a:t>
-            </a:r>
-            <a:r>
-              <a:rPr lang="de-AT" dirty="0" err="1"/>
-              <a:t>evaluated</a:t>
-            </a:r>
-            <a:r>
-              <a:rPr lang="de-AT" dirty="0"/>
-              <a:t>:</a:t>
-            </a:r>
-          </a:p>
-          <a:p>
-            <a:r>
-              <a:rPr lang="de-AT" dirty="0" err="1"/>
-              <a:t>essay</a:t>
-            </a:r>
-            <a:r>
-              <a:rPr lang="de-AT" dirty="0"/>
-              <a:t> </a:t>
-            </a:r>
-            <a:r>
-              <a:rPr lang="de-AT" dirty="0" err="1"/>
-              <a:t>quality</a:t>
-            </a:r>
-            <a:r>
-              <a:rPr lang="de-AT" dirty="0"/>
-              <a:t>, </a:t>
-            </a:r>
-          </a:p>
-          <a:p>
-            <a:r>
-              <a:rPr lang="de-AT" dirty="0" err="1"/>
-              <a:t>writing</a:t>
-            </a:r>
-            <a:r>
-              <a:rPr lang="de-AT" dirty="0"/>
-              <a:t> </a:t>
-            </a:r>
-            <a:r>
-              <a:rPr lang="de-AT" dirty="0" err="1"/>
-              <a:t>duration</a:t>
-            </a:r>
-            <a:r>
-              <a:rPr lang="de-AT" dirty="0"/>
-              <a:t>, </a:t>
-            </a:r>
-          </a:p>
-          <a:p>
-            <a:r>
-              <a:rPr lang="de-AT" dirty="0" err="1"/>
-              <a:t>text</a:t>
-            </a:r>
-            <a:r>
-              <a:rPr lang="de-AT" dirty="0"/>
-              <a:t> </a:t>
-            </a:r>
-            <a:r>
-              <a:rPr lang="de-AT" dirty="0" err="1"/>
-              <a:t>authenticity</a:t>
-            </a:r>
-            <a:r>
-              <a:rPr lang="de-AT" dirty="0"/>
-              <a:t>, </a:t>
-            </a:r>
-          </a:p>
-          <a:p>
-            <a:r>
-              <a:rPr lang="de-AT" dirty="0"/>
-              <a:t>and </a:t>
-            </a:r>
-            <a:r>
-              <a:rPr lang="de-AT" dirty="0" err="1"/>
-              <a:t>the</a:t>
-            </a:r>
-            <a:r>
-              <a:rPr lang="de-AT" dirty="0"/>
-              <a:t> </a:t>
-            </a:r>
-            <a:r>
-              <a:rPr lang="de-AT" dirty="0" err="1"/>
-              <a:t>likelihood</a:t>
-            </a:r>
-            <a:r>
-              <a:rPr lang="de-AT" dirty="0"/>
-              <a:t> </a:t>
-            </a:r>
-            <a:r>
-              <a:rPr lang="de-AT" dirty="0" err="1"/>
-              <a:t>that</a:t>
-            </a:r>
-            <a:r>
-              <a:rPr lang="de-AT" dirty="0"/>
-              <a:t> AI-</a:t>
-            </a:r>
-            <a:r>
-              <a:rPr lang="de-AT" dirty="0" err="1"/>
-              <a:t>generated</a:t>
-            </a:r>
-            <a:r>
-              <a:rPr lang="de-AT" dirty="0"/>
-              <a:t> </a:t>
-            </a:r>
-            <a:r>
-              <a:rPr lang="de-AT" dirty="0" err="1"/>
-              <a:t>content</a:t>
-            </a:r>
-            <a:r>
-              <a:rPr lang="de-AT" dirty="0"/>
-              <a:t> was </a:t>
-            </a:r>
-            <a:r>
-              <a:rPr lang="de-AT" dirty="0" err="1"/>
-              <a:t>present</a:t>
-            </a:r>
-            <a:r>
-              <a:rPr lang="de-AT" dirty="0"/>
-              <a:t>.</a:t>
-            </a:r>
-          </a:p>
-          <a:p>
             <a:endParaRPr lang="de-AT" dirty="0"/>
           </a:p>
         </p:txBody>
@@ -1982,458 +1134,7 @@
           <a:bodyPr/>
           <a:lstStyle/>
           <a:p>
-            <a:r>
-              <a:rPr lang="de-AT" dirty="0"/>
-              <a:t>The </a:t>
-            </a:r>
-            <a:r>
-              <a:rPr lang="de-AT" dirty="0" err="1"/>
-              <a:t>results</a:t>
-            </a:r>
-            <a:r>
-              <a:rPr lang="de-AT" dirty="0"/>
-              <a:t> </a:t>
-            </a:r>
-            <a:r>
-              <a:rPr lang="de-AT" dirty="0" err="1"/>
-              <a:t>were</a:t>
-            </a:r>
-            <a:r>
-              <a:rPr lang="de-AT" dirty="0"/>
-              <a:t> </a:t>
-            </a:r>
-            <a:r>
-              <a:rPr lang="de-AT" dirty="0" err="1"/>
-              <a:t>quite</a:t>
-            </a:r>
-            <a:r>
-              <a:rPr lang="de-AT" dirty="0"/>
-              <a:t> </a:t>
-            </a:r>
-            <a:r>
-              <a:rPr lang="de-AT" dirty="0" err="1"/>
-              <a:t>surprising</a:t>
-            </a:r>
-            <a:r>
-              <a:rPr lang="de-AT" dirty="0"/>
-              <a:t>.</a:t>
-            </a:r>
-          </a:p>
-          <a:p>
             <a:endParaRPr lang="de-AT" dirty="0"/>
-          </a:p>
-          <a:p>
-            <a:r>
-              <a:rPr lang="de-AT" dirty="0"/>
-              <a:t>The </a:t>
-            </a:r>
-            <a:r>
-              <a:rPr lang="de-AT" dirty="0" err="1"/>
-              <a:t>researchers</a:t>
-            </a:r>
-            <a:r>
-              <a:rPr lang="de-AT" dirty="0"/>
-              <a:t> </a:t>
-            </a:r>
-            <a:r>
-              <a:rPr lang="de-AT" dirty="0" err="1"/>
-              <a:t>found</a:t>
-            </a:r>
-            <a:r>
-              <a:rPr lang="de-AT" dirty="0"/>
-              <a:t> </a:t>
-            </a:r>
-            <a:r>
-              <a:rPr lang="de-AT" dirty="0" err="1"/>
-              <a:t>that</a:t>
-            </a:r>
-            <a:r>
-              <a:rPr lang="de-AT" dirty="0"/>
-              <a:t> </a:t>
-            </a:r>
-            <a:r>
-              <a:rPr lang="de-AT" dirty="0" err="1"/>
-              <a:t>the</a:t>
-            </a:r>
-            <a:r>
-              <a:rPr lang="de-AT" dirty="0"/>
-              <a:t> </a:t>
-            </a:r>
-            <a:r>
-              <a:rPr lang="de-AT" b="1" dirty="0"/>
-              <a:t>ChatGPT </a:t>
-            </a:r>
-            <a:r>
-              <a:rPr lang="de-AT" b="1" dirty="0" err="1"/>
-              <a:t>group</a:t>
-            </a:r>
-            <a:r>
-              <a:rPr lang="de-AT" b="1" dirty="0"/>
-              <a:t> </a:t>
-            </a:r>
-            <a:r>
-              <a:rPr lang="de-AT" b="1" dirty="0" err="1"/>
-              <a:t>did</a:t>
-            </a:r>
-            <a:r>
-              <a:rPr lang="de-AT" b="1" dirty="0"/>
-              <a:t> not perform </a:t>
-            </a:r>
-            <a:r>
-              <a:rPr lang="de-AT" b="1" dirty="0" err="1"/>
-              <a:t>better</a:t>
-            </a:r>
-            <a:r>
-              <a:rPr lang="de-AT" b="1" dirty="0"/>
-              <a:t> </a:t>
-            </a:r>
-            <a:r>
-              <a:rPr lang="de-AT" b="1" dirty="0" err="1"/>
-              <a:t>than</a:t>
-            </a:r>
-            <a:r>
-              <a:rPr lang="de-AT" b="1" dirty="0"/>
-              <a:t> </a:t>
-            </a:r>
-            <a:r>
-              <a:rPr lang="de-AT" b="1" dirty="0" err="1"/>
-              <a:t>the</a:t>
-            </a:r>
-            <a:r>
-              <a:rPr lang="de-AT" b="1" dirty="0"/>
-              <a:t> </a:t>
-            </a:r>
-            <a:r>
-              <a:rPr lang="de-AT" b="1" dirty="0" err="1"/>
-              <a:t>control</a:t>
-            </a:r>
-            <a:r>
-              <a:rPr lang="de-AT" b="1" dirty="0"/>
-              <a:t> </a:t>
-            </a:r>
-            <a:r>
-              <a:rPr lang="de-AT" b="1" dirty="0" err="1"/>
-              <a:t>group</a:t>
-            </a:r>
-            <a:r>
-              <a:rPr lang="de-AT" b="1" dirty="0"/>
-              <a:t>.</a:t>
-            </a:r>
-            <a:endParaRPr lang="de-AT" dirty="0"/>
-          </a:p>
-          <a:p>
-            <a:r>
-              <a:rPr lang="de-AT" dirty="0"/>
-              <a:t>Both </a:t>
-            </a:r>
-            <a:r>
-              <a:rPr lang="de-AT" dirty="0" err="1"/>
-              <a:t>groups</a:t>
-            </a:r>
-            <a:r>
-              <a:rPr lang="de-AT" dirty="0"/>
-              <a:t> </a:t>
-            </a:r>
-            <a:r>
-              <a:rPr lang="de-AT" dirty="0" err="1"/>
-              <a:t>achieved</a:t>
-            </a:r>
-            <a:r>
-              <a:rPr lang="de-AT" dirty="0"/>
-              <a:t> an </a:t>
-            </a:r>
-            <a:r>
-              <a:rPr lang="de-AT" dirty="0" err="1"/>
-              <a:t>average</a:t>
-            </a:r>
-            <a:r>
-              <a:rPr lang="de-AT" dirty="0"/>
-              <a:t> grade </a:t>
-            </a:r>
-            <a:r>
-              <a:rPr lang="de-AT" dirty="0" err="1"/>
-              <a:t>of</a:t>
-            </a:r>
-            <a:r>
-              <a:rPr lang="de-AT" dirty="0"/>
-              <a:t> </a:t>
-            </a:r>
-            <a:r>
-              <a:rPr lang="de-AT" b="1" dirty="0"/>
-              <a:t>C</a:t>
-            </a:r>
-            <a:r>
-              <a:rPr lang="de-AT" dirty="0"/>
-              <a:t>.</a:t>
-            </a:r>
-          </a:p>
-          <a:p>
-            <a:endParaRPr lang="de-AT" dirty="0"/>
-          </a:p>
-          <a:p>
-            <a:r>
-              <a:rPr lang="de-AT" dirty="0"/>
-              <a:t>In </a:t>
-            </a:r>
-            <a:r>
-              <a:rPr lang="de-AT" dirty="0" err="1"/>
-              <a:t>addition</a:t>
-            </a:r>
-            <a:r>
-              <a:rPr lang="de-AT" dirty="0"/>
-              <a:t>:</a:t>
-            </a:r>
-          </a:p>
-          <a:p>
-            <a:r>
-              <a:rPr lang="de-AT" dirty="0" err="1"/>
-              <a:t>students</a:t>
-            </a:r>
-            <a:r>
-              <a:rPr lang="de-AT" dirty="0"/>
-              <a:t> </a:t>
-            </a:r>
-            <a:r>
-              <a:rPr lang="de-AT" dirty="0" err="1"/>
-              <a:t>using</a:t>
-            </a:r>
-            <a:r>
-              <a:rPr lang="de-AT" dirty="0"/>
-              <a:t> ChatGPT </a:t>
-            </a:r>
-            <a:r>
-              <a:rPr lang="de-AT" dirty="0" err="1"/>
-              <a:t>did</a:t>
-            </a:r>
-            <a:r>
-              <a:rPr lang="de-AT" dirty="0"/>
-              <a:t> not finish </a:t>
-            </a:r>
-            <a:r>
-              <a:rPr lang="de-AT" dirty="0" err="1"/>
-              <a:t>their</a:t>
-            </a:r>
-            <a:r>
-              <a:rPr lang="de-AT" dirty="0"/>
-              <a:t> </a:t>
-            </a:r>
-            <a:r>
-              <a:rPr lang="de-AT" dirty="0" err="1"/>
-              <a:t>essays</a:t>
-            </a:r>
-            <a:r>
-              <a:rPr lang="de-AT" dirty="0"/>
-              <a:t> </a:t>
-            </a:r>
-            <a:r>
-              <a:rPr lang="de-AT" dirty="0" err="1"/>
-              <a:t>faster</a:t>
-            </a:r>
-            <a:r>
-              <a:rPr lang="de-AT" dirty="0"/>
-              <a:t>, </a:t>
-            </a:r>
-          </a:p>
-          <a:p>
-            <a:r>
-              <a:rPr lang="de-AT" dirty="0" err="1"/>
-              <a:t>they</a:t>
-            </a:r>
-            <a:r>
-              <a:rPr lang="de-AT" dirty="0"/>
-              <a:t> </a:t>
-            </a:r>
-            <a:r>
-              <a:rPr lang="de-AT" dirty="0" err="1"/>
-              <a:t>did</a:t>
-            </a:r>
-            <a:r>
-              <a:rPr lang="de-AT" dirty="0"/>
-              <a:t> not </a:t>
-            </a:r>
-            <a:r>
-              <a:rPr lang="de-AT" dirty="0" err="1"/>
-              <a:t>produce</a:t>
-            </a:r>
-            <a:r>
-              <a:rPr lang="de-AT" dirty="0"/>
-              <a:t> </a:t>
-            </a:r>
-            <a:r>
-              <a:rPr lang="de-AT" dirty="0" err="1"/>
-              <a:t>higher</a:t>
-            </a:r>
-            <a:r>
-              <a:rPr lang="de-AT" dirty="0"/>
-              <a:t>-quality </a:t>
-            </a:r>
-            <a:r>
-              <a:rPr lang="de-AT" dirty="0" err="1"/>
-              <a:t>essays</a:t>
-            </a:r>
-            <a:r>
-              <a:rPr lang="de-AT" dirty="0"/>
-              <a:t>, </a:t>
-            </a:r>
-          </a:p>
-          <a:p>
-            <a:r>
-              <a:rPr lang="de-AT" dirty="0"/>
-              <a:t>and </a:t>
-            </a:r>
-            <a:r>
-              <a:rPr lang="de-AT" dirty="0" err="1"/>
-              <a:t>their</a:t>
-            </a:r>
-            <a:r>
-              <a:rPr lang="de-AT" dirty="0"/>
-              <a:t> </a:t>
-            </a:r>
-            <a:r>
-              <a:rPr lang="de-AT" dirty="0" err="1"/>
-              <a:t>texts</a:t>
-            </a:r>
-            <a:r>
-              <a:rPr lang="de-AT" dirty="0"/>
-              <a:t> </a:t>
-            </a:r>
-            <a:r>
-              <a:rPr lang="de-AT" dirty="0" err="1"/>
-              <a:t>were</a:t>
-            </a:r>
-            <a:r>
-              <a:rPr lang="de-AT" dirty="0"/>
-              <a:t> </a:t>
-            </a:r>
-            <a:r>
-              <a:rPr lang="de-AT" dirty="0" err="1"/>
-              <a:t>slightly</a:t>
-            </a:r>
-            <a:r>
-              <a:rPr lang="de-AT" dirty="0"/>
-              <a:t> </a:t>
-            </a:r>
-            <a:r>
-              <a:rPr lang="de-AT" dirty="0" err="1"/>
-              <a:t>less</a:t>
-            </a:r>
-            <a:r>
-              <a:rPr lang="de-AT" dirty="0"/>
-              <a:t> </a:t>
-            </a:r>
-            <a:r>
-              <a:rPr lang="de-AT" dirty="0" err="1"/>
-              <a:t>authentic</a:t>
-            </a:r>
-            <a:r>
-              <a:rPr lang="de-AT" dirty="0"/>
-              <a:t>. </a:t>
-            </a:r>
-          </a:p>
-          <a:p>
-            <a:endParaRPr lang="de-AT" dirty="0"/>
-          </a:p>
-          <a:p>
-            <a:r>
-              <a:rPr lang="de-AT" dirty="0"/>
-              <a:t>The </a:t>
-            </a:r>
-            <a:r>
-              <a:rPr lang="de-AT" dirty="0" err="1"/>
-              <a:t>statistical</a:t>
-            </a:r>
-            <a:r>
-              <a:rPr lang="de-AT" dirty="0"/>
-              <a:t> </a:t>
-            </a:r>
-            <a:r>
-              <a:rPr lang="de-AT" dirty="0" err="1"/>
-              <a:t>analysis</a:t>
-            </a:r>
-            <a:r>
-              <a:rPr lang="de-AT" dirty="0"/>
-              <a:t> </a:t>
-            </a:r>
-            <a:r>
-              <a:rPr lang="de-AT" dirty="0" err="1"/>
-              <a:t>showed</a:t>
-            </a:r>
-            <a:r>
-              <a:rPr lang="de-AT" dirty="0"/>
-              <a:t> </a:t>
-            </a:r>
-            <a:r>
-              <a:rPr lang="de-AT" dirty="0" err="1"/>
-              <a:t>that</a:t>
-            </a:r>
-            <a:r>
-              <a:rPr lang="de-AT" dirty="0"/>
-              <a:t> </a:t>
-            </a:r>
-            <a:r>
-              <a:rPr lang="de-AT" dirty="0" err="1"/>
-              <a:t>none</a:t>
-            </a:r>
-            <a:r>
-              <a:rPr lang="de-AT" dirty="0"/>
-              <a:t> </a:t>
-            </a:r>
-            <a:r>
-              <a:rPr lang="de-AT" dirty="0" err="1"/>
-              <a:t>of</a:t>
-            </a:r>
-            <a:r>
-              <a:rPr lang="de-AT" dirty="0"/>
-              <a:t> </a:t>
-            </a:r>
-            <a:r>
-              <a:rPr lang="de-AT" dirty="0" err="1"/>
-              <a:t>the</a:t>
-            </a:r>
-            <a:r>
-              <a:rPr lang="de-AT" dirty="0"/>
-              <a:t> </a:t>
-            </a:r>
-            <a:r>
-              <a:rPr lang="de-AT" dirty="0" err="1"/>
-              <a:t>examined</a:t>
-            </a:r>
-            <a:r>
-              <a:rPr lang="de-AT" dirty="0"/>
-              <a:t> variables </a:t>
-            </a:r>
-            <a:r>
-              <a:rPr lang="de-AT" dirty="0" err="1"/>
-              <a:t>significantly</a:t>
-            </a:r>
-            <a:r>
-              <a:rPr lang="de-AT" dirty="0"/>
-              <a:t> </a:t>
-            </a:r>
-            <a:r>
-              <a:rPr lang="de-AT" dirty="0" err="1"/>
-              <a:t>improved</a:t>
-            </a:r>
-            <a:r>
-              <a:rPr lang="de-AT" dirty="0"/>
-              <a:t> </a:t>
-            </a:r>
-            <a:r>
-              <a:rPr lang="de-AT" dirty="0" err="1"/>
-              <a:t>essay</a:t>
-            </a:r>
-            <a:r>
-              <a:rPr lang="de-AT" dirty="0"/>
-              <a:t> </a:t>
-            </a:r>
-            <a:r>
-              <a:rPr lang="de-AT" dirty="0" err="1"/>
-              <a:t>performance</a:t>
-            </a:r>
-            <a:r>
-              <a:rPr lang="de-AT" dirty="0"/>
-              <a:t>. </a:t>
-            </a:r>
           </a:p>
         </p:txBody>
       </p:sp>
@@ -2517,272 +1218,6 @@
           <a:bodyPr/>
           <a:lstStyle/>
           <a:p>
-            <a:r>
-              <a:rPr lang="de-AT" dirty="0"/>
-              <a:t>The </a:t>
-            </a:r>
-            <a:r>
-              <a:rPr lang="de-AT" dirty="0" err="1"/>
-              <a:t>authors</a:t>
-            </a:r>
-            <a:r>
-              <a:rPr lang="de-AT" dirty="0"/>
-              <a:t> </a:t>
-            </a:r>
-            <a:r>
-              <a:rPr lang="de-AT" dirty="0" err="1"/>
-              <a:t>therefore</a:t>
-            </a:r>
-            <a:r>
-              <a:rPr lang="de-AT" dirty="0"/>
-              <a:t> </a:t>
-            </a:r>
-            <a:r>
-              <a:rPr lang="de-AT" dirty="0" err="1"/>
-              <a:t>concluded</a:t>
-            </a:r>
-            <a:r>
-              <a:rPr lang="de-AT" dirty="0"/>
-              <a:t> </a:t>
-            </a:r>
-            <a:r>
-              <a:rPr lang="de-AT" dirty="0" err="1"/>
-              <a:t>that</a:t>
-            </a:r>
-            <a:r>
-              <a:rPr lang="de-AT" dirty="0"/>
-              <a:t> ChatGPT </a:t>
-            </a:r>
-            <a:r>
-              <a:rPr lang="de-AT" dirty="0" err="1"/>
-              <a:t>should</a:t>
-            </a:r>
-            <a:r>
-              <a:rPr lang="de-AT" dirty="0"/>
-              <a:t> not </a:t>
-            </a:r>
-            <a:r>
-              <a:rPr lang="de-AT" dirty="0" err="1"/>
-              <a:t>automatically</a:t>
-            </a:r>
-            <a:r>
-              <a:rPr lang="de-AT" dirty="0"/>
-              <a:t> </a:t>
-            </a:r>
-            <a:r>
-              <a:rPr lang="de-AT" dirty="0" err="1"/>
-              <a:t>be</a:t>
-            </a:r>
-            <a:r>
-              <a:rPr lang="de-AT" dirty="0"/>
-              <a:t> </a:t>
-            </a:r>
-            <a:r>
-              <a:rPr lang="de-AT" dirty="0" err="1"/>
-              <a:t>viewed</a:t>
-            </a:r>
-            <a:r>
-              <a:rPr lang="de-AT" dirty="0"/>
-              <a:t> </a:t>
-            </a:r>
-            <a:r>
-              <a:rPr lang="de-AT" dirty="0" err="1"/>
-              <a:t>as</a:t>
-            </a:r>
-            <a:r>
-              <a:rPr lang="de-AT" dirty="0"/>
-              <a:t> an “</a:t>
-            </a:r>
-            <a:r>
-              <a:rPr lang="de-AT" dirty="0" err="1"/>
-              <a:t>essay</a:t>
-            </a:r>
-            <a:r>
-              <a:rPr lang="de-AT" dirty="0"/>
-              <a:t> </a:t>
-            </a:r>
-            <a:r>
-              <a:rPr lang="de-AT" dirty="0" err="1"/>
-              <a:t>enhancement</a:t>
-            </a:r>
-            <a:r>
-              <a:rPr lang="de-AT" dirty="0"/>
-              <a:t> </a:t>
-            </a:r>
-            <a:r>
-              <a:rPr lang="de-AT" dirty="0" err="1"/>
-              <a:t>tool</a:t>
-            </a:r>
-            <a:r>
-              <a:rPr lang="de-AT" dirty="0"/>
-              <a:t>.”</a:t>
-            </a:r>
-          </a:p>
-          <a:p>
-            <a:endParaRPr lang="de-AT" dirty="0"/>
-          </a:p>
-          <a:p>
-            <a:r>
-              <a:rPr lang="de-AT" dirty="0" err="1"/>
-              <a:t>Instead</a:t>
-            </a:r>
-            <a:r>
-              <a:rPr lang="de-AT" dirty="0"/>
-              <a:t>, </a:t>
-            </a:r>
-            <a:r>
-              <a:rPr lang="de-AT" dirty="0" err="1"/>
-              <a:t>its</a:t>
-            </a:r>
-            <a:r>
-              <a:rPr lang="de-AT" dirty="0"/>
-              <a:t> </a:t>
-            </a:r>
-            <a:r>
-              <a:rPr lang="de-AT" dirty="0" err="1"/>
-              <a:t>effectiveness</a:t>
-            </a:r>
-            <a:r>
-              <a:rPr lang="de-AT" dirty="0"/>
-              <a:t> </a:t>
-            </a:r>
-            <a:r>
-              <a:rPr lang="de-AT" dirty="0" err="1"/>
-              <a:t>appears</a:t>
-            </a:r>
-            <a:r>
-              <a:rPr lang="de-AT" dirty="0"/>
-              <a:t> </a:t>
-            </a:r>
-            <a:r>
-              <a:rPr lang="de-AT" dirty="0" err="1"/>
-              <a:t>to</a:t>
-            </a:r>
-            <a:r>
-              <a:rPr lang="de-AT" dirty="0"/>
-              <a:t> </a:t>
-            </a:r>
-            <a:r>
-              <a:rPr lang="de-AT" dirty="0" err="1"/>
-              <a:t>depend</a:t>
-            </a:r>
-            <a:r>
-              <a:rPr lang="de-AT" dirty="0"/>
-              <a:t> on </a:t>
-            </a:r>
-            <a:r>
-              <a:rPr lang="de-AT" dirty="0" err="1"/>
-              <a:t>several</a:t>
-            </a:r>
-            <a:r>
-              <a:rPr lang="de-AT" dirty="0"/>
-              <a:t> </a:t>
-            </a:r>
-            <a:r>
-              <a:rPr lang="de-AT" dirty="0" err="1"/>
-              <a:t>factors</a:t>
-            </a:r>
-            <a:r>
-              <a:rPr lang="de-AT" dirty="0"/>
-              <a:t>:</a:t>
-            </a:r>
-          </a:p>
-          <a:p>
-            <a:endParaRPr lang="de-AT" dirty="0"/>
-          </a:p>
-          <a:p>
-            <a:r>
-              <a:rPr lang="de-AT" dirty="0" err="1"/>
-              <a:t>prior</a:t>
-            </a:r>
-            <a:r>
-              <a:rPr lang="de-AT" dirty="0"/>
-              <a:t> </a:t>
-            </a:r>
-            <a:r>
-              <a:rPr lang="de-AT" dirty="0" err="1"/>
-              <a:t>knowledge</a:t>
-            </a:r>
-            <a:r>
-              <a:rPr lang="de-AT" dirty="0"/>
-              <a:t>, </a:t>
-            </a:r>
-          </a:p>
-          <a:p>
-            <a:r>
-              <a:rPr lang="de-AT" dirty="0" err="1"/>
-              <a:t>critical</a:t>
-            </a:r>
-            <a:r>
-              <a:rPr lang="de-AT" dirty="0"/>
-              <a:t> </a:t>
-            </a:r>
-            <a:r>
-              <a:rPr lang="de-AT" dirty="0" err="1"/>
-              <a:t>thinking</a:t>
-            </a:r>
-            <a:r>
-              <a:rPr lang="de-AT" dirty="0"/>
-              <a:t> </a:t>
-            </a:r>
-            <a:r>
-              <a:rPr lang="de-AT" dirty="0" err="1"/>
-              <a:t>skills</a:t>
-            </a:r>
-            <a:r>
-              <a:rPr lang="de-AT" dirty="0"/>
-              <a:t>, </a:t>
-            </a:r>
-          </a:p>
-          <a:p>
-            <a:r>
-              <a:rPr lang="de-AT" dirty="0" err="1"/>
-              <a:t>prompting</a:t>
-            </a:r>
-            <a:r>
-              <a:rPr lang="de-AT" dirty="0"/>
-              <a:t> </a:t>
-            </a:r>
-            <a:r>
-              <a:rPr lang="de-AT" dirty="0" err="1"/>
-              <a:t>ability</a:t>
-            </a:r>
-            <a:r>
-              <a:rPr lang="de-AT" dirty="0"/>
-              <a:t>, </a:t>
-            </a:r>
-          </a:p>
-          <a:p>
-            <a:r>
-              <a:rPr lang="de-AT" dirty="0"/>
-              <a:t>and </a:t>
-            </a:r>
-            <a:r>
-              <a:rPr lang="de-AT" dirty="0" err="1"/>
-              <a:t>overall</a:t>
-            </a:r>
-            <a:r>
-              <a:rPr lang="de-AT" dirty="0"/>
-              <a:t> </a:t>
-            </a:r>
-            <a:r>
-              <a:rPr lang="de-AT" dirty="0" err="1"/>
-              <a:t>writing</a:t>
-            </a:r>
-            <a:r>
-              <a:rPr lang="de-AT" dirty="0"/>
-              <a:t> </a:t>
-            </a:r>
-            <a:r>
-              <a:rPr lang="de-AT" dirty="0" err="1"/>
-              <a:t>competence</a:t>
-            </a:r>
-            <a:r>
-              <a:rPr lang="de-AT" dirty="0"/>
-              <a:t>. </a:t>
-            </a:r>
-          </a:p>
-          <a:p>
             <a:endParaRPr lang="de-AT" dirty="0"/>
           </a:p>
         </p:txBody>
@@ -2867,726 +1302,6 @@
           <a:bodyPr/>
           <a:lstStyle/>
           <a:p>
-            <a:r>
-              <a:rPr lang="de-AT" dirty="0"/>
-              <a:t>Like </a:t>
-            </a:r>
-            <a:r>
-              <a:rPr lang="de-AT" dirty="0" err="1"/>
-              <a:t>every</a:t>
-            </a:r>
-            <a:r>
-              <a:rPr lang="de-AT" dirty="0"/>
-              <a:t> </a:t>
-            </a:r>
-            <a:r>
-              <a:rPr lang="de-AT" dirty="0" err="1"/>
-              <a:t>study</a:t>
-            </a:r>
-            <a:r>
-              <a:rPr lang="de-AT" dirty="0"/>
-              <a:t>, </a:t>
-            </a:r>
-            <a:r>
-              <a:rPr lang="de-AT" dirty="0" err="1"/>
-              <a:t>this</a:t>
-            </a:r>
-            <a:r>
-              <a:rPr lang="de-AT" dirty="0"/>
-              <a:t> </a:t>
-            </a:r>
-            <a:r>
-              <a:rPr lang="de-AT" dirty="0" err="1"/>
-              <a:t>one</a:t>
-            </a:r>
-            <a:r>
-              <a:rPr lang="de-AT" dirty="0"/>
-              <a:t> </a:t>
-            </a:r>
-            <a:r>
-              <a:rPr lang="de-AT" dirty="0" err="1"/>
-              <a:t>has</a:t>
-            </a:r>
-            <a:r>
-              <a:rPr lang="de-AT" dirty="0"/>
-              <a:t> </a:t>
-            </a:r>
-            <a:r>
-              <a:rPr lang="de-AT" dirty="0" err="1"/>
-              <a:t>strengths</a:t>
-            </a:r>
-            <a:r>
-              <a:rPr lang="de-AT" dirty="0"/>
-              <a:t> and </a:t>
-            </a:r>
-            <a:r>
-              <a:rPr lang="de-AT" dirty="0" err="1"/>
-              <a:t>limitations</a:t>
-            </a:r>
-            <a:r>
-              <a:rPr lang="de-AT" dirty="0"/>
-              <a:t>.</a:t>
-            </a:r>
-          </a:p>
-          <a:p>
-            <a:endParaRPr lang="de-AT" dirty="0"/>
-          </a:p>
-          <a:p>
-            <a:r>
-              <a:rPr lang="de-AT" dirty="0"/>
-              <a:t>First, </a:t>
-            </a:r>
-            <a:r>
-              <a:rPr lang="de-AT" dirty="0" err="1"/>
-              <a:t>the</a:t>
-            </a:r>
-            <a:r>
-              <a:rPr lang="de-AT" dirty="0"/>
-              <a:t> </a:t>
-            </a:r>
-            <a:r>
-              <a:rPr lang="de-AT" dirty="0" err="1"/>
-              <a:t>strengths</a:t>
-            </a:r>
-            <a:r>
-              <a:rPr lang="de-AT" dirty="0"/>
-              <a:t>:</a:t>
-            </a:r>
-          </a:p>
-          <a:p>
-            <a:r>
-              <a:rPr lang="de-AT" dirty="0"/>
-              <a:t>The </a:t>
-            </a:r>
-            <a:r>
-              <a:rPr lang="de-AT" dirty="0" err="1"/>
-              <a:t>study</a:t>
-            </a:r>
-            <a:r>
-              <a:rPr lang="de-AT" dirty="0"/>
-              <a:t> </a:t>
-            </a:r>
-            <a:r>
-              <a:rPr lang="de-AT" dirty="0" err="1"/>
-              <a:t>used</a:t>
-            </a:r>
-            <a:r>
-              <a:rPr lang="de-AT" dirty="0"/>
-              <a:t> a real experimental design and </a:t>
-            </a:r>
-            <a:r>
-              <a:rPr lang="de-AT" dirty="0" err="1"/>
-              <a:t>examined</a:t>
-            </a:r>
-            <a:r>
-              <a:rPr lang="de-AT" dirty="0"/>
-              <a:t> </a:t>
-            </a:r>
-            <a:r>
-              <a:rPr lang="de-AT" dirty="0" err="1"/>
-              <a:t>students</a:t>
-            </a:r>
-            <a:r>
-              <a:rPr lang="de-AT" dirty="0"/>
-              <a:t> in an </a:t>
-            </a:r>
-            <a:r>
-              <a:rPr lang="de-AT" dirty="0" err="1"/>
-              <a:t>authentic</a:t>
-            </a:r>
-            <a:r>
-              <a:rPr lang="de-AT" dirty="0"/>
-              <a:t> </a:t>
-            </a:r>
-            <a:r>
-              <a:rPr lang="de-AT" dirty="0" err="1"/>
-              <a:t>educational</a:t>
-            </a:r>
-            <a:r>
-              <a:rPr lang="de-AT" dirty="0"/>
-              <a:t> </a:t>
-            </a:r>
-            <a:r>
-              <a:rPr lang="de-AT" dirty="0" err="1"/>
-              <a:t>environment</a:t>
-            </a:r>
-            <a:r>
-              <a:rPr lang="de-AT" dirty="0"/>
-              <a:t>. </a:t>
-            </a:r>
-          </a:p>
-          <a:p>
-            <a:r>
-              <a:rPr lang="de-AT" dirty="0"/>
-              <a:t>This </a:t>
-            </a:r>
-            <a:r>
-              <a:rPr lang="de-AT" dirty="0" err="1"/>
-              <a:t>makes</a:t>
-            </a:r>
-            <a:r>
-              <a:rPr lang="de-AT" dirty="0"/>
-              <a:t> </a:t>
-            </a:r>
-            <a:r>
-              <a:rPr lang="de-AT" dirty="0" err="1"/>
-              <a:t>the</a:t>
-            </a:r>
-            <a:r>
-              <a:rPr lang="de-AT" dirty="0"/>
-              <a:t> </a:t>
-            </a:r>
-            <a:r>
-              <a:rPr lang="de-AT" dirty="0" err="1"/>
-              <a:t>findings</a:t>
-            </a:r>
-            <a:r>
-              <a:rPr lang="de-AT" dirty="0"/>
-              <a:t> </a:t>
-            </a:r>
-            <a:r>
-              <a:rPr lang="de-AT" dirty="0" err="1"/>
-              <a:t>highly</a:t>
-            </a:r>
-            <a:r>
-              <a:rPr lang="de-AT" dirty="0"/>
-              <a:t> relevant </a:t>
-            </a:r>
-            <a:r>
-              <a:rPr lang="de-AT" dirty="0" err="1"/>
-              <a:t>for</a:t>
-            </a:r>
-            <a:r>
-              <a:rPr lang="de-AT" dirty="0"/>
-              <a:t> </a:t>
-            </a:r>
-            <a:r>
-              <a:rPr lang="de-AT" dirty="0" err="1"/>
-              <a:t>higher</a:t>
-            </a:r>
-            <a:r>
-              <a:rPr lang="de-AT" dirty="0"/>
-              <a:t> </a:t>
-            </a:r>
-            <a:r>
-              <a:rPr lang="de-AT" dirty="0" err="1"/>
-              <a:t>education</a:t>
-            </a:r>
-            <a:r>
-              <a:rPr lang="de-AT" dirty="0"/>
-              <a:t>.</a:t>
-            </a:r>
-          </a:p>
-          <a:p>
-            <a:endParaRPr lang="de-AT" dirty="0"/>
-          </a:p>
-          <a:p>
-            <a:endParaRPr lang="de-AT" dirty="0"/>
-          </a:p>
-          <a:p>
-            <a:r>
-              <a:rPr lang="de-AT" dirty="0" err="1"/>
-              <a:t>However</a:t>
-            </a:r>
-            <a:r>
-              <a:rPr lang="de-AT" dirty="0"/>
-              <a:t>, </a:t>
-            </a:r>
-            <a:r>
-              <a:rPr lang="de-AT" dirty="0" err="1"/>
-              <a:t>there</a:t>
-            </a:r>
-            <a:r>
-              <a:rPr lang="de-AT" dirty="0"/>
-              <a:t> </a:t>
-            </a:r>
-            <a:r>
-              <a:rPr lang="de-AT" dirty="0" err="1"/>
-              <a:t>are</a:t>
-            </a:r>
-            <a:r>
-              <a:rPr lang="de-AT" dirty="0"/>
-              <a:t> also </a:t>
-            </a:r>
-            <a:r>
-              <a:rPr lang="de-AT" dirty="0" err="1"/>
-              <a:t>important</a:t>
-            </a:r>
-            <a:r>
-              <a:rPr lang="de-AT" dirty="0"/>
-              <a:t> </a:t>
-            </a:r>
-            <a:r>
-              <a:rPr lang="de-AT" dirty="0" err="1"/>
-              <a:t>limitations</a:t>
-            </a:r>
-            <a:r>
-              <a:rPr lang="de-AT" dirty="0"/>
-              <a:t>.</a:t>
-            </a:r>
-          </a:p>
-          <a:p>
-            <a:r>
-              <a:rPr lang="de-AT" dirty="0"/>
-              <a:t>The sample </a:t>
-            </a:r>
-            <a:r>
-              <a:rPr lang="de-AT" dirty="0" err="1"/>
-              <a:t>size</a:t>
-            </a:r>
-            <a:r>
-              <a:rPr lang="de-AT" dirty="0"/>
-              <a:t> was </a:t>
-            </a:r>
-            <a:r>
-              <a:rPr lang="de-AT" dirty="0" err="1"/>
-              <a:t>very</a:t>
-            </a:r>
-            <a:r>
-              <a:rPr lang="de-AT" dirty="0"/>
-              <a:t> </a:t>
-            </a:r>
-            <a:r>
-              <a:rPr lang="de-AT" dirty="0" err="1"/>
-              <a:t>small</a:t>
-            </a:r>
-            <a:r>
-              <a:rPr lang="de-AT" dirty="0"/>
-              <a:t>, </a:t>
-            </a:r>
-            <a:r>
-              <a:rPr lang="de-AT" dirty="0" err="1"/>
-              <a:t>with</a:t>
-            </a:r>
-            <a:r>
-              <a:rPr lang="de-AT" dirty="0"/>
-              <a:t> </a:t>
-            </a:r>
-            <a:r>
-              <a:rPr lang="de-AT" dirty="0" err="1"/>
-              <a:t>only</a:t>
-            </a:r>
-            <a:r>
-              <a:rPr lang="de-AT" dirty="0"/>
-              <a:t> </a:t>
-            </a:r>
-            <a:r>
-              <a:rPr lang="de-AT" dirty="0" err="1"/>
-              <a:t>nine</a:t>
-            </a:r>
-            <a:r>
-              <a:rPr lang="de-AT" dirty="0"/>
-              <a:t> </a:t>
-            </a:r>
-            <a:r>
-              <a:rPr lang="de-AT" dirty="0" err="1"/>
-              <a:t>students</a:t>
-            </a:r>
-            <a:r>
-              <a:rPr lang="de-AT" dirty="0"/>
-              <a:t> per </a:t>
-            </a:r>
-            <a:r>
-              <a:rPr lang="de-AT" dirty="0" err="1"/>
-              <a:t>group</a:t>
-            </a:r>
-            <a:r>
-              <a:rPr lang="de-AT" dirty="0"/>
-              <a:t>.</a:t>
-            </a:r>
-          </a:p>
-          <a:p>
-            <a:r>
-              <a:rPr lang="de-AT" dirty="0" err="1"/>
-              <a:t>Furthermore</a:t>
-            </a:r>
-            <a:r>
-              <a:rPr lang="de-AT" dirty="0"/>
-              <a:t>, </a:t>
-            </a:r>
-            <a:r>
-              <a:rPr lang="de-AT" dirty="0" err="1"/>
-              <a:t>most</a:t>
-            </a:r>
-            <a:r>
-              <a:rPr lang="de-AT" dirty="0"/>
-              <a:t> </a:t>
-            </a:r>
-            <a:r>
-              <a:rPr lang="de-AT" dirty="0" err="1"/>
-              <a:t>participants</a:t>
-            </a:r>
-            <a:r>
-              <a:rPr lang="de-AT" dirty="0"/>
-              <a:t> </a:t>
-            </a:r>
-            <a:r>
-              <a:rPr lang="de-AT" dirty="0" err="1"/>
-              <a:t>had</a:t>
-            </a:r>
-            <a:r>
-              <a:rPr lang="de-AT" dirty="0"/>
-              <a:t> </a:t>
-            </a:r>
-            <a:r>
-              <a:rPr lang="de-AT" dirty="0" err="1"/>
-              <a:t>little</a:t>
-            </a:r>
-            <a:r>
-              <a:rPr lang="de-AT" dirty="0"/>
-              <a:t> </a:t>
-            </a:r>
-            <a:r>
-              <a:rPr lang="de-AT" dirty="0" err="1"/>
-              <a:t>or</a:t>
-            </a:r>
-            <a:r>
-              <a:rPr lang="de-AT" dirty="0"/>
-              <a:t> </a:t>
-            </a:r>
-            <a:r>
-              <a:rPr lang="de-AT" dirty="0" err="1"/>
-              <a:t>no</a:t>
-            </a:r>
-            <a:r>
-              <a:rPr lang="de-AT" dirty="0"/>
-              <a:t> </a:t>
-            </a:r>
-            <a:r>
-              <a:rPr lang="de-AT" dirty="0" err="1"/>
-              <a:t>experience</a:t>
-            </a:r>
-            <a:r>
-              <a:rPr lang="de-AT" dirty="0"/>
-              <a:t> </a:t>
-            </a:r>
-            <a:r>
-              <a:rPr lang="de-AT" dirty="0" err="1"/>
-              <a:t>using</a:t>
-            </a:r>
-            <a:r>
-              <a:rPr lang="de-AT" dirty="0"/>
-              <a:t> ChatGPT </a:t>
-            </a:r>
-            <a:r>
-              <a:rPr lang="de-AT" dirty="0" err="1"/>
-              <a:t>before</a:t>
-            </a:r>
-            <a:r>
-              <a:rPr lang="de-AT" dirty="0"/>
-              <a:t> </a:t>
-            </a:r>
-            <a:r>
-              <a:rPr lang="de-AT" dirty="0" err="1"/>
-              <a:t>the</a:t>
-            </a:r>
-            <a:r>
-              <a:rPr lang="de-AT" dirty="0"/>
-              <a:t> </a:t>
-            </a:r>
-            <a:r>
-              <a:rPr lang="de-AT" dirty="0" err="1"/>
-              <a:t>experiment</a:t>
-            </a:r>
-            <a:r>
-              <a:rPr lang="de-AT" dirty="0"/>
-              <a:t>.</a:t>
-            </a:r>
-          </a:p>
-          <a:p>
-            <a:r>
-              <a:rPr lang="de-AT" dirty="0"/>
-              <a:t>The </a:t>
-            </a:r>
-            <a:r>
-              <a:rPr lang="de-AT" dirty="0" err="1"/>
-              <a:t>essays</a:t>
-            </a:r>
-            <a:r>
-              <a:rPr lang="de-AT" dirty="0"/>
-              <a:t> </a:t>
-            </a:r>
-            <a:r>
-              <a:rPr lang="de-AT" dirty="0" err="1"/>
-              <a:t>were</a:t>
-            </a:r>
-            <a:r>
-              <a:rPr lang="de-AT" dirty="0"/>
-              <a:t> </a:t>
-            </a:r>
-            <a:r>
-              <a:rPr lang="de-AT" dirty="0" err="1"/>
-              <a:t>written</a:t>
-            </a:r>
-            <a:r>
-              <a:rPr lang="de-AT" dirty="0"/>
-              <a:t> in Croatian, </a:t>
-            </a:r>
-            <a:r>
-              <a:rPr lang="de-AT" dirty="0" err="1"/>
-              <a:t>which</a:t>
-            </a:r>
-            <a:r>
-              <a:rPr lang="de-AT" dirty="0"/>
-              <a:t> </a:t>
-            </a:r>
-            <a:r>
-              <a:rPr lang="de-AT" dirty="0" err="1"/>
-              <a:t>may</a:t>
-            </a:r>
-            <a:r>
-              <a:rPr lang="de-AT" dirty="0"/>
-              <a:t> </a:t>
-            </a:r>
-            <a:r>
-              <a:rPr lang="de-AT" dirty="0" err="1"/>
-              <a:t>have</a:t>
-            </a:r>
-            <a:r>
-              <a:rPr lang="de-AT" dirty="0"/>
-              <a:t> </a:t>
-            </a:r>
-            <a:r>
-              <a:rPr lang="de-AT" dirty="0" err="1"/>
-              <a:t>influenced</a:t>
-            </a:r>
-            <a:r>
-              <a:rPr lang="de-AT" dirty="0"/>
-              <a:t> </a:t>
-            </a:r>
-            <a:r>
-              <a:rPr lang="de-AT" dirty="0" err="1"/>
-              <a:t>ChatGPT’s</a:t>
-            </a:r>
-            <a:r>
-              <a:rPr lang="de-AT" dirty="0"/>
-              <a:t> </a:t>
-            </a:r>
-            <a:r>
-              <a:rPr lang="de-AT" dirty="0" err="1"/>
-              <a:t>performance</a:t>
-            </a:r>
-            <a:r>
-              <a:rPr lang="de-AT" dirty="0"/>
-              <a:t>.</a:t>
-            </a:r>
-          </a:p>
-          <a:p>
-            <a:r>
-              <a:rPr lang="de-AT" dirty="0" err="1"/>
-              <a:t>Finally</a:t>
-            </a:r>
-            <a:r>
-              <a:rPr lang="de-AT" dirty="0"/>
-              <a:t>, </a:t>
-            </a:r>
-            <a:r>
-              <a:rPr lang="de-AT" dirty="0" err="1"/>
-              <a:t>the</a:t>
-            </a:r>
-            <a:r>
-              <a:rPr lang="de-AT" dirty="0"/>
-              <a:t> </a:t>
-            </a:r>
-            <a:r>
-              <a:rPr lang="de-AT" dirty="0" err="1"/>
-              <a:t>study</a:t>
-            </a:r>
-            <a:r>
-              <a:rPr lang="de-AT" dirty="0"/>
-              <a:t> </a:t>
-            </a:r>
-            <a:r>
-              <a:rPr lang="de-AT" dirty="0" err="1"/>
-              <a:t>only</a:t>
-            </a:r>
-            <a:r>
-              <a:rPr lang="de-AT" dirty="0"/>
-              <a:t> </a:t>
-            </a:r>
-            <a:r>
-              <a:rPr lang="de-AT" dirty="0" err="1"/>
-              <a:t>examined</a:t>
-            </a:r>
-            <a:r>
-              <a:rPr lang="de-AT" dirty="0"/>
-              <a:t> a </a:t>
-            </a:r>
-            <a:r>
-              <a:rPr lang="de-AT" dirty="0" err="1"/>
-              <a:t>short</a:t>
-            </a:r>
-            <a:r>
-              <a:rPr lang="de-AT" dirty="0"/>
-              <a:t>-term </a:t>
-            </a:r>
-            <a:r>
-              <a:rPr lang="de-AT" dirty="0" err="1"/>
-              <a:t>intervention</a:t>
-            </a:r>
-            <a:r>
-              <a:rPr lang="de-AT" dirty="0"/>
-              <a:t> and </a:t>
-            </a:r>
-            <a:r>
-              <a:rPr lang="de-AT" dirty="0" err="1"/>
-              <a:t>therefore</a:t>
-            </a:r>
-            <a:r>
-              <a:rPr lang="de-AT" dirty="0"/>
-              <a:t> </a:t>
-            </a:r>
-            <a:r>
-              <a:rPr lang="de-AT" dirty="0" err="1"/>
-              <a:t>cannot</a:t>
-            </a:r>
-            <a:r>
-              <a:rPr lang="de-AT" dirty="0"/>
-              <a:t> </a:t>
-            </a:r>
-            <a:r>
-              <a:rPr lang="de-AT" dirty="0" err="1"/>
-              <a:t>tell</a:t>
-            </a:r>
-            <a:r>
-              <a:rPr lang="de-AT" dirty="0"/>
-              <a:t> </a:t>
-            </a:r>
-            <a:r>
-              <a:rPr lang="de-AT" dirty="0" err="1"/>
-              <a:t>us</a:t>
-            </a:r>
-            <a:r>
-              <a:rPr lang="de-AT" dirty="0"/>
-              <a:t> </a:t>
-            </a:r>
-            <a:r>
-              <a:rPr lang="de-AT" dirty="0" err="1"/>
-              <a:t>much</a:t>
-            </a:r>
-            <a:r>
-              <a:rPr lang="de-AT" dirty="0"/>
-              <a:t> </a:t>
-            </a:r>
-            <a:r>
-              <a:rPr lang="de-AT" dirty="0" err="1"/>
-              <a:t>about</a:t>
-            </a:r>
-            <a:r>
-              <a:rPr lang="de-AT" dirty="0"/>
-              <a:t> </a:t>
-            </a:r>
-            <a:r>
-              <a:rPr lang="de-AT" dirty="0" err="1"/>
-              <a:t>long</a:t>
-            </a:r>
-            <a:r>
-              <a:rPr lang="de-AT" dirty="0"/>
-              <a:t>-term </a:t>
-            </a:r>
-            <a:r>
-              <a:rPr lang="de-AT" dirty="0" err="1"/>
-              <a:t>learning</a:t>
-            </a:r>
-            <a:r>
-              <a:rPr lang="de-AT" dirty="0"/>
-              <a:t> </a:t>
-            </a:r>
-            <a:r>
-              <a:rPr lang="de-AT" dirty="0" err="1"/>
-              <a:t>effects</a:t>
-            </a:r>
-            <a:r>
-              <a:rPr lang="de-AT" dirty="0"/>
-              <a:t>.</a:t>
-            </a:r>
-          </a:p>
-          <a:p>
-            <a:endParaRPr lang="de-AT" dirty="0"/>
-          </a:p>
-          <a:p>
-            <a:r>
-              <a:rPr lang="de-AT" dirty="0" err="1"/>
-              <a:t>Because</a:t>
-            </a:r>
-            <a:r>
-              <a:rPr lang="de-AT" dirty="0"/>
-              <a:t> </a:t>
-            </a:r>
-            <a:r>
-              <a:rPr lang="de-AT" dirty="0" err="1"/>
-              <a:t>of</a:t>
-            </a:r>
-            <a:r>
-              <a:rPr lang="de-AT" dirty="0"/>
-              <a:t> </a:t>
-            </a:r>
-            <a:r>
-              <a:rPr lang="de-AT" dirty="0" err="1"/>
-              <a:t>these</a:t>
-            </a:r>
-            <a:r>
-              <a:rPr lang="de-AT" dirty="0"/>
-              <a:t> </a:t>
-            </a:r>
-            <a:r>
-              <a:rPr lang="de-AT" dirty="0" err="1"/>
-              <a:t>limitations</a:t>
-            </a:r>
-            <a:r>
-              <a:rPr lang="de-AT" dirty="0"/>
-              <a:t>, </a:t>
-            </a:r>
-            <a:r>
-              <a:rPr lang="de-AT" dirty="0" err="1"/>
-              <a:t>the</a:t>
-            </a:r>
-            <a:r>
-              <a:rPr lang="de-AT" dirty="0"/>
-              <a:t> </a:t>
-            </a:r>
-            <a:r>
-              <a:rPr lang="de-AT" dirty="0" err="1"/>
-              <a:t>results</a:t>
-            </a:r>
-            <a:r>
-              <a:rPr lang="de-AT" dirty="0"/>
-              <a:t> </a:t>
-            </a:r>
-            <a:r>
-              <a:rPr lang="de-AT" dirty="0" err="1"/>
-              <a:t>should</a:t>
-            </a:r>
-            <a:r>
-              <a:rPr lang="de-AT" dirty="0"/>
-              <a:t> </a:t>
-            </a:r>
-            <a:r>
-              <a:rPr lang="de-AT" dirty="0" err="1"/>
-              <a:t>be</a:t>
-            </a:r>
-            <a:r>
-              <a:rPr lang="de-AT" dirty="0"/>
-              <a:t> </a:t>
-            </a:r>
-            <a:r>
-              <a:rPr lang="de-AT" dirty="0" err="1"/>
-              <a:t>interpreted</a:t>
-            </a:r>
-            <a:r>
-              <a:rPr lang="de-AT" dirty="0"/>
-              <a:t> </a:t>
-            </a:r>
-            <a:r>
-              <a:rPr lang="de-AT" dirty="0" err="1"/>
-              <a:t>cautiously</a:t>
-            </a:r>
-            <a:r>
-              <a:rPr lang="de-AT" dirty="0"/>
-              <a:t>.</a:t>
-            </a:r>
-          </a:p>
-          <a:p>
             <a:endParaRPr lang="de-AT" dirty="0"/>
           </a:p>
         </p:txBody>
@@ -3671,708 +1386,6 @@
           <a:bodyPr/>
           <a:lstStyle/>
           <a:p>
-            <a:r>
-              <a:rPr lang="de-AT" dirty="0"/>
-              <a:t>I </a:t>
-            </a:r>
-            <a:r>
-              <a:rPr lang="de-AT" dirty="0" err="1"/>
-              <a:t>selected</a:t>
-            </a:r>
-            <a:r>
-              <a:rPr lang="de-AT" dirty="0"/>
-              <a:t> </a:t>
-            </a:r>
-            <a:r>
-              <a:rPr lang="de-AT" dirty="0" err="1"/>
-              <a:t>this</a:t>
-            </a:r>
-            <a:r>
-              <a:rPr lang="de-AT" dirty="0"/>
-              <a:t> </a:t>
-            </a:r>
-            <a:r>
-              <a:rPr lang="de-AT" dirty="0" err="1"/>
-              <a:t>study</a:t>
-            </a:r>
-            <a:r>
-              <a:rPr lang="de-AT" dirty="0"/>
-              <a:t> </a:t>
-            </a:r>
-            <a:r>
-              <a:rPr lang="de-AT" dirty="0" err="1"/>
-              <a:t>because</a:t>
-            </a:r>
-            <a:r>
-              <a:rPr lang="de-AT" dirty="0"/>
-              <a:t> </a:t>
-            </a:r>
-            <a:r>
-              <a:rPr lang="de-AT" dirty="0" err="1"/>
-              <a:t>it</a:t>
-            </a:r>
-            <a:r>
-              <a:rPr lang="de-AT" dirty="0"/>
-              <a:t> </a:t>
-            </a:r>
-            <a:r>
-              <a:rPr lang="de-AT" dirty="0" err="1"/>
-              <a:t>connects</a:t>
-            </a:r>
-            <a:r>
-              <a:rPr lang="de-AT" dirty="0"/>
-              <a:t> </a:t>
-            </a:r>
-            <a:r>
-              <a:rPr lang="de-AT" dirty="0" err="1"/>
-              <a:t>directly</a:t>
-            </a:r>
-            <a:r>
-              <a:rPr lang="de-AT" dirty="0"/>
-              <a:t> </a:t>
-            </a:r>
-            <a:r>
-              <a:rPr lang="de-AT" dirty="0" err="1"/>
-              <a:t>to</a:t>
-            </a:r>
-            <a:r>
-              <a:rPr lang="de-AT" dirty="0"/>
-              <a:t> </a:t>
-            </a:r>
-            <a:r>
-              <a:rPr lang="de-AT" dirty="0" err="1"/>
-              <a:t>my</a:t>
-            </a:r>
-            <a:r>
-              <a:rPr lang="de-AT" dirty="0"/>
-              <a:t> </a:t>
-            </a:r>
-            <a:r>
-              <a:rPr lang="de-AT" dirty="0" err="1"/>
-              <a:t>master’s</a:t>
-            </a:r>
-            <a:r>
-              <a:rPr lang="de-AT" dirty="0"/>
-              <a:t> </a:t>
-            </a:r>
-            <a:r>
-              <a:rPr lang="de-AT" dirty="0" err="1"/>
-              <a:t>thesis</a:t>
-            </a:r>
-            <a:r>
-              <a:rPr lang="de-AT" dirty="0"/>
-              <a:t>.</a:t>
-            </a:r>
-          </a:p>
-          <a:p>
-            <a:endParaRPr lang="de-AT" dirty="0"/>
-          </a:p>
-          <a:p>
-            <a:r>
-              <a:rPr lang="de-AT" dirty="0"/>
-              <a:t>Many </a:t>
-            </a:r>
-            <a:r>
-              <a:rPr lang="de-AT" dirty="0" err="1"/>
-              <a:t>discussions</a:t>
-            </a:r>
-            <a:r>
-              <a:rPr lang="de-AT" dirty="0"/>
-              <a:t> </a:t>
-            </a:r>
-            <a:r>
-              <a:rPr lang="de-AT" dirty="0" err="1"/>
-              <a:t>about</a:t>
-            </a:r>
-            <a:r>
-              <a:rPr lang="de-AT" dirty="0"/>
-              <a:t> ChatGPT </a:t>
-            </a:r>
-            <a:r>
-              <a:rPr lang="de-AT" dirty="0" err="1"/>
-              <a:t>focus</a:t>
-            </a:r>
-            <a:r>
-              <a:rPr lang="de-AT" dirty="0"/>
-              <a:t> </a:t>
-            </a:r>
-            <a:r>
-              <a:rPr lang="de-AT" dirty="0" err="1"/>
-              <a:t>mainly</a:t>
-            </a:r>
-            <a:r>
-              <a:rPr lang="de-AT" dirty="0"/>
-              <a:t> on </a:t>
-            </a:r>
-            <a:r>
-              <a:rPr lang="de-AT" dirty="0" err="1"/>
-              <a:t>its</a:t>
-            </a:r>
-            <a:r>
-              <a:rPr lang="de-AT" dirty="0"/>
-              <a:t> potential </a:t>
-            </a:r>
-            <a:r>
-              <a:rPr lang="de-AT" dirty="0" err="1"/>
-              <a:t>benefits</a:t>
-            </a:r>
-            <a:r>
-              <a:rPr lang="de-AT" dirty="0"/>
-              <a:t>.</a:t>
-            </a:r>
-          </a:p>
-          <a:p>
-            <a:r>
-              <a:rPr lang="de-AT" dirty="0" err="1"/>
-              <a:t>What</a:t>
-            </a:r>
-            <a:r>
-              <a:rPr lang="de-AT" dirty="0"/>
-              <a:t> I find </a:t>
-            </a:r>
-            <a:r>
-              <a:rPr lang="de-AT" dirty="0" err="1"/>
-              <a:t>particularly</a:t>
-            </a:r>
-            <a:r>
-              <a:rPr lang="de-AT" dirty="0"/>
-              <a:t> </a:t>
-            </a:r>
-            <a:r>
-              <a:rPr lang="de-AT" dirty="0" err="1"/>
-              <a:t>interesting</a:t>
-            </a:r>
-            <a:r>
-              <a:rPr lang="de-AT" dirty="0"/>
-              <a:t> </a:t>
-            </a:r>
-            <a:r>
-              <a:rPr lang="de-AT" dirty="0" err="1"/>
-              <a:t>is</a:t>
-            </a:r>
-            <a:r>
-              <a:rPr lang="de-AT" dirty="0"/>
-              <a:t> </a:t>
-            </a:r>
-            <a:r>
-              <a:rPr lang="de-AT" dirty="0" err="1"/>
-              <a:t>that</a:t>
-            </a:r>
-            <a:r>
-              <a:rPr lang="de-AT" dirty="0"/>
-              <a:t> </a:t>
-            </a:r>
-            <a:r>
-              <a:rPr lang="de-AT" dirty="0" err="1"/>
-              <a:t>this</a:t>
-            </a:r>
-            <a:r>
-              <a:rPr lang="de-AT" dirty="0"/>
-              <a:t> </a:t>
-            </a:r>
-            <a:r>
-              <a:rPr lang="de-AT" dirty="0" err="1"/>
-              <a:t>study</a:t>
-            </a:r>
-            <a:r>
-              <a:rPr lang="de-AT" dirty="0"/>
-              <a:t> also </a:t>
-            </a:r>
-            <a:r>
-              <a:rPr lang="de-AT" dirty="0" err="1"/>
-              <a:t>highlights</a:t>
-            </a:r>
-            <a:r>
-              <a:rPr lang="de-AT" dirty="0"/>
-              <a:t> </a:t>
-            </a:r>
-            <a:r>
-              <a:rPr lang="de-AT" dirty="0" err="1"/>
-              <a:t>its</a:t>
-            </a:r>
-            <a:r>
-              <a:rPr lang="de-AT" dirty="0"/>
-              <a:t> </a:t>
-            </a:r>
-            <a:r>
-              <a:rPr lang="de-AT" dirty="0" err="1"/>
-              <a:t>limitations</a:t>
-            </a:r>
-            <a:r>
-              <a:rPr lang="de-AT" dirty="0"/>
-              <a:t>.</a:t>
-            </a:r>
-          </a:p>
-          <a:p>
-            <a:r>
-              <a:rPr lang="de-AT" dirty="0"/>
-              <a:t>The </a:t>
-            </a:r>
-            <a:r>
-              <a:rPr lang="de-AT" dirty="0" err="1"/>
-              <a:t>findings</a:t>
-            </a:r>
-            <a:r>
-              <a:rPr lang="de-AT" dirty="0"/>
-              <a:t> </a:t>
-            </a:r>
-            <a:r>
-              <a:rPr lang="de-AT" dirty="0" err="1"/>
-              <a:t>suggest</a:t>
-            </a:r>
-            <a:r>
-              <a:rPr lang="de-AT" dirty="0"/>
-              <a:t> </a:t>
-            </a:r>
-            <a:r>
-              <a:rPr lang="de-AT" dirty="0" err="1"/>
-              <a:t>that</a:t>
-            </a:r>
-            <a:r>
-              <a:rPr lang="de-AT" dirty="0"/>
-              <a:t> </a:t>
-            </a:r>
-            <a:r>
-              <a:rPr lang="de-AT" dirty="0" err="1"/>
-              <a:t>simply</a:t>
-            </a:r>
-            <a:r>
-              <a:rPr lang="de-AT" dirty="0"/>
-              <a:t> </a:t>
-            </a:r>
-            <a:r>
-              <a:rPr lang="de-AT" dirty="0" err="1"/>
-              <a:t>having</a:t>
-            </a:r>
-            <a:r>
-              <a:rPr lang="de-AT" dirty="0"/>
-              <a:t> </a:t>
-            </a:r>
-            <a:r>
-              <a:rPr lang="de-AT" dirty="0" err="1"/>
-              <a:t>access</a:t>
-            </a:r>
-            <a:r>
-              <a:rPr lang="de-AT" dirty="0"/>
-              <a:t> </a:t>
-            </a:r>
-            <a:r>
-              <a:rPr lang="de-AT" dirty="0" err="1"/>
-              <a:t>to</a:t>
-            </a:r>
-            <a:r>
-              <a:rPr lang="de-AT" dirty="0"/>
-              <a:t> AI </a:t>
-            </a:r>
-            <a:r>
-              <a:rPr lang="de-AT" dirty="0" err="1"/>
-              <a:t>does</a:t>
-            </a:r>
-            <a:r>
-              <a:rPr lang="de-AT" dirty="0"/>
-              <a:t> not </a:t>
-            </a:r>
-            <a:r>
-              <a:rPr lang="de-AT" dirty="0" err="1"/>
-              <a:t>automatically</a:t>
-            </a:r>
-            <a:r>
-              <a:rPr lang="de-AT" dirty="0"/>
-              <a:t> </a:t>
-            </a:r>
-            <a:r>
-              <a:rPr lang="de-AT" dirty="0" err="1"/>
-              <a:t>improve</a:t>
-            </a:r>
-            <a:r>
-              <a:rPr lang="de-AT" dirty="0"/>
-              <a:t> </a:t>
-            </a:r>
-            <a:r>
-              <a:rPr lang="de-AT" dirty="0" err="1"/>
-              <a:t>performance</a:t>
-            </a:r>
-            <a:r>
-              <a:rPr lang="de-AT" dirty="0"/>
-              <a:t>.</a:t>
-            </a:r>
-          </a:p>
-          <a:p>
-            <a:endParaRPr lang="de-AT" dirty="0"/>
-          </a:p>
-          <a:p>
-            <a:r>
-              <a:rPr lang="de-AT" dirty="0" err="1"/>
-              <a:t>Instead</a:t>
-            </a:r>
-            <a:r>
-              <a:rPr lang="de-AT" dirty="0"/>
-              <a:t>, </a:t>
-            </a:r>
-            <a:r>
-              <a:rPr lang="de-AT" dirty="0" err="1"/>
-              <a:t>successful</a:t>
-            </a:r>
-            <a:r>
-              <a:rPr lang="de-AT" dirty="0"/>
-              <a:t> </a:t>
-            </a:r>
-            <a:r>
-              <a:rPr lang="de-AT" dirty="0" err="1"/>
-              <a:t>use</a:t>
-            </a:r>
-            <a:r>
-              <a:rPr lang="de-AT" dirty="0"/>
-              <a:t> </a:t>
-            </a:r>
-            <a:r>
-              <a:rPr lang="de-AT" dirty="0" err="1"/>
-              <a:t>depends</a:t>
-            </a:r>
-            <a:r>
-              <a:rPr lang="de-AT" dirty="0"/>
-              <a:t> on </a:t>
-            </a:r>
-            <a:r>
-              <a:rPr lang="de-AT" dirty="0" err="1"/>
-              <a:t>how</a:t>
-            </a:r>
-            <a:r>
-              <a:rPr lang="de-AT" dirty="0"/>
-              <a:t> </a:t>
-            </a:r>
-            <a:r>
-              <a:rPr lang="de-AT" dirty="0" err="1"/>
-              <a:t>well</a:t>
-            </a:r>
-            <a:r>
-              <a:rPr lang="de-AT" dirty="0"/>
-              <a:t> </a:t>
-            </a:r>
-            <a:r>
-              <a:rPr lang="de-AT" dirty="0" err="1"/>
-              <a:t>students</a:t>
-            </a:r>
-            <a:r>
-              <a:rPr lang="de-AT" dirty="0"/>
-              <a:t> </a:t>
-            </a:r>
-            <a:r>
-              <a:rPr lang="de-AT" dirty="0" err="1"/>
-              <a:t>understand</a:t>
-            </a:r>
-            <a:r>
-              <a:rPr lang="de-AT" dirty="0"/>
-              <a:t> </a:t>
-            </a:r>
-            <a:r>
-              <a:rPr lang="de-AT" dirty="0" err="1"/>
-              <a:t>the</a:t>
-            </a:r>
-            <a:r>
-              <a:rPr lang="de-AT" dirty="0"/>
-              <a:t> </a:t>
-            </a:r>
-            <a:r>
-              <a:rPr lang="de-AT" dirty="0" err="1"/>
-              <a:t>topic</a:t>
-            </a:r>
-            <a:r>
-              <a:rPr lang="de-AT" dirty="0"/>
-              <a:t>, </a:t>
-            </a:r>
-            <a:r>
-              <a:rPr lang="de-AT" dirty="0" err="1"/>
-              <a:t>formulate</a:t>
-            </a:r>
-            <a:r>
-              <a:rPr lang="de-AT" dirty="0"/>
-              <a:t> </a:t>
-            </a:r>
-            <a:r>
-              <a:rPr lang="de-AT" dirty="0" err="1"/>
-              <a:t>prompts</a:t>
-            </a:r>
-            <a:r>
-              <a:rPr lang="de-AT" dirty="0"/>
-              <a:t>, </a:t>
-            </a:r>
-            <a:r>
-              <a:rPr lang="de-AT" dirty="0" err="1"/>
-              <a:t>evaluate</a:t>
-            </a:r>
-            <a:r>
-              <a:rPr lang="de-AT" dirty="0"/>
-              <a:t> </a:t>
-            </a:r>
-            <a:r>
-              <a:rPr lang="de-AT" dirty="0" err="1"/>
-              <a:t>information</a:t>
-            </a:r>
-            <a:r>
-              <a:rPr lang="de-AT" dirty="0"/>
-              <a:t>, and </a:t>
-            </a:r>
-            <a:r>
-              <a:rPr lang="de-AT" dirty="0" err="1"/>
-              <a:t>integrate</a:t>
-            </a:r>
-            <a:r>
-              <a:rPr lang="de-AT" dirty="0"/>
-              <a:t> AI-</a:t>
-            </a:r>
-            <a:r>
-              <a:rPr lang="de-AT" dirty="0" err="1"/>
-              <a:t>generated</a:t>
-            </a:r>
-            <a:r>
-              <a:rPr lang="de-AT" dirty="0"/>
-              <a:t> </a:t>
-            </a:r>
-            <a:r>
-              <a:rPr lang="de-AT" dirty="0" err="1"/>
-              <a:t>content</a:t>
-            </a:r>
-            <a:r>
-              <a:rPr lang="de-AT" dirty="0"/>
-              <a:t> </a:t>
-            </a:r>
-            <a:r>
-              <a:rPr lang="de-AT" dirty="0" err="1"/>
-              <a:t>into</a:t>
-            </a:r>
-            <a:r>
-              <a:rPr lang="de-AT" dirty="0"/>
-              <a:t> </a:t>
-            </a:r>
-            <a:r>
-              <a:rPr lang="de-AT" dirty="0" err="1"/>
-              <a:t>their</a:t>
-            </a:r>
-            <a:r>
-              <a:rPr lang="de-AT" dirty="0"/>
-              <a:t> own </a:t>
-            </a:r>
-            <a:r>
-              <a:rPr lang="de-AT" dirty="0" err="1"/>
-              <a:t>work</a:t>
-            </a:r>
-            <a:r>
-              <a:rPr lang="de-AT" dirty="0"/>
-              <a:t>. </a:t>
-            </a:r>
-          </a:p>
-          <a:p>
-            <a:r>
-              <a:rPr lang="de-AT" dirty="0" err="1"/>
-              <a:t>For</a:t>
-            </a:r>
-            <a:r>
-              <a:rPr lang="de-AT" dirty="0"/>
-              <a:t> </a:t>
-            </a:r>
-            <a:r>
-              <a:rPr lang="de-AT" dirty="0" err="1"/>
-              <a:t>my</a:t>
-            </a:r>
-            <a:r>
-              <a:rPr lang="de-AT" dirty="0"/>
-              <a:t> </a:t>
-            </a:r>
-            <a:r>
-              <a:rPr lang="de-AT" dirty="0" err="1"/>
-              <a:t>research</a:t>
-            </a:r>
-            <a:r>
-              <a:rPr lang="de-AT" dirty="0"/>
-              <a:t>, </a:t>
-            </a:r>
-            <a:r>
-              <a:rPr lang="de-AT" dirty="0" err="1"/>
-              <a:t>this</a:t>
-            </a:r>
-            <a:r>
-              <a:rPr lang="de-AT" dirty="0"/>
-              <a:t> </a:t>
-            </a:r>
-            <a:r>
-              <a:rPr lang="de-AT" dirty="0" err="1"/>
-              <a:t>is</a:t>
-            </a:r>
-            <a:r>
-              <a:rPr lang="de-AT" dirty="0"/>
-              <a:t> </a:t>
-            </a:r>
-            <a:r>
-              <a:rPr lang="de-AT" dirty="0" err="1"/>
-              <a:t>highly</a:t>
-            </a:r>
-            <a:r>
-              <a:rPr lang="de-AT" dirty="0"/>
-              <a:t> relevant </a:t>
-            </a:r>
-            <a:r>
-              <a:rPr lang="de-AT" dirty="0" err="1"/>
-              <a:t>because</a:t>
-            </a:r>
-            <a:r>
-              <a:rPr lang="de-AT" dirty="0"/>
-              <a:t> </a:t>
-            </a:r>
-            <a:r>
-              <a:rPr lang="de-AT" dirty="0" err="1"/>
-              <a:t>it</a:t>
-            </a:r>
-            <a:r>
-              <a:rPr lang="de-AT" dirty="0"/>
-              <a:t> </a:t>
-            </a:r>
-            <a:r>
-              <a:rPr lang="de-AT" dirty="0" err="1"/>
-              <a:t>shows</a:t>
-            </a:r>
-            <a:r>
-              <a:rPr lang="de-AT" dirty="0"/>
-              <a:t> </a:t>
-            </a:r>
-            <a:r>
-              <a:rPr lang="de-AT" dirty="0" err="1"/>
-              <a:t>that</a:t>
-            </a:r>
-            <a:r>
-              <a:rPr lang="de-AT" dirty="0"/>
-              <a:t> AI </a:t>
-            </a:r>
-            <a:r>
-              <a:rPr lang="de-AT" dirty="0" err="1"/>
-              <a:t>should</a:t>
-            </a:r>
-            <a:r>
-              <a:rPr lang="de-AT" dirty="0"/>
-              <a:t> not </a:t>
-            </a:r>
-            <a:r>
-              <a:rPr lang="de-AT" dirty="0" err="1"/>
-              <a:t>be</a:t>
-            </a:r>
-            <a:r>
-              <a:rPr lang="de-AT" dirty="0"/>
-              <a:t> </a:t>
-            </a:r>
-            <a:r>
-              <a:rPr lang="de-AT" dirty="0" err="1"/>
-              <a:t>seen</a:t>
-            </a:r>
-            <a:r>
-              <a:rPr lang="de-AT" dirty="0"/>
-              <a:t> </a:t>
-            </a:r>
-            <a:r>
-              <a:rPr lang="de-AT" dirty="0" err="1"/>
-              <a:t>as</a:t>
-            </a:r>
-            <a:r>
-              <a:rPr lang="de-AT" dirty="0"/>
-              <a:t> a </a:t>
-            </a:r>
-            <a:r>
-              <a:rPr lang="de-AT" dirty="0" err="1"/>
-              <a:t>replacement</a:t>
-            </a:r>
-            <a:r>
-              <a:rPr lang="de-AT" dirty="0"/>
-              <a:t> </a:t>
-            </a:r>
-            <a:r>
-              <a:rPr lang="de-AT" dirty="0" err="1"/>
-              <a:t>for</a:t>
-            </a:r>
-            <a:r>
-              <a:rPr lang="de-AT" dirty="0"/>
-              <a:t> </a:t>
-            </a:r>
-            <a:r>
-              <a:rPr lang="de-AT" dirty="0" err="1"/>
-              <a:t>writing</a:t>
-            </a:r>
-            <a:r>
-              <a:rPr lang="de-AT" dirty="0"/>
-              <a:t> </a:t>
-            </a:r>
-            <a:r>
-              <a:rPr lang="de-AT" dirty="0" err="1"/>
-              <a:t>skills</a:t>
-            </a:r>
-            <a:r>
-              <a:rPr lang="de-AT" dirty="0"/>
-              <a:t>, but </a:t>
-            </a:r>
-            <a:r>
-              <a:rPr lang="de-AT" dirty="0" err="1"/>
-              <a:t>rather</a:t>
-            </a:r>
-            <a:r>
-              <a:rPr lang="de-AT" dirty="0"/>
-              <a:t> </a:t>
-            </a:r>
-            <a:r>
-              <a:rPr lang="de-AT" dirty="0" err="1"/>
-              <a:t>as</a:t>
-            </a:r>
-            <a:r>
-              <a:rPr lang="de-AT" dirty="0"/>
-              <a:t> a </a:t>
-            </a:r>
-            <a:r>
-              <a:rPr lang="de-AT" dirty="0" err="1"/>
-              <a:t>tool</a:t>
-            </a:r>
-            <a:r>
-              <a:rPr lang="de-AT" dirty="0"/>
-              <a:t> </a:t>
-            </a:r>
-            <a:r>
-              <a:rPr lang="de-AT" dirty="0" err="1"/>
-              <a:t>whose</a:t>
-            </a:r>
-            <a:r>
-              <a:rPr lang="de-AT" dirty="0"/>
-              <a:t> </a:t>
-            </a:r>
-            <a:r>
-              <a:rPr lang="de-AT" dirty="0" err="1"/>
-              <a:t>effectiveness</a:t>
-            </a:r>
-            <a:r>
-              <a:rPr lang="de-AT" dirty="0"/>
-              <a:t> </a:t>
-            </a:r>
-            <a:r>
-              <a:rPr lang="de-AT" dirty="0" err="1"/>
-              <a:t>depends</a:t>
-            </a:r>
-            <a:r>
-              <a:rPr lang="de-AT" dirty="0"/>
-              <a:t> on </a:t>
-            </a:r>
-            <a:r>
-              <a:rPr lang="de-AT" dirty="0" err="1"/>
-              <a:t>the</a:t>
-            </a:r>
-            <a:r>
-              <a:rPr lang="de-AT" dirty="0"/>
-              <a:t> </a:t>
-            </a:r>
-            <a:r>
-              <a:rPr lang="de-AT" dirty="0" err="1"/>
-              <a:t>user</a:t>
-            </a:r>
-            <a:r>
-              <a:rPr lang="de-AT" dirty="0"/>
-              <a:t>.</a:t>
-            </a:r>
-          </a:p>
-          <a:p>
             <a:endParaRPr lang="de-AT" dirty="0"/>
           </a:p>
         </p:txBody>
@@ -4457,306 +1470,7 @@
           <a:bodyPr/>
           <a:lstStyle/>
           <a:p>
-            <a:r>
-              <a:rPr lang="de-AT" dirty="0" err="1"/>
-              <a:t>To</a:t>
-            </a:r>
-            <a:r>
-              <a:rPr lang="de-AT" dirty="0"/>
-              <a:t> </a:t>
-            </a:r>
-            <a:r>
-              <a:rPr lang="de-AT" dirty="0" err="1"/>
-              <a:t>conclude</a:t>
-            </a:r>
-            <a:r>
-              <a:rPr lang="de-AT" dirty="0"/>
-              <a:t>:</a:t>
-            </a:r>
-          </a:p>
-          <a:p>
             <a:endParaRPr lang="de-AT" dirty="0"/>
-          </a:p>
-          <a:p>
-            <a:r>
-              <a:rPr lang="de-AT" dirty="0"/>
-              <a:t>This </a:t>
-            </a:r>
-            <a:r>
-              <a:rPr lang="de-AT" dirty="0" err="1"/>
-              <a:t>study</a:t>
-            </a:r>
-            <a:r>
-              <a:rPr lang="de-AT" dirty="0"/>
-              <a:t> </a:t>
-            </a:r>
-            <a:r>
-              <a:rPr lang="de-AT" dirty="0" err="1"/>
-              <a:t>found</a:t>
-            </a:r>
-            <a:r>
-              <a:rPr lang="de-AT" dirty="0"/>
-              <a:t> </a:t>
-            </a:r>
-            <a:r>
-              <a:rPr lang="de-AT" dirty="0" err="1"/>
-              <a:t>that</a:t>
-            </a:r>
-            <a:r>
-              <a:rPr lang="de-AT" dirty="0"/>
-              <a:t> ChatGPT </a:t>
-            </a:r>
-            <a:r>
-              <a:rPr lang="de-AT" dirty="0" err="1"/>
-              <a:t>did</a:t>
-            </a:r>
-            <a:r>
-              <a:rPr lang="de-AT" dirty="0"/>
-              <a:t> not </a:t>
-            </a:r>
-            <a:r>
-              <a:rPr lang="de-AT" dirty="0" err="1"/>
-              <a:t>significantly</a:t>
-            </a:r>
-            <a:r>
-              <a:rPr lang="de-AT" dirty="0"/>
-              <a:t> </a:t>
-            </a:r>
-            <a:r>
-              <a:rPr lang="de-AT" dirty="0" err="1"/>
-              <a:t>improve</a:t>
-            </a:r>
-            <a:r>
-              <a:rPr lang="de-AT" dirty="0"/>
-              <a:t> </a:t>
-            </a:r>
-            <a:r>
-              <a:rPr lang="de-AT" dirty="0" err="1"/>
-              <a:t>essay</a:t>
-            </a:r>
-            <a:r>
-              <a:rPr lang="de-AT" dirty="0"/>
-              <a:t> </a:t>
-            </a:r>
-            <a:r>
-              <a:rPr lang="de-AT" dirty="0" err="1"/>
-              <a:t>quality</a:t>
-            </a:r>
-            <a:r>
-              <a:rPr lang="de-AT" dirty="0"/>
-              <a:t>, </a:t>
-            </a:r>
-            <a:r>
-              <a:rPr lang="de-AT" dirty="0" err="1"/>
-              <a:t>speed</a:t>
-            </a:r>
-            <a:r>
-              <a:rPr lang="de-AT" dirty="0"/>
-              <a:t>, </a:t>
-            </a:r>
-            <a:r>
-              <a:rPr lang="de-AT" dirty="0" err="1"/>
-              <a:t>or</a:t>
-            </a:r>
-            <a:r>
-              <a:rPr lang="de-AT" dirty="0"/>
-              <a:t> </a:t>
-            </a:r>
-            <a:r>
-              <a:rPr lang="de-AT" dirty="0" err="1"/>
-              <a:t>authenticity</a:t>
-            </a:r>
-            <a:r>
-              <a:rPr lang="de-AT" dirty="0"/>
-              <a:t> in </a:t>
-            </a:r>
-            <a:r>
-              <a:rPr lang="de-AT" dirty="0" err="1"/>
-              <a:t>this</a:t>
-            </a:r>
-            <a:r>
-              <a:rPr lang="de-AT" dirty="0"/>
-              <a:t> </a:t>
-            </a:r>
-            <a:r>
-              <a:rPr lang="de-AT" dirty="0" err="1"/>
-              <a:t>student</a:t>
-            </a:r>
-            <a:r>
-              <a:rPr lang="de-AT" dirty="0"/>
-              <a:t> sample.</a:t>
-            </a:r>
-          </a:p>
-          <a:p>
-            <a:r>
-              <a:rPr lang="de-AT" dirty="0"/>
-              <a:t>The </a:t>
-            </a:r>
-            <a:r>
-              <a:rPr lang="de-AT" dirty="0" err="1"/>
-              <a:t>results</a:t>
-            </a:r>
-            <a:r>
-              <a:rPr lang="de-AT" dirty="0"/>
-              <a:t> </a:t>
-            </a:r>
-            <a:r>
-              <a:rPr lang="de-AT" dirty="0" err="1"/>
-              <a:t>suggest</a:t>
-            </a:r>
-            <a:r>
-              <a:rPr lang="de-AT" dirty="0"/>
-              <a:t> </a:t>
-            </a:r>
-            <a:r>
-              <a:rPr lang="de-AT" dirty="0" err="1"/>
-              <a:t>that</a:t>
-            </a:r>
-            <a:r>
-              <a:rPr lang="de-AT" dirty="0"/>
-              <a:t> AI </a:t>
-            </a:r>
-            <a:r>
-              <a:rPr lang="de-AT" dirty="0" err="1"/>
-              <a:t>can</a:t>
-            </a:r>
-            <a:r>
-              <a:rPr lang="de-AT" dirty="0"/>
-              <a:t> support </a:t>
-            </a:r>
-            <a:r>
-              <a:rPr lang="de-AT" dirty="0" err="1"/>
-              <a:t>writing</a:t>
-            </a:r>
-            <a:r>
-              <a:rPr lang="de-AT" dirty="0"/>
-              <a:t>, but </a:t>
-            </a:r>
-            <a:r>
-              <a:rPr lang="de-AT" dirty="0" err="1"/>
-              <a:t>only</a:t>
-            </a:r>
-            <a:r>
-              <a:rPr lang="de-AT" dirty="0"/>
-              <a:t> </a:t>
-            </a:r>
-            <a:r>
-              <a:rPr lang="de-AT" dirty="0" err="1"/>
-              <a:t>when</a:t>
-            </a:r>
-            <a:r>
-              <a:rPr lang="de-AT" dirty="0"/>
-              <a:t> </a:t>
-            </a:r>
-            <a:r>
-              <a:rPr lang="de-AT" dirty="0" err="1"/>
-              <a:t>users</a:t>
-            </a:r>
-            <a:r>
-              <a:rPr lang="de-AT" dirty="0"/>
-              <a:t> </a:t>
-            </a:r>
-            <a:r>
-              <a:rPr lang="de-AT" dirty="0" err="1"/>
-              <a:t>have</a:t>
-            </a:r>
-            <a:r>
-              <a:rPr lang="de-AT" dirty="0"/>
-              <a:t> </a:t>
-            </a:r>
-            <a:r>
-              <a:rPr lang="de-AT" dirty="0" err="1"/>
-              <a:t>the</a:t>
-            </a:r>
-            <a:r>
-              <a:rPr lang="de-AT" dirty="0"/>
-              <a:t> </a:t>
-            </a:r>
-            <a:r>
-              <a:rPr lang="de-AT" dirty="0" err="1"/>
-              <a:t>necessary</a:t>
-            </a:r>
-            <a:r>
-              <a:rPr lang="de-AT" dirty="0"/>
-              <a:t> </a:t>
-            </a:r>
-            <a:r>
-              <a:rPr lang="de-AT" dirty="0" err="1"/>
-              <a:t>skills</a:t>
-            </a:r>
-            <a:r>
-              <a:rPr lang="de-AT" dirty="0"/>
-              <a:t> </a:t>
-            </a:r>
-            <a:r>
-              <a:rPr lang="de-AT" dirty="0" err="1"/>
-              <a:t>to</a:t>
-            </a:r>
-            <a:r>
-              <a:rPr lang="de-AT" dirty="0"/>
-              <a:t> </a:t>
-            </a:r>
-            <a:r>
-              <a:rPr lang="de-AT" dirty="0" err="1"/>
-              <a:t>use</a:t>
-            </a:r>
-            <a:r>
-              <a:rPr lang="de-AT" dirty="0"/>
-              <a:t> </a:t>
-            </a:r>
-            <a:r>
-              <a:rPr lang="de-AT" dirty="0" err="1"/>
-              <a:t>it</a:t>
-            </a:r>
-            <a:r>
-              <a:rPr lang="de-AT" dirty="0"/>
-              <a:t> </a:t>
-            </a:r>
-            <a:r>
-              <a:rPr lang="de-AT" dirty="0" err="1"/>
-              <a:t>effectively</a:t>
-            </a:r>
-            <a:r>
-              <a:rPr lang="de-AT"/>
-              <a:t>.</a:t>
-            </a:r>
-          </a:p>
-          <a:p>
-            <a:endParaRPr lang="de-AT" dirty="0"/>
-          </a:p>
-          <a:p>
-            <a:r>
-              <a:rPr lang="de-AT" dirty="0" err="1"/>
-              <a:t>Thank</a:t>
-            </a:r>
-            <a:r>
-              <a:rPr lang="de-AT" dirty="0"/>
-              <a:t> </a:t>
-            </a:r>
-            <a:r>
-              <a:rPr lang="de-AT" dirty="0" err="1"/>
-              <a:t>you</a:t>
-            </a:r>
-            <a:r>
-              <a:rPr lang="de-AT" dirty="0"/>
-              <a:t> </a:t>
-            </a:r>
-            <a:r>
-              <a:rPr lang="de-AT" dirty="0" err="1"/>
-              <a:t>for</a:t>
-            </a:r>
-            <a:r>
-              <a:rPr lang="de-AT" dirty="0"/>
-              <a:t> </a:t>
-            </a:r>
-            <a:r>
-              <a:rPr lang="de-AT" dirty="0" err="1"/>
-              <a:t>listening</a:t>
-            </a:r>
-            <a:r>
-              <a:rPr lang="de-AT" dirty="0"/>
-              <a:t>.</a:t>
-            </a:r>
           </a:p>
         </p:txBody>
       </p:sp>
@@ -4976,7 +1690,7 @@
             <a:fld id="{1D8BD707-D9CF-40AE-B4C6-C98DA3205C09}" type="datetimeFigureOut">
               <a:rPr lang="en-US" smtClean="0"/>
               <a:pPr/>
-              <a:t>6/16/2026</a:t>
+              <a:t>6/23/2026</a:t>
             </a:fld>
             <a:endParaRPr lang="en-US"/>
           </a:p>
@@ -5141,7 +1855,7 @@
             <a:fld id="{1D8BD707-D9CF-40AE-B4C6-C98DA3205C09}" type="datetimeFigureOut">
               <a:rPr lang="en-US" smtClean="0"/>
               <a:pPr/>
-              <a:t>6/16/2026</a:t>
+              <a:t>6/23/2026</a:t>
             </a:fld>
             <a:endParaRPr lang="en-US"/>
           </a:p>
@@ -5316,7 +2030,7 @@
             <a:fld id="{1D8BD707-D9CF-40AE-B4C6-C98DA3205C09}" type="datetimeFigureOut">
               <a:rPr lang="en-US" smtClean="0"/>
               <a:pPr/>
-              <a:t>6/16/2026</a:t>
+              <a:t>6/23/2026</a:t>
             </a:fld>
             <a:endParaRPr lang="en-US"/>
           </a:p>
@@ -5481,7 +2195,7 @@
             <a:fld id="{1D8BD707-D9CF-40AE-B4C6-C98DA3205C09}" type="datetimeFigureOut">
               <a:rPr lang="en-US" smtClean="0"/>
               <a:pPr/>
-              <a:t>6/16/2026</a:t>
+              <a:t>6/23/2026</a:t>
             </a:fld>
             <a:endParaRPr lang="en-US"/>
           </a:p>
@@ -5723,7 +2437,7 @@
             <a:fld id="{1D8BD707-D9CF-40AE-B4C6-C98DA3205C09}" type="datetimeFigureOut">
               <a:rPr lang="en-US" smtClean="0"/>
               <a:pPr/>
-              <a:t>6/16/2026</a:t>
+              <a:t>6/23/2026</a:t>
             </a:fld>
             <a:endParaRPr lang="en-US"/>
           </a:p>
@@ -6005,7 +2719,7 @@
             <a:fld id="{1D8BD707-D9CF-40AE-B4C6-C98DA3205C09}" type="datetimeFigureOut">
               <a:rPr lang="en-US" smtClean="0"/>
               <a:pPr/>
-              <a:t>6/16/2026</a:t>
+              <a:t>6/23/2026</a:t>
             </a:fld>
             <a:endParaRPr lang="en-US"/>
           </a:p>
@@ -6421,7 +3135,7 @@
             <a:fld id="{1D8BD707-D9CF-40AE-B4C6-C98DA3205C09}" type="datetimeFigureOut">
               <a:rPr lang="en-US" smtClean="0"/>
               <a:pPr/>
-              <a:t>6/16/2026</a:t>
+              <a:t>6/23/2026</a:t>
             </a:fld>
             <a:endParaRPr lang="en-US"/>
           </a:p>
@@ -6535,7 +3249,7 @@
             <a:fld id="{1D8BD707-D9CF-40AE-B4C6-C98DA3205C09}" type="datetimeFigureOut">
               <a:rPr lang="en-US" smtClean="0"/>
               <a:pPr/>
-              <a:t>6/16/2026</a:t>
+              <a:t>6/23/2026</a:t>
             </a:fld>
             <a:endParaRPr lang="en-US"/>
           </a:p>
@@ -6627,7 +3341,7 @@
             <a:fld id="{1D8BD707-D9CF-40AE-B4C6-C98DA3205C09}" type="datetimeFigureOut">
               <a:rPr lang="en-US" smtClean="0"/>
               <a:pPr/>
-              <a:t>6/16/2026</a:t>
+              <a:t>6/23/2026</a:t>
             </a:fld>
             <a:endParaRPr lang="en-US"/>
           </a:p>
@@ -6899,7 +3613,7 @@
             <a:fld id="{1D8BD707-D9CF-40AE-B4C6-C98DA3205C09}" type="datetimeFigureOut">
               <a:rPr lang="en-US" smtClean="0"/>
               <a:pPr/>
-              <a:t>6/16/2026</a:t>
+              <a:t>6/23/2026</a:t>
             </a:fld>
             <a:endParaRPr lang="en-US"/>
           </a:p>
@@ -7148,7 +3862,7 @@
             <a:fld id="{1D8BD707-D9CF-40AE-B4C6-C98DA3205C09}" type="datetimeFigureOut">
               <a:rPr lang="en-US" smtClean="0"/>
               <a:pPr/>
-              <a:t>6/16/2026</a:t>
+              <a:t>6/23/2026</a:t>
             </a:fld>
             <a:endParaRPr lang="en-US"/>
           </a:p>
@@ -7356,7 +4070,7 @@
             <a:fld id="{1D8BD707-D9CF-40AE-B4C6-C98DA3205C09}" type="datetimeFigureOut">
               <a:rPr lang="en-US" smtClean="0"/>
               <a:pPr/>
-              <a:t>6/16/2026</a:t>
+              <a:t>6/23/2026</a:t>
             </a:fld>
             <a:endParaRPr lang="en-US"/>
           </a:p>

</xml_diff>